<commit_message>
Added Initial UI Stylings
</commit_message>
<xml_diff>
--- a/Assets/Sprites/rockin_rackin_Logo.pptx
+++ b/Assets/Sprites/rockin_rackin_Logo.pptx
@@ -6,6 +6,7 @@
   </p:sldMasterIdLst>
   <p:sldIdLst>
     <p:sldId id="256" r:id="rId2"/>
+    <p:sldId id="257" r:id="rId3"/>
   </p:sldIdLst>
   <p:sldSz cx="9753600" cy="9753600"/>
   <p:notesSz cx="6858000" cy="9144000"/>
@@ -104,6 +105,11 @@
       </a:defRPr>
     </a:lvl9pPr>
   </p:defaultTextStyle>
+  <p:extLst>
+    <p:ext uri="{EFAFB233-063F-42B5-8137-9DF3F51BA10A}">
+      <p15:sldGuideLst xmlns:p15="http://schemas.microsoft.com/office/powerpoint/2012/main"/>
+    </p:ext>
+  </p:extLst>
 </p:presentation>
 </file>
 
@@ -238,7 +244,7 @@
           <a:p>
             <a:fld id="{E6DAED35-DFB6-4BA2-A5B6-52D99E578295}" type="datetimeFigureOut">
               <a:rPr lang="ko-KR" altLang="en-US" smtClean="0"/>
-              <a:t>2026-08-04</a:t>
+              <a:t>2026-08-05</a:t>
             </a:fld>
             <a:endParaRPr lang="ko-KR" altLang="en-US"/>
           </a:p>
@@ -408,7 +414,7 @@
           <a:p>
             <a:fld id="{E6DAED35-DFB6-4BA2-A5B6-52D99E578295}" type="datetimeFigureOut">
               <a:rPr lang="ko-KR" altLang="en-US" smtClean="0"/>
-              <a:t>2026-08-04</a:t>
+              <a:t>2026-08-05</a:t>
             </a:fld>
             <a:endParaRPr lang="ko-KR" altLang="en-US"/>
           </a:p>
@@ -588,7 +594,7 @@
           <a:p>
             <a:fld id="{E6DAED35-DFB6-4BA2-A5B6-52D99E578295}" type="datetimeFigureOut">
               <a:rPr lang="ko-KR" altLang="en-US" smtClean="0"/>
-              <a:t>2026-08-04</a:t>
+              <a:t>2026-08-05</a:t>
             </a:fld>
             <a:endParaRPr lang="ko-KR" altLang="en-US"/>
           </a:p>
@@ -758,7 +764,7 @@
           <a:p>
             <a:fld id="{E6DAED35-DFB6-4BA2-A5B6-52D99E578295}" type="datetimeFigureOut">
               <a:rPr lang="ko-KR" altLang="en-US" smtClean="0"/>
-              <a:t>2026-08-04</a:t>
+              <a:t>2026-08-05</a:t>
             </a:fld>
             <a:endParaRPr lang="ko-KR" altLang="en-US"/>
           </a:p>
@@ -1004,7 +1010,7 @@
           <a:p>
             <a:fld id="{E6DAED35-DFB6-4BA2-A5B6-52D99E578295}" type="datetimeFigureOut">
               <a:rPr lang="ko-KR" altLang="en-US" smtClean="0"/>
-              <a:t>2026-08-04</a:t>
+              <a:t>2026-08-05</a:t>
             </a:fld>
             <a:endParaRPr lang="ko-KR" altLang="en-US"/>
           </a:p>
@@ -1236,7 +1242,7 @@
           <a:p>
             <a:fld id="{E6DAED35-DFB6-4BA2-A5B6-52D99E578295}" type="datetimeFigureOut">
               <a:rPr lang="ko-KR" altLang="en-US" smtClean="0"/>
-              <a:t>2026-08-04</a:t>
+              <a:t>2026-08-05</a:t>
             </a:fld>
             <a:endParaRPr lang="ko-KR" altLang="en-US"/>
           </a:p>
@@ -1603,7 +1609,7 @@
           <a:p>
             <a:fld id="{E6DAED35-DFB6-4BA2-A5B6-52D99E578295}" type="datetimeFigureOut">
               <a:rPr lang="ko-KR" altLang="en-US" smtClean="0"/>
-              <a:t>2026-08-04</a:t>
+              <a:t>2026-08-05</a:t>
             </a:fld>
             <a:endParaRPr lang="ko-KR" altLang="en-US"/>
           </a:p>
@@ -1721,7 +1727,7 @@
           <a:p>
             <a:fld id="{E6DAED35-DFB6-4BA2-A5B6-52D99E578295}" type="datetimeFigureOut">
               <a:rPr lang="ko-KR" altLang="en-US" smtClean="0"/>
-              <a:t>2026-08-04</a:t>
+              <a:t>2026-08-05</a:t>
             </a:fld>
             <a:endParaRPr lang="ko-KR" altLang="en-US"/>
           </a:p>
@@ -1816,7 +1822,7 @@
           <a:p>
             <a:fld id="{E6DAED35-DFB6-4BA2-A5B6-52D99E578295}" type="datetimeFigureOut">
               <a:rPr lang="ko-KR" altLang="en-US" smtClean="0"/>
-              <a:t>2026-08-04</a:t>
+              <a:t>2026-08-05</a:t>
             </a:fld>
             <a:endParaRPr lang="ko-KR" altLang="en-US"/>
           </a:p>
@@ -2093,7 +2099,7 @@
           <a:p>
             <a:fld id="{E6DAED35-DFB6-4BA2-A5B6-52D99E578295}" type="datetimeFigureOut">
               <a:rPr lang="ko-KR" altLang="en-US" smtClean="0"/>
-              <a:t>2026-08-04</a:t>
+              <a:t>2026-08-05</a:t>
             </a:fld>
             <a:endParaRPr lang="ko-KR" altLang="en-US"/>
           </a:p>
@@ -2350,7 +2356,7 @@
           <a:p>
             <a:fld id="{E6DAED35-DFB6-4BA2-A5B6-52D99E578295}" type="datetimeFigureOut">
               <a:rPr lang="ko-KR" altLang="en-US" smtClean="0"/>
-              <a:t>2026-08-04</a:t>
+              <a:t>2026-08-05</a:t>
             </a:fld>
             <a:endParaRPr lang="ko-KR" altLang="en-US"/>
           </a:p>
@@ -2563,7 +2569,7 @@
           <a:p>
             <a:fld id="{E6DAED35-DFB6-4BA2-A5B6-52D99E578295}" type="datetimeFigureOut">
               <a:rPr lang="ko-KR" altLang="en-US" smtClean="0"/>
-              <a:t>2026-08-04</a:t>
+              <a:t>2026-08-05</a:t>
             </a:fld>
             <a:endParaRPr lang="ko-KR" altLang="en-US"/>
           </a:p>
@@ -3227,10 +3233,1711 @@
 </p:sld>
 </file>
 
+<file path=ppt/slides/slide2.xml><?xml version="1.0" encoding="utf-8"?>
+<p:sld xmlns:a="http://schemas.openxmlformats.org/drawingml/2006/main" xmlns:r="http://schemas.openxmlformats.org/officeDocument/2006/relationships" xmlns:p="http://schemas.openxmlformats.org/presentationml/2006/main">
+  <p:cSld>
+    <p:bg>
+      <p:bgPr>
+        <a:solidFill>
+          <a:schemeClr val="accent1"/>
+        </a:solidFill>
+        <a:effectLst/>
+      </p:bgPr>
+    </p:bg>
+    <p:spTree>
+      <p:nvGrpSpPr>
+        <p:cNvPr id="1" name=""/>
+        <p:cNvGrpSpPr/>
+        <p:nvPr/>
+      </p:nvGrpSpPr>
+      <p:grpSpPr>
+        <a:xfrm>
+          <a:off x="0" y="0"/>
+          <a:ext cx="0" cy="0"/>
+          <a:chOff x="0" y="0"/>
+          <a:chExt cx="0" cy="0"/>
+        </a:xfrm>
+      </p:grpSpPr>
+      <p:grpSp>
+        <p:nvGrpSpPr>
+          <p:cNvPr id="32" name="Group 31">
+            <a:extLst>
+              <a:ext uri="{FF2B5EF4-FFF2-40B4-BE49-F238E27FC236}">
+                <a16:creationId xmlns:a16="http://schemas.microsoft.com/office/drawing/2014/main" id="{8F9AE2FD-65F5-68E5-53E6-14CD89E79C55}"/>
+              </a:ext>
+            </a:extLst>
+          </p:cNvPr>
+          <p:cNvGrpSpPr/>
+          <p:nvPr/>
+        </p:nvGrpSpPr>
+        <p:grpSpPr>
+          <a:xfrm>
+            <a:off x="0" y="0"/>
+            <a:ext cx="4876800" cy="4876800"/>
+            <a:chOff x="0" y="0"/>
+            <a:chExt cx="4876800" cy="4876800"/>
+          </a:xfrm>
+        </p:grpSpPr>
+        <p:sp>
+          <p:nvSpPr>
+            <p:cNvPr id="2" name="Rectangle 1">
+              <a:extLst>
+                <a:ext uri="{FF2B5EF4-FFF2-40B4-BE49-F238E27FC236}">
+                  <a16:creationId xmlns:a16="http://schemas.microsoft.com/office/drawing/2014/main" id="{5BC8C924-FE08-578F-8494-21C4165D6AB1}"/>
+                </a:ext>
+              </a:extLst>
+            </p:cNvPr>
+            <p:cNvSpPr/>
+            <p:nvPr/>
+          </p:nvSpPr>
+          <p:spPr>
+            <a:xfrm>
+              <a:off x="0" y="0"/>
+              <a:ext cx="4876800" cy="4876800"/>
+            </a:xfrm>
+            <a:prstGeom prst="rect">
+              <a:avLst/>
+            </a:prstGeom>
+            <a:solidFill>
+              <a:schemeClr val="tx1">
+                <a:alpha val="0"/>
+              </a:schemeClr>
+            </a:solidFill>
+            <a:ln>
+              <a:noFill/>
+            </a:ln>
+          </p:spPr>
+          <p:style>
+            <a:lnRef idx="2">
+              <a:schemeClr val="accent1">
+                <a:shade val="15000"/>
+              </a:schemeClr>
+            </a:lnRef>
+            <a:fillRef idx="1">
+              <a:schemeClr val="accent1"/>
+            </a:fillRef>
+            <a:effectRef idx="0">
+              <a:schemeClr val="accent1"/>
+            </a:effectRef>
+            <a:fontRef idx="minor">
+              <a:schemeClr val="lt1"/>
+            </a:fontRef>
+          </p:style>
+          <p:txBody>
+            <a:bodyPr rtlCol="0" anchor="ctr"/>
+            <a:lstStyle/>
+            <a:p>
+              <a:pPr algn="ctr"/>
+              <a:endParaRPr lang="ko-KR" altLang="en-US" dirty="0"/>
+            </a:p>
+          </p:txBody>
+        </p:sp>
+        <p:sp>
+          <p:nvSpPr>
+            <p:cNvPr id="4" name="Frame 3">
+              <a:extLst>
+                <a:ext uri="{FF2B5EF4-FFF2-40B4-BE49-F238E27FC236}">
+                  <a16:creationId xmlns:a16="http://schemas.microsoft.com/office/drawing/2014/main" id="{611F1EBF-EC91-3FD5-C7C7-42B3F6DD1F35}"/>
+                </a:ext>
+              </a:extLst>
+            </p:cNvPr>
+            <p:cNvSpPr/>
+            <p:nvPr/>
+          </p:nvSpPr>
+          <p:spPr>
+            <a:xfrm>
+              <a:off x="179294" y="179294"/>
+              <a:ext cx="4518212" cy="4518212"/>
+            </a:xfrm>
+            <a:prstGeom prst="frame">
+              <a:avLst>
+                <a:gd name="adj1" fmla="val 7353"/>
+              </a:avLst>
+            </a:prstGeom>
+            <a:solidFill>
+              <a:schemeClr val="tx1"/>
+            </a:solidFill>
+            <a:ln>
+              <a:noFill/>
+            </a:ln>
+          </p:spPr>
+          <p:style>
+            <a:lnRef idx="2">
+              <a:schemeClr val="accent1">
+                <a:shade val="15000"/>
+              </a:schemeClr>
+            </a:lnRef>
+            <a:fillRef idx="1">
+              <a:schemeClr val="accent1"/>
+            </a:fillRef>
+            <a:effectRef idx="0">
+              <a:schemeClr val="accent1"/>
+            </a:effectRef>
+            <a:fontRef idx="minor">
+              <a:schemeClr val="lt1"/>
+            </a:fontRef>
+          </p:style>
+          <p:txBody>
+            <a:bodyPr rtlCol="0" anchor="ctr"/>
+            <a:lstStyle/>
+            <a:p>
+              <a:pPr algn="ctr"/>
+              <a:endParaRPr lang="ko-KR" altLang="en-US"/>
+            </a:p>
+          </p:txBody>
+        </p:sp>
+      </p:grpSp>
+      <p:grpSp>
+        <p:nvGrpSpPr>
+          <p:cNvPr id="31" name="Group 30">
+            <a:extLst>
+              <a:ext uri="{FF2B5EF4-FFF2-40B4-BE49-F238E27FC236}">
+                <a16:creationId xmlns:a16="http://schemas.microsoft.com/office/drawing/2014/main" id="{BDDABEE3-DECB-B7F7-7432-F8809EFFF7DE}"/>
+              </a:ext>
+            </a:extLst>
+          </p:cNvPr>
+          <p:cNvGrpSpPr/>
+          <p:nvPr/>
+        </p:nvGrpSpPr>
+        <p:grpSpPr>
+          <a:xfrm>
+            <a:off x="4876799" y="0"/>
+            <a:ext cx="4876801" cy="4876801"/>
+            <a:chOff x="4876799" y="0"/>
+            <a:chExt cx="4876801" cy="4876801"/>
+          </a:xfrm>
+          <a:solidFill>
+            <a:schemeClr val="tx1"/>
+          </a:solidFill>
+        </p:grpSpPr>
+        <p:sp>
+          <p:nvSpPr>
+            <p:cNvPr id="24" name="Freeform: Shape 23">
+              <a:extLst>
+                <a:ext uri="{FF2B5EF4-FFF2-40B4-BE49-F238E27FC236}">
+                  <a16:creationId xmlns:a16="http://schemas.microsoft.com/office/drawing/2014/main" id="{B0A7C99B-A6B4-840B-6B8E-A91D87DAFCD7}"/>
+                </a:ext>
+              </a:extLst>
+            </p:cNvPr>
+            <p:cNvSpPr/>
+            <p:nvPr/>
+          </p:nvSpPr>
+          <p:spPr>
+            <a:xfrm>
+              <a:off x="7315200" y="0"/>
+              <a:ext cx="2438400" cy="2438401"/>
+            </a:xfrm>
+            <a:custGeom>
+              <a:avLst/>
+              <a:gdLst>
+                <a:gd name="csX0" fmla="*/ 2162174 w 2438400"/>
+                <a:gd name="csY0" fmla="*/ 1015509 h 2438401"/>
+                <a:gd name="csX1" fmla="*/ 2226113 w 2438400"/>
+                <a:gd name="csY1" fmla="*/ 1031950 h 2438401"/>
+                <a:gd name="csX2" fmla="*/ 2438400 w 2438400"/>
+                <a:gd name="csY2" fmla="*/ 1053350 h 2438401"/>
+                <a:gd name="csX3" fmla="*/ 2438400 w 2438400"/>
+                <a:gd name="csY3" fmla="*/ 2438401 h 2438401"/>
+                <a:gd name="csX4" fmla="*/ 2162174 w 2438400"/>
+                <a:gd name="csY4" fmla="*/ 2438401 h 2438401"/>
+                <a:gd name="csX5" fmla="*/ 1385048 w 2438400"/>
+                <a:gd name="csY5" fmla="*/ 0 h 2438401"/>
+                <a:gd name="csX6" fmla="*/ 1659489 w 2438400"/>
+                <a:gd name="csY6" fmla="*/ 0 h 2438401"/>
+                <a:gd name="csX7" fmla="*/ 1663510 w 2438400"/>
+                <a:gd name="csY7" fmla="*/ 79636 h 2438401"/>
+                <a:gd name="csX8" fmla="*/ 1675314 w 2438400"/>
+                <a:gd name="csY8" fmla="*/ 156975 h 2438401"/>
+                <a:gd name="csX9" fmla="*/ 1712331 w 2438400"/>
+                <a:gd name="csY9" fmla="*/ 276225 h 2438401"/>
+                <a:gd name="csX10" fmla="*/ 1712330 w 2438400"/>
+                <a:gd name="csY10" fmla="*/ 276225 h 2438401"/>
+                <a:gd name="csX11" fmla="*/ 1720699 w 2438400"/>
+                <a:gd name="csY11" fmla="*/ 303185 h 2438401"/>
+                <a:gd name="csX12" fmla="*/ 2135212 w 2438400"/>
+                <a:gd name="csY12" fmla="*/ 717698 h 2438401"/>
+                <a:gd name="csX13" fmla="*/ 2162174 w 2438400"/>
+                <a:gd name="csY13" fmla="*/ 726067 h 2438401"/>
+                <a:gd name="csX14" fmla="*/ 2162174 w 2438400"/>
+                <a:gd name="csY14" fmla="*/ 726067 h 2438401"/>
+                <a:gd name="csX15" fmla="*/ 2281422 w 2438400"/>
+                <a:gd name="csY15" fmla="*/ 763084 h 2438401"/>
+                <a:gd name="csX16" fmla="*/ 2438400 w 2438400"/>
+                <a:gd name="csY16" fmla="*/ 778909 h 2438401"/>
+                <a:gd name="csX17" fmla="*/ 2438400 w 2438400"/>
+                <a:gd name="csY17" fmla="*/ 1053350 h 2438401"/>
+                <a:gd name="csX18" fmla="*/ 2226113 w 2438400"/>
+                <a:gd name="csY18" fmla="*/ 1031950 h 2438401"/>
+                <a:gd name="csX19" fmla="*/ 2162174 w 2438400"/>
+                <a:gd name="csY19" fmla="*/ 1015509 h 2438401"/>
+                <a:gd name="csX20" fmla="*/ 2162174 w 2438400"/>
+                <a:gd name="csY20" fmla="*/ 1015509 h 2438401"/>
+                <a:gd name="csX21" fmla="*/ 2125165 w 2438400"/>
+                <a:gd name="csY21" fmla="*/ 1005993 h 2438401"/>
+                <a:gd name="csX22" fmla="*/ 1432404 w 2438400"/>
+                <a:gd name="csY22" fmla="*/ 313232 h 2438401"/>
+                <a:gd name="csX23" fmla="*/ 1422888 w 2438400"/>
+                <a:gd name="csY23" fmla="*/ 276225 h 2438401"/>
+                <a:gd name="csX24" fmla="*/ 1422889 w 2438400"/>
+                <a:gd name="csY24" fmla="*/ 276225 h 2438401"/>
+                <a:gd name="csX25" fmla="*/ 1406448 w 2438400"/>
+                <a:gd name="csY25" fmla="*/ 212284 h 2438401"/>
+                <a:gd name="csX26" fmla="*/ 1390486 w 2438400"/>
+                <a:gd name="csY26" fmla="*/ 107696 h 2438401"/>
+                <a:gd name="csX27" fmla="*/ 0 w 2438400"/>
+                <a:gd name="csY27" fmla="*/ 0 h 2438401"/>
+                <a:gd name="csX28" fmla="*/ 1385047 w 2438400"/>
+                <a:gd name="csY28" fmla="*/ 0 h 2438401"/>
+                <a:gd name="csX29" fmla="*/ 1390485 w 2438400"/>
+                <a:gd name="csY29" fmla="*/ 107696 h 2438401"/>
+                <a:gd name="csX30" fmla="*/ 1406447 w 2438400"/>
+                <a:gd name="csY30" fmla="*/ 212284 h 2438401"/>
+                <a:gd name="csX31" fmla="*/ 1422888 w 2438400"/>
+                <a:gd name="csY31" fmla="*/ 276225 h 2438401"/>
+                <a:gd name="csX32" fmla="*/ 0 w 2438400"/>
+                <a:gd name="csY32" fmla="*/ 276225 h 2438401"/>
+              </a:gdLst>
+              <a:ahLst/>
+              <a:cxnLst>
+                <a:cxn ang="0">
+                  <a:pos x="csX0" y="csY0"/>
+                </a:cxn>
+                <a:cxn ang="0">
+                  <a:pos x="csX1" y="csY1"/>
+                </a:cxn>
+                <a:cxn ang="0">
+                  <a:pos x="csX2" y="csY2"/>
+                </a:cxn>
+                <a:cxn ang="0">
+                  <a:pos x="csX3" y="csY3"/>
+                </a:cxn>
+                <a:cxn ang="0">
+                  <a:pos x="csX4" y="csY4"/>
+                </a:cxn>
+                <a:cxn ang="0">
+                  <a:pos x="csX5" y="csY5"/>
+                </a:cxn>
+                <a:cxn ang="0">
+                  <a:pos x="csX6" y="csY6"/>
+                </a:cxn>
+                <a:cxn ang="0">
+                  <a:pos x="csX7" y="csY7"/>
+                </a:cxn>
+                <a:cxn ang="0">
+                  <a:pos x="csX8" y="csY8"/>
+                </a:cxn>
+                <a:cxn ang="0">
+                  <a:pos x="csX9" y="csY9"/>
+                </a:cxn>
+                <a:cxn ang="0">
+                  <a:pos x="csX10" y="csY10"/>
+                </a:cxn>
+                <a:cxn ang="0">
+                  <a:pos x="csX11" y="csY11"/>
+                </a:cxn>
+                <a:cxn ang="0">
+                  <a:pos x="csX12" y="csY12"/>
+                </a:cxn>
+                <a:cxn ang="0">
+                  <a:pos x="csX13" y="csY13"/>
+                </a:cxn>
+                <a:cxn ang="0">
+                  <a:pos x="csX14" y="csY14"/>
+                </a:cxn>
+                <a:cxn ang="0">
+                  <a:pos x="csX15" y="csY15"/>
+                </a:cxn>
+                <a:cxn ang="0">
+                  <a:pos x="csX16" y="csY16"/>
+                </a:cxn>
+                <a:cxn ang="0">
+                  <a:pos x="csX17" y="csY17"/>
+                </a:cxn>
+                <a:cxn ang="0">
+                  <a:pos x="csX18" y="csY18"/>
+                </a:cxn>
+                <a:cxn ang="0">
+                  <a:pos x="csX19" y="csY19"/>
+                </a:cxn>
+                <a:cxn ang="0">
+                  <a:pos x="csX20" y="csY20"/>
+                </a:cxn>
+                <a:cxn ang="0">
+                  <a:pos x="csX21" y="csY21"/>
+                </a:cxn>
+                <a:cxn ang="0">
+                  <a:pos x="csX22" y="csY22"/>
+                </a:cxn>
+                <a:cxn ang="0">
+                  <a:pos x="csX23" y="csY23"/>
+                </a:cxn>
+                <a:cxn ang="0">
+                  <a:pos x="csX24" y="csY24"/>
+                </a:cxn>
+                <a:cxn ang="0">
+                  <a:pos x="csX25" y="csY25"/>
+                </a:cxn>
+                <a:cxn ang="0">
+                  <a:pos x="csX26" y="csY26"/>
+                </a:cxn>
+                <a:cxn ang="0">
+                  <a:pos x="csX27" y="csY27"/>
+                </a:cxn>
+                <a:cxn ang="0">
+                  <a:pos x="csX28" y="csY28"/>
+                </a:cxn>
+                <a:cxn ang="0">
+                  <a:pos x="csX29" y="csY29"/>
+                </a:cxn>
+                <a:cxn ang="0">
+                  <a:pos x="csX30" y="csY30"/>
+                </a:cxn>
+                <a:cxn ang="0">
+                  <a:pos x="csX31" y="csY31"/>
+                </a:cxn>
+                <a:cxn ang="0">
+                  <a:pos x="csX32" y="csY32"/>
+                </a:cxn>
+              </a:cxnLst>
+              <a:rect l="l" t="t" r="r" b="b"/>
+              <a:pathLst>
+                <a:path w="2438400" h="2438401">
+                  <a:moveTo>
+                    <a:pt x="2162174" y="1015509"/>
+                  </a:moveTo>
+                  <a:lnTo>
+                    <a:pt x="2226113" y="1031950"/>
+                  </a:lnTo>
+                  <a:cubicBezTo>
+                    <a:pt x="2294683" y="1045981"/>
+                    <a:pt x="2365681" y="1053350"/>
+                    <a:pt x="2438400" y="1053350"/>
+                  </a:cubicBezTo>
+                  <a:lnTo>
+                    <a:pt x="2438400" y="2438401"/>
+                  </a:lnTo>
+                  <a:lnTo>
+                    <a:pt x="2162174" y="2438401"/>
+                  </a:lnTo>
+                  <a:close/>
+                  <a:moveTo>
+                    <a:pt x="1385048" y="0"/>
+                  </a:moveTo>
+                  <a:lnTo>
+                    <a:pt x="1659489" y="0"/>
+                  </a:lnTo>
+                  <a:lnTo>
+                    <a:pt x="1663510" y="79636"/>
+                  </a:lnTo>
+                  <a:cubicBezTo>
+                    <a:pt x="1666170" y="105821"/>
+                    <a:pt x="1670126" y="131622"/>
+                    <a:pt x="1675314" y="156975"/>
+                  </a:cubicBezTo>
+                  <a:lnTo>
+                    <a:pt x="1712331" y="276225"/>
+                  </a:lnTo>
+                  <a:lnTo>
+                    <a:pt x="1712330" y="276225"/>
+                  </a:lnTo>
+                  <a:lnTo>
+                    <a:pt x="1720699" y="303185"/>
+                  </a:lnTo>
+                  <a:cubicBezTo>
+                    <a:pt x="1799529" y="489560"/>
+                    <a:pt x="1948837" y="638868"/>
+                    <a:pt x="2135212" y="717698"/>
+                  </a:cubicBezTo>
+                  <a:lnTo>
+                    <a:pt x="2162174" y="726067"/>
+                  </a:lnTo>
+                  <a:lnTo>
+                    <a:pt x="2162174" y="726067"/>
+                  </a:lnTo>
+                  <a:lnTo>
+                    <a:pt x="2281422" y="763084"/>
+                  </a:lnTo>
+                  <a:cubicBezTo>
+                    <a:pt x="2332127" y="773460"/>
+                    <a:pt x="2384627" y="778909"/>
+                    <a:pt x="2438400" y="778909"/>
+                  </a:cubicBezTo>
+                  <a:lnTo>
+                    <a:pt x="2438400" y="1053350"/>
+                  </a:lnTo>
+                  <a:cubicBezTo>
+                    <a:pt x="2365681" y="1053350"/>
+                    <a:pt x="2294683" y="1045981"/>
+                    <a:pt x="2226113" y="1031950"/>
+                  </a:cubicBezTo>
+                  <a:lnTo>
+                    <a:pt x="2162174" y="1015509"/>
+                  </a:lnTo>
+                  <a:lnTo>
+                    <a:pt x="2162174" y="1015509"/>
+                  </a:lnTo>
+                  <a:lnTo>
+                    <a:pt x="2125165" y="1005993"/>
+                  </a:lnTo>
+                  <a:cubicBezTo>
+                    <a:pt x="1795329" y="903404"/>
+                    <a:pt x="1534993" y="643068"/>
+                    <a:pt x="1432404" y="313232"/>
+                  </a:cubicBezTo>
+                  <a:lnTo>
+                    <a:pt x="1422888" y="276225"/>
+                  </a:lnTo>
+                  <a:lnTo>
+                    <a:pt x="1422889" y="276225"/>
+                  </a:lnTo>
+                  <a:lnTo>
+                    <a:pt x="1406448" y="212284"/>
+                  </a:lnTo>
+                  <a:cubicBezTo>
+                    <a:pt x="1399433" y="177999"/>
+                    <a:pt x="1394082" y="143107"/>
+                    <a:pt x="1390486" y="107696"/>
+                  </a:cubicBezTo>
+                  <a:close/>
+                  <a:moveTo>
+                    <a:pt x="0" y="0"/>
+                  </a:moveTo>
+                  <a:lnTo>
+                    <a:pt x="1385047" y="0"/>
+                  </a:lnTo>
+                  <a:lnTo>
+                    <a:pt x="1390485" y="107696"/>
+                  </a:lnTo>
+                  <a:cubicBezTo>
+                    <a:pt x="1394081" y="143107"/>
+                    <a:pt x="1399432" y="177999"/>
+                    <a:pt x="1406447" y="212284"/>
+                  </a:cubicBezTo>
+                  <a:lnTo>
+                    <a:pt x="1422888" y="276225"/>
+                  </a:lnTo>
+                  <a:lnTo>
+                    <a:pt x="0" y="276225"/>
+                  </a:lnTo>
+                  <a:close/>
+                </a:path>
+              </a:pathLst>
+            </a:custGeom>
+            <a:grpFill/>
+            <a:ln>
+              <a:noFill/>
+            </a:ln>
+          </p:spPr>
+          <p:style>
+            <a:lnRef idx="2">
+              <a:schemeClr val="accent1">
+                <a:shade val="15000"/>
+              </a:schemeClr>
+            </a:lnRef>
+            <a:fillRef idx="1">
+              <a:schemeClr val="accent1"/>
+            </a:fillRef>
+            <a:effectRef idx="0">
+              <a:schemeClr val="accent1"/>
+            </a:effectRef>
+            <a:fontRef idx="minor">
+              <a:schemeClr val="lt1"/>
+            </a:fontRef>
+          </p:style>
+          <p:txBody>
+            <a:bodyPr wrap="square" rtlCol="0" anchor="ctr">
+              <a:noAutofit/>
+            </a:bodyPr>
+            <a:lstStyle/>
+            <a:p>
+              <a:pPr algn="ctr"/>
+              <a:endParaRPr lang="ko-KR" altLang="en-US"/>
+            </a:p>
+          </p:txBody>
+        </p:sp>
+        <p:sp>
+          <p:nvSpPr>
+            <p:cNvPr id="26" name="Freeform: Shape 25">
+              <a:extLst>
+                <a:ext uri="{FF2B5EF4-FFF2-40B4-BE49-F238E27FC236}">
+                  <a16:creationId xmlns:a16="http://schemas.microsoft.com/office/drawing/2014/main" id="{208781D9-4ED5-9AA2-5F5E-091E56A2E925}"/>
+                </a:ext>
+              </a:extLst>
+            </p:cNvPr>
+            <p:cNvSpPr/>
+            <p:nvPr/>
+          </p:nvSpPr>
+          <p:spPr>
+            <a:xfrm rot="5400000">
+              <a:off x="7315200" y="2438400"/>
+              <a:ext cx="2438400" cy="2438401"/>
+            </a:xfrm>
+            <a:custGeom>
+              <a:avLst/>
+              <a:gdLst>
+                <a:gd name="csX0" fmla="*/ 2162174 w 2438400"/>
+                <a:gd name="csY0" fmla="*/ 1015509 h 2438401"/>
+                <a:gd name="csX1" fmla="*/ 2226113 w 2438400"/>
+                <a:gd name="csY1" fmla="*/ 1031950 h 2438401"/>
+                <a:gd name="csX2" fmla="*/ 2438400 w 2438400"/>
+                <a:gd name="csY2" fmla="*/ 1053350 h 2438401"/>
+                <a:gd name="csX3" fmla="*/ 2438400 w 2438400"/>
+                <a:gd name="csY3" fmla="*/ 2438401 h 2438401"/>
+                <a:gd name="csX4" fmla="*/ 2162174 w 2438400"/>
+                <a:gd name="csY4" fmla="*/ 2438401 h 2438401"/>
+                <a:gd name="csX5" fmla="*/ 1385048 w 2438400"/>
+                <a:gd name="csY5" fmla="*/ 0 h 2438401"/>
+                <a:gd name="csX6" fmla="*/ 1659489 w 2438400"/>
+                <a:gd name="csY6" fmla="*/ 0 h 2438401"/>
+                <a:gd name="csX7" fmla="*/ 1663510 w 2438400"/>
+                <a:gd name="csY7" fmla="*/ 79636 h 2438401"/>
+                <a:gd name="csX8" fmla="*/ 1675314 w 2438400"/>
+                <a:gd name="csY8" fmla="*/ 156975 h 2438401"/>
+                <a:gd name="csX9" fmla="*/ 1712331 w 2438400"/>
+                <a:gd name="csY9" fmla="*/ 276225 h 2438401"/>
+                <a:gd name="csX10" fmla="*/ 1712330 w 2438400"/>
+                <a:gd name="csY10" fmla="*/ 276225 h 2438401"/>
+                <a:gd name="csX11" fmla="*/ 1720699 w 2438400"/>
+                <a:gd name="csY11" fmla="*/ 303185 h 2438401"/>
+                <a:gd name="csX12" fmla="*/ 2135212 w 2438400"/>
+                <a:gd name="csY12" fmla="*/ 717698 h 2438401"/>
+                <a:gd name="csX13" fmla="*/ 2162174 w 2438400"/>
+                <a:gd name="csY13" fmla="*/ 726067 h 2438401"/>
+                <a:gd name="csX14" fmla="*/ 2162174 w 2438400"/>
+                <a:gd name="csY14" fmla="*/ 726067 h 2438401"/>
+                <a:gd name="csX15" fmla="*/ 2281422 w 2438400"/>
+                <a:gd name="csY15" fmla="*/ 763084 h 2438401"/>
+                <a:gd name="csX16" fmla="*/ 2438400 w 2438400"/>
+                <a:gd name="csY16" fmla="*/ 778909 h 2438401"/>
+                <a:gd name="csX17" fmla="*/ 2438400 w 2438400"/>
+                <a:gd name="csY17" fmla="*/ 1053350 h 2438401"/>
+                <a:gd name="csX18" fmla="*/ 2226113 w 2438400"/>
+                <a:gd name="csY18" fmla="*/ 1031950 h 2438401"/>
+                <a:gd name="csX19" fmla="*/ 2162174 w 2438400"/>
+                <a:gd name="csY19" fmla="*/ 1015509 h 2438401"/>
+                <a:gd name="csX20" fmla="*/ 2162174 w 2438400"/>
+                <a:gd name="csY20" fmla="*/ 1015509 h 2438401"/>
+                <a:gd name="csX21" fmla="*/ 2125165 w 2438400"/>
+                <a:gd name="csY21" fmla="*/ 1005993 h 2438401"/>
+                <a:gd name="csX22" fmla="*/ 1432404 w 2438400"/>
+                <a:gd name="csY22" fmla="*/ 313232 h 2438401"/>
+                <a:gd name="csX23" fmla="*/ 1422888 w 2438400"/>
+                <a:gd name="csY23" fmla="*/ 276225 h 2438401"/>
+                <a:gd name="csX24" fmla="*/ 1422889 w 2438400"/>
+                <a:gd name="csY24" fmla="*/ 276225 h 2438401"/>
+                <a:gd name="csX25" fmla="*/ 1406448 w 2438400"/>
+                <a:gd name="csY25" fmla="*/ 212284 h 2438401"/>
+                <a:gd name="csX26" fmla="*/ 1390486 w 2438400"/>
+                <a:gd name="csY26" fmla="*/ 107696 h 2438401"/>
+                <a:gd name="csX27" fmla="*/ 0 w 2438400"/>
+                <a:gd name="csY27" fmla="*/ 0 h 2438401"/>
+                <a:gd name="csX28" fmla="*/ 1385047 w 2438400"/>
+                <a:gd name="csY28" fmla="*/ 0 h 2438401"/>
+                <a:gd name="csX29" fmla="*/ 1390485 w 2438400"/>
+                <a:gd name="csY29" fmla="*/ 107696 h 2438401"/>
+                <a:gd name="csX30" fmla="*/ 1406447 w 2438400"/>
+                <a:gd name="csY30" fmla="*/ 212284 h 2438401"/>
+                <a:gd name="csX31" fmla="*/ 1422888 w 2438400"/>
+                <a:gd name="csY31" fmla="*/ 276225 h 2438401"/>
+                <a:gd name="csX32" fmla="*/ 0 w 2438400"/>
+                <a:gd name="csY32" fmla="*/ 276225 h 2438401"/>
+              </a:gdLst>
+              <a:ahLst/>
+              <a:cxnLst>
+                <a:cxn ang="0">
+                  <a:pos x="csX0" y="csY0"/>
+                </a:cxn>
+                <a:cxn ang="0">
+                  <a:pos x="csX1" y="csY1"/>
+                </a:cxn>
+                <a:cxn ang="0">
+                  <a:pos x="csX2" y="csY2"/>
+                </a:cxn>
+                <a:cxn ang="0">
+                  <a:pos x="csX3" y="csY3"/>
+                </a:cxn>
+                <a:cxn ang="0">
+                  <a:pos x="csX4" y="csY4"/>
+                </a:cxn>
+                <a:cxn ang="0">
+                  <a:pos x="csX5" y="csY5"/>
+                </a:cxn>
+                <a:cxn ang="0">
+                  <a:pos x="csX6" y="csY6"/>
+                </a:cxn>
+                <a:cxn ang="0">
+                  <a:pos x="csX7" y="csY7"/>
+                </a:cxn>
+                <a:cxn ang="0">
+                  <a:pos x="csX8" y="csY8"/>
+                </a:cxn>
+                <a:cxn ang="0">
+                  <a:pos x="csX9" y="csY9"/>
+                </a:cxn>
+                <a:cxn ang="0">
+                  <a:pos x="csX10" y="csY10"/>
+                </a:cxn>
+                <a:cxn ang="0">
+                  <a:pos x="csX11" y="csY11"/>
+                </a:cxn>
+                <a:cxn ang="0">
+                  <a:pos x="csX12" y="csY12"/>
+                </a:cxn>
+                <a:cxn ang="0">
+                  <a:pos x="csX13" y="csY13"/>
+                </a:cxn>
+                <a:cxn ang="0">
+                  <a:pos x="csX14" y="csY14"/>
+                </a:cxn>
+                <a:cxn ang="0">
+                  <a:pos x="csX15" y="csY15"/>
+                </a:cxn>
+                <a:cxn ang="0">
+                  <a:pos x="csX16" y="csY16"/>
+                </a:cxn>
+                <a:cxn ang="0">
+                  <a:pos x="csX17" y="csY17"/>
+                </a:cxn>
+                <a:cxn ang="0">
+                  <a:pos x="csX18" y="csY18"/>
+                </a:cxn>
+                <a:cxn ang="0">
+                  <a:pos x="csX19" y="csY19"/>
+                </a:cxn>
+                <a:cxn ang="0">
+                  <a:pos x="csX20" y="csY20"/>
+                </a:cxn>
+                <a:cxn ang="0">
+                  <a:pos x="csX21" y="csY21"/>
+                </a:cxn>
+                <a:cxn ang="0">
+                  <a:pos x="csX22" y="csY22"/>
+                </a:cxn>
+                <a:cxn ang="0">
+                  <a:pos x="csX23" y="csY23"/>
+                </a:cxn>
+                <a:cxn ang="0">
+                  <a:pos x="csX24" y="csY24"/>
+                </a:cxn>
+                <a:cxn ang="0">
+                  <a:pos x="csX25" y="csY25"/>
+                </a:cxn>
+                <a:cxn ang="0">
+                  <a:pos x="csX26" y="csY26"/>
+                </a:cxn>
+                <a:cxn ang="0">
+                  <a:pos x="csX27" y="csY27"/>
+                </a:cxn>
+                <a:cxn ang="0">
+                  <a:pos x="csX28" y="csY28"/>
+                </a:cxn>
+                <a:cxn ang="0">
+                  <a:pos x="csX29" y="csY29"/>
+                </a:cxn>
+                <a:cxn ang="0">
+                  <a:pos x="csX30" y="csY30"/>
+                </a:cxn>
+                <a:cxn ang="0">
+                  <a:pos x="csX31" y="csY31"/>
+                </a:cxn>
+                <a:cxn ang="0">
+                  <a:pos x="csX32" y="csY32"/>
+                </a:cxn>
+              </a:cxnLst>
+              <a:rect l="l" t="t" r="r" b="b"/>
+              <a:pathLst>
+                <a:path w="2438400" h="2438401">
+                  <a:moveTo>
+                    <a:pt x="2162174" y="1015509"/>
+                  </a:moveTo>
+                  <a:lnTo>
+                    <a:pt x="2226113" y="1031950"/>
+                  </a:lnTo>
+                  <a:cubicBezTo>
+                    <a:pt x="2294683" y="1045981"/>
+                    <a:pt x="2365681" y="1053350"/>
+                    <a:pt x="2438400" y="1053350"/>
+                  </a:cubicBezTo>
+                  <a:lnTo>
+                    <a:pt x="2438400" y="2438401"/>
+                  </a:lnTo>
+                  <a:lnTo>
+                    <a:pt x="2162174" y="2438401"/>
+                  </a:lnTo>
+                  <a:close/>
+                  <a:moveTo>
+                    <a:pt x="1385048" y="0"/>
+                  </a:moveTo>
+                  <a:lnTo>
+                    <a:pt x="1659489" y="0"/>
+                  </a:lnTo>
+                  <a:lnTo>
+                    <a:pt x="1663510" y="79636"/>
+                  </a:lnTo>
+                  <a:cubicBezTo>
+                    <a:pt x="1666170" y="105821"/>
+                    <a:pt x="1670126" y="131622"/>
+                    <a:pt x="1675314" y="156975"/>
+                  </a:cubicBezTo>
+                  <a:lnTo>
+                    <a:pt x="1712331" y="276225"/>
+                  </a:lnTo>
+                  <a:lnTo>
+                    <a:pt x="1712330" y="276225"/>
+                  </a:lnTo>
+                  <a:lnTo>
+                    <a:pt x="1720699" y="303185"/>
+                  </a:lnTo>
+                  <a:cubicBezTo>
+                    <a:pt x="1799529" y="489560"/>
+                    <a:pt x="1948837" y="638868"/>
+                    <a:pt x="2135212" y="717698"/>
+                  </a:cubicBezTo>
+                  <a:lnTo>
+                    <a:pt x="2162174" y="726067"/>
+                  </a:lnTo>
+                  <a:lnTo>
+                    <a:pt x="2162174" y="726067"/>
+                  </a:lnTo>
+                  <a:lnTo>
+                    <a:pt x="2281422" y="763084"/>
+                  </a:lnTo>
+                  <a:cubicBezTo>
+                    <a:pt x="2332127" y="773460"/>
+                    <a:pt x="2384627" y="778909"/>
+                    <a:pt x="2438400" y="778909"/>
+                  </a:cubicBezTo>
+                  <a:lnTo>
+                    <a:pt x="2438400" y="1053350"/>
+                  </a:lnTo>
+                  <a:cubicBezTo>
+                    <a:pt x="2365681" y="1053350"/>
+                    <a:pt x="2294683" y="1045981"/>
+                    <a:pt x="2226113" y="1031950"/>
+                  </a:cubicBezTo>
+                  <a:lnTo>
+                    <a:pt x="2162174" y="1015509"/>
+                  </a:lnTo>
+                  <a:lnTo>
+                    <a:pt x="2162174" y="1015509"/>
+                  </a:lnTo>
+                  <a:lnTo>
+                    <a:pt x="2125165" y="1005993"/>
+                  </a:lnTo>
+                  <a:cubicBezTo>
+                    <a:pt x="1795329" y="903404"/>
+                    <a:pt x="1534993" y="643068"/>
+                    <a:pt x="1432404" y="313232"/>
+                  </a:cubicBezTo>
+                  <a:lnTo>
+                    <a:pt x="1422888" y="276225"/>
+                  </a:lnTo>
+                  <a:lnTo>
+                    <a:pt x="1422889" y="276225"/>
+                  </a:lnTo>
+                  <a:lnTo>
+                    <a:pt x="1406448" y="212284"/>
+                  </a:lnTo>
+                  <a:cubicBezTo>
+                    <a:pt x="1399433" y="177999"/>
+                    <a:pt x="1394082" y="143107"/>
+                    <a:pt x="1390486" y="107696"/>
+                  </a:cubicBezTo>
+                  <a:close/>
+                  <a:moveTo>
+                    <a:pt x="0" y="0"/>
+                  </a:moveTo>
+                  <a:lnTo>
+                    <a:pt x="1385047" y="0"/>
+                  </a:lnTo>
+                  <a:lnTo>
+                    <a:pt x="1390485" y="107696"/>
+                  </a:lnTo>
+                  <a:cubicBezTo>
+                    <a:pt x="1394081" y="143107"/>
+                    <a:pt x="1399432" y="177999"/>
+                    <a:pt x="1406447" y="212284"/>
+                  </a:cubicBezTo>
+                  <a:lnTo>
+                    <a:pt x="1422888" y="276225"/>
+                  </a:lnTo>
+                  <a:lnTo>
+                    <a:pt x="0" y="276225"/>
+                  </a:lnTo>
+                  <a:close/>
+                </a:path>
+              </a:pathLst>
+            </a:custGeom>
+            <a:grpFill/>
+            <a:ln>
+              <a:noFill/>
+            </a:ln>
+          </p:spPr>
+          <p:style>
+            <a:lnRef idx="2">
+              <a:schemeClr val="accent1">
+                <a:shade val="15000"/>
+              </a:schemeClr>
+            </a:lnRef>
+            <a:fillRef idx="1">
+              <a:schemeClr val="accent1"/>
+            </a:fillRef>
+            <a:effectRef idx="0">
+              <a:schemeClr val="accent1"/>
+            </a:effectRef>
+            <a:fontRef idx="minor">
+              <a:schemeClr val="lt1"/>
+            </a:fontRef>
+          </p:style>
+          <p:txBody>
+            <a:bodyPr wrap="square" rtlCol="0" anchor="ctr">
+              <a:noAutofit/>
+            </a:bodyPr>
+            <a:lstStyle/>
+            <a:p>
+              <a:pPr algn="ctr"/>
+              <a:endParaRPr lang="ko-KR" altLang="en-US"/>
+            </a:p>
+          </p:txBody>
+        </p:sp>
+        <p:sp>
+          <p:nvSpPr>
+            <p:cNvPr id="28" name="Freeform: Shape 27">
+              <a:extLst>
+                <a:ext uri="{FF2B5EF4-FFF2-40B4-BE49-F238E27FC236}">
+                  <a16:creationId xmlns:a16="http://schemas.microsoft.com/office/drawing/2014/main" id="{B9A6CB8D-0753-19D5-EDEE-2A5B0582CD33}"/>
+                </a:ext>
+              </a:extLst>
+            </p:cNvPr>
+            <p:cNvSpPr/>
+            <p:nvPr/>
+          </p:nvSpPr>
+          <p:spPr>
+            <a:xfrm rot="10800000">
+              <a:off x="4876800" y="2438399"/>
+              <a:ext cx="2438400" cy="2438401"/>
+            </a:xfrm>
+            <a:custGeom>
+              <a:avLst/>
+              <a:gdLst>
+                <a:gd name="csX0" fmla="*/ 2162174 w 2438400"/>
+                <a:gd name="csY0" fmla="*/ 1015509 h 2438401"/>
+                <a:gd name="csX1" fmla="*/ 2226113 w 2438400"/>
+                <a:gd name="csY1" fmla="*/ 1031950 h 2438401"/>
+                <a:gd name="csX2" fmla="*/ 2438400 w 2438400"/>
+                <a:gd name="csY2" fmla="*/ 1053350 h 2438401"/>
+                <a:gd name="csX3" fmla="*/ 2438400 w 2438400"/>
+                <a:gd name="csY3" fmla="*/ 2438401 h 2438401"/>
+                <a:gd name="csX4" fmla="*/ 2162174 w 2438400"/>
+                <a:gd name="csY4" fmla="*/ 2438401 h 2438401"/>
+                <a:gd name="csX5" fmla="*/ 1385048 w 2438400"/>
+                <a:gd name="csY5" fmla="*/ 0 h 2438401"/>
+                <a:gd name="csX6" fmla="*/ 1659489 w 2438400"/>
+                <a:gd name="csY6" fmla="*/ 0 h 2438401"/>
+                <a:gd name="csX7" fmla="*/ 1663510 w 2438400"/>
+                <a:gd name="csY7" fmla="*/ 79636 h 2438401"/>
+                <a:gd name="csX8" fmla="*/ 1675314 w 2438400"/>
+                <a:gd name="csY8" fmla="*/ 156975 h 2438401"/>
+                <a:gd name="csX9" fmla="*/ 1712331 w 2438400"/>
+                <a:gd name="csY9" fmla="*/ 276225 h 2438401"/>
+                <a:gd name="csX10" fmla="*/ 1712330 w 2438400"/>
+                <a:gd name="csY10" fmla="*/ 276225 h 2438401"/>
+                <a:gd name="csX11" fmla="*/ 1720699 w 2438400"/>
+                <a:gd name="csY11" fmla="*/ 303185 h 2438401"/>
+                <a:gd name="csX12" fmla="*/ 2135212 w 2438400"/>
+                <a:gd name="csY12" fmla="*/ 717698 h 2438401"/>
+                <a:gd name="csX13" fmla="*/ 2162174 w 2438400"/>
+                <a:gd name="csY13" fmla="*/ 726067 h 2438401"/>
+                <a:gd name="csX14" fmla="*/ 2162174 w 2438400"/>
+                <a:gd name="csY14" fmla="*/ 726067 h 2438401"/>
+                <a:gd name="csX15" fmla="*/ 2281422 w 2438400"/>
+                <a:gd name="csY15" fmla="*/ 763084 h 2438401"/>
+                <a:gd name="csX16" fmla="*/ 2438400 w 2438400"/>
+                <a:gd name="csY16" fmla="*/ 778909 h 2438401"/>
+                <a:gd name="csX17" fmla="*/ 2438400 w 2438400"/>
+                <a:gd name="csY17" fmla="*/ 1053350 h 2438401"/>
+                <a:gd name="csX18" fmla="*/ 2226113 w 2438400"/>
+                <a:gd name="csY18" fmla="*/ 1031950 h 2438401"/>
+                <a:gd name="csX19" fmla="*/ 2162174 w 2438400"/>
+                <a:gd name="csY19" fmla="*/ 1015509 h 2438401"/>
+                <a:gd name="csX20" fmla="*/ 2162174 w 2438400"/>
+                <a:gd name="csY20" fmla="*/ 1015509 h 2438401"/>
+                <a:gd name="csX21" fmla="*/ 2125165 w 2438400"/>
+                <a:gd name="csY21" fmla="*/ 1005993 h 2438401"/>
+                <a:gd name="csX22" fmla="*/ 1432404 w 2438400"/>
+                <a:gd name="csY22" fmla="*/ 313232 h 2438401"/>
+                <a:gd name="csX23" fmla="*/ 1422888 w 2438400"/>
+                <a:gd name="csY23" fmla="*/ 276225 h 2438401"/>
+                <a:gd name="csX24" fmla="*/ 1422889 w 2438400"/>
+                <a:gd name="csY24" fmla="*/ 276225 h 2438401"/>
+                <a:gd name="csX25" fmla="*/ 1406448 w 2438400"/>
+                <a:gd name="csY25" fmla="*/ 212284 h 2438401"/>
+                <a:gd name="csX26" fmla="*/ 1390486 w 2438400"/>
+                <a:gd name="csY26" fmla="*/ 107696 h 2438401"/>
+                <a:gd name="csX27" fmla="*/ 0 w 2438400"/>
+                <a:gd name="csY27" fmla="*/ 0 h 2438401"/>
+                <a:gd name="csX28" fmla="*/ 1385047 w 2438400"/>
+                <a:gd name="csY28" fmla="*/ 0 h 2438401"/>
+                <a:gd name="csX29" fmla="*/ 1390485 w 2438400"/>
+                <a:gd name="csY29" fmla="*/ 107696 h 2438401"/>
+                <a:gd name="csX30" fmla="*/ 1406447 w 2438400"/>
+                <a:gd name="csY30" fmla="*/ 212284 h 2438401"/>
+                <a:gd name="csX31" fmla="*/ 1422888 w 2438400"/>
+                <a:gd name="csY31" fmla="*/ 276225 h 2438401"/>
+                <a:gd name="csX32" fmla="*/ 0 w 2438400"/>
+                <a:gd name="csY32" fmla="*/ 276225 h 2438401"/>
+              </a:gdLst>
+              <a:ahLst/>
+              <a:cxnLst>
+                <a:cxn ang="0">
+                  <a:pos x="csX0" y="csY0"/>
+                </a:cxn>
+                <a:cxn ang="0">
+                  <a:pos x="csX1" y="csY1"/>
+                </a:cxn>
+                <a:cxn ang="0">
+                  <a:pos x="csX2" y="csY2"/>
+                </a:cxn>
+                <a:cxn ang="0">
+                  <a:pos x="csX3" y="csY3"/>
+                </a:cxn>
+                <a:cxn ang="0">
+                  <a:pos x="csX4" y="csY4"/>
+                </a:cxn>
+                <a:cxn ang="0">
+                  <a:pos x="csX5" y="csY5"/>
+                </a:cxn>
+                <a:cxn ang="0">
+                  <a:pos x="csX6" y="csY6"/>
+                </a:cxn>
+                <a:cxn ang="0">
+                  <a:pos x="csX7" y="csY7"/>
+                </a:cxn>
+                <a:cxn ang="0">
+                  <a:pos x="csX8" y="csY8"/>
+                </a:cxn>
+                <a:cxn ang="0">
+                  <a:pos x="csX9" y="csY9"/>
+                </a:cxn>
+                <a:cxn ang="0">
+                  <a:pos x="csX10" y="csY10"/>
+                </a:cxn>
+                <a:cxn ang="0">
+                  <a:pos x="csX11" y="csY11"/>
+                </a:cxn>
+                <a:cxn ang="0">
+                  <a:pos x="csX12" y="csY12"/>
+                </a:cxn>
+                <a:cxn ang="0">
+                  <a:pos x="csX13" y="csY13"/>
+                </a:cxn>
+                <a:cxn ang="0">
+                  <a:pos x="csX14" y="csY14"/>
+                </a:cxn>
+                <a:cxn ang="0">
+                  <a:pos x="csX15" y="csY15"/>
+                </a:cxn>
+                <a:cxn ang="0">
+                  <a:pos x="csX16" y="csY16"/>
+                </a:cxn>
+                <a:cxn ang="0">
+                  <a:pos x="csX17" y="csY17"/>
+                </a:cxn>
+                <a:cxn ang="0">
+                  <a:pos x="csX18" y="csY18"/>
+                </a:cxn>
+                <a:cxn ang="0">
+                  <a:pos x="csX19" y="csY19"/>
+                </a:cxn>
+                <a:cxn ang="0">
+                  <a:pos x="csX20" y="csY20"/>
+                </a:cxn>
+                <a:cxn ang="0">
+                  <a:pos x="csX21" y="csY21"/>
+                </a:cxn>
+                <a:cxn ang="0">
+                  <a:pos x="csX22" y="csY22"/>
+                </a:cxn>
+                <a:cxn ang="0">
+                  <a:pos x="csX23" y="csY23"/>
+                </a:cxn>
+                <a:cxn ang="0">
+                  <a:pos x="csX24" y="csY24"/>
+                </a:cxn>
+                <a:cxn ang="0">
+                  <a:pos x="csX25" y="csY25"/>
+                </a:cxn>
+                <a:cxn ang="0">
+                  <a:pos x="csX26" y="csY26"/>
+                </a:cxn>
+                <a:cxn ang="0">
+                  <a:pos x="csX27" y="csY27"/>
+                </a:cxn>
+                <a:cxn ang="0">
+                  <a:pos x="csX28" y="csY28"/>
+                </a:cxn>
+                <a:cxn ang="0">
+                  <a:pos x="csX29" y="csY29"/>
+                </a:cxn>
+                <a:cxn ang="0">
+                  <a:pos x="csX30" y="csY30"/>
+                </a:cxn>
+                <a:cxn ang="0">
+                  <a:pos x="csX31" y="csY31"/>
+                </a:cxn>
+                <a:cxn ang="0">
+                  <a:pos x="csX32" y="csY32"/>
+                </a:cxn>
+              </a:cxnLst>
+              <a:rect l="l" t="t" r="r" b="b"/>
+              <a:pathLst>
+                <a:path w="2438400" h="2438401">
+                  <a:moveTo>
+                    <a:pt x="2162174" y="1015509"/>
+                  </a:moveTo>
+                  <a:lnTo>
+                    <a:pt x="2226113" y="1031950"/>
+                  </a:lnTo>
+                  <a:cubicBezTo>
+                    <a:pt x="2294683" y="1045981"/>
+                    <a:pt x="2365681" y="1053350"/>
+                    <a:pt x="2438400" y="1053350"/>
+                  </a:cubicBezTo>
+                  <a:lnTo>
+                    <a:pt x="2438400" y="2438401"/>
+                  </a:lnTo>
+                  <a:lnTo>
+                    <a:pt x="2162174" y="2438401"/>
+                  </a:lnTo>
+                  <a:close/>
+                  <a:moveTo>
+                    <a:pt x="1385048" y="0"/>
+                  </a:moveTo>
+                  <a:lnTo>
+                    <a:pt x="1659489" y="0"/>
+                  </a:lnTo>
+                  <a:lnTo>
+                    <a:pt x="1663510" y="79636"/>
+                  </a:lnTo>
+                  <a:cubicBezTo>
+                    <a:pt x="1666170" y="105821"/>
+                    <a:pt x="1670126" y="131622"/>
+                    <a:pt x="1675314" y="156975"/>
+                  </a:cubicBezTo>
+                  <a:lnTo>
+                    <a:pt x="1712331" y="276225"/>
+                  </a:lnTo>
+                  <a:lnTo>
+                    <a:pt x="1712330" y="276225"/>
+                  </a:lnTo>
+                  <a:lnTo>
+                    <a:pt x="1720699" y="303185"/>
+                  </a:lnTo>
+                  <a:cubicBezTo>
+                    <a:pt x="1799529" y="489560"/>
+                    <a:pt x="1948837" y="638868"/>
+                    <a:pt x="2135212" y="717698"/>
+                  </a:cubicBezTo>
+                  <a:lnTo>
+                    <a:pt x="2162174" y="726067"/>
+                  </a:lnTo>
+                  <a:lnTo>
+                    <a:pt x="2162174" y="726067"/>
+                  </a:lnTo>
+                  <a:lnTo>
+                    <a:pt x="2281422" y="763084"/>
+                  </a:lnTo>
+                  <a:cubicBezTo>
+                    <a:pt x="2332127" y="773460"/>
+                    <a:pt x="2384627" y="778909"/>
+                    <a:pt x="2438400" y="778909"/>
+                  </a:cubicBezTo>
+                  <a:lnTo>
+                    <a:pt x="2438400" y="1053350"/>
+                  </a:lnTo>
+                  <a:cubicBezTo>
+                    <a:pt x="2365681" y="1053350"/>
+                    <a:pt x="2294683" y="1045981"/>
+                    <a:pt x="2226113" y="1031950"/>
+                  </a:cubicBezTo>
+                  <a:lnTo>
+                    <a:pt x="2162174" y="1015509"/>
+                  </a:lnTo>
+                  <a:lnTo>
+                    <a:pt x="2162174" y="1015509"/>
+                  </a:lnTo>
+                  <a:lnTo>
+                    <a:pt x="2125165" y="1005993"/>
+                  </a:lnTo>
+                  <a:cubicBezTo>
+                    <a:pt x="1795329" y="903404"/>
+                    <a:pt x="1534993" y="643068"/>
+                    <a:pt x="1432404" y="313232"/>
+                  </a:cubicBezTo>
+                  <a:lnTo>
+                    <a:pt x="1422888" y="276225"/>
+                  </a:lnTo>
+                  <a:lnTo>
+                    <a:pt x="1422889" y="276225"/>
+                  </a:lnTo>
+                  <a:lnTo>
+                    <a:pt x="1406448" y="212284"/>
+                  </a:lnTo>
+                  <a:cubicBezTo>
+                    <a:pt x="1399433" y="177999"/>
+                    <a:pt x="1394082" y="143107"/>
+                    <a:pt x="1390486" y="107696"/>
+                  </a:cubicBezTo>
+                  <a:close/>
+                  <a:moveTo>
+                    <a:pt x="0" y="0"/>
+                  </a:moveTo>
+                  <a:lnTo>
+                    <a:pt x="1385047" y="0"/>
+                  </a:lnTo>
+                  <a:lnTo>
+                    <a:pt x="1390485" y="107696"/>
+                  </a:lnTo>
+                  <a:cubicBezTo>
+                    <a:pt x="1394081" y="143107"/>
+                    <a:pt x="1399432" y="177999"/>
+                    <a:pt x="1406447" y="212284"/>
+                  </a:cubicBezTo>
+                  <a:lnTo>
+                    <a:pt x="1422888" y="276225"/>
+                  </a:lnTo>
+                  <a:lnTo>
+                    <a:pt x="0" y="276225"/>
+                  </a:lnTo>
+                  <a:close/>
+                </a:path>
+              </a:pathLst>
+            </a:custGeom>
+            <a:grpFill/>
+            <a:ln>
+              <a:noFill/>
+            </a:ln>
+          </p:spPr>
+          <p:style>
+            <a:lnRef idx="2">
+              <a:schemeClr val="accent1">
+                <a:shade val="15000"/>
+              </a:schemeClr>
+            </a:lnRef>
+            <a:fillRef idx="1">
+              <a:schemeClr val="accent1"/>
+            </a:fillRef>
+            <a:effectRef idx="0">
+              <a:schemeClr val="accent1"/>
+            </a:effectRef>
+            <a:fontRef idx="minor">
+              <a:schemeClr val="lt1"/>
+            </a:fontRef>
+          </p:style>
+          <p:txBody>
+            <a:bodyPr wrap="square" rtlCol="0" anchor="ctr">
+              <a:noAutofit/>
+            </a:bodyPr>
+            <a:lstStyle/>
+            <a:p>
+              <a:pPr algn="ctr"/>
+              <a:endParaRPr lang="ko-KR" altLang="en-US"/>
+            </a:p>
+          </p:txBody>
+        </p:sp>
+        <p:sp>
+          <p:nvSpPr>
+            <p:cNvPr id="30" name="Freeform: Shape 29">
+              <a:extLst>
+                <a:ext uri="{FF2B5EF4-FFF2-40B4-BE49-F238E27FC236}">
+                  <a16:creationId xmlns:a16="http://schemas.microsoft.com/office/drawing/2014/main" id="{B9257E55-990A-DF82-E3A6-521F2B7E0371}"/>
+                </a:ext>
+              </a:extLst>
+            </p:cNvPr>
+            <p:cNvSpPr/>
+            <p:nvPr/>
+          </p:nvSpPr>
+          <p:spPr>
+            <a:xfrm rot="16200000">
+              <a:off x="4876800" y="0"/>
+              <a:ext cx="2438400" cy="2438401"/>
+            </a:xfrm>
+            <a:custGeom>
+              <a:avLst/>
+              <a:gdLst>
+                <a:gd name="csX0" fmla="*/ 2162174 w 2438400"/>
+                <a:gd name="csY0" fmla="*/ 1015509 h 2438401"/>
+                <a:gd name="csX1" fmla="*/ 2226113 w 2438400"/>
+                <a:gd name="csY1" fmla="*/ 1031950 h 2438401"/>
+                <a:gd name="csX2" fmla="*/ 2438400 w 2438400"/>
+                <a:gd name="csY2" fmla="*/ 1053350 h 2438401"/>
+                <a:gd name="csX3" fmla="*/ 2438400 w 2438400"/>
+                <a:gd name="csY3" fmla="*/ 2438401 h 2438401"/>
+                <a:gd name="csX4" fmla="*/ 2162174 w 2438400"/>
+                <a:gd name="csY4" fmla="*/ 2438401 h 2438401"/>
+                <a:gd name="csX5" fmla="*/ 1385048 w 2438400"/>
+                <a:gd name="csY5" fmla="*/ 0 h 2438401"/>
+                <a:gd name="csX6" fmla="*/ 1659489 w 2438400"/>
+                <a:gd name="csY6" fmla="*/ 0 h 2438401"/>
+                <a:gd name="csX7" fmla="*/ 1663510 w 2438400"/>
+                <a:gd name="csY7" fmla="*/ 79636 h 2438401"/>
+                <a:gd name="csX8" fmla="*/ 1675314 w 2438400"/>
+                <a:gd name="csY8" fmla="*/ 156975 h 2438401"/>
+                <a:gd name="csX9" fmla="*/ 1712331 w 2438400"/>
+                <a:gd name="csY9" fmla="*/ 276225 h 2438401"/>
+                <a:gd name="csX10" fmla="*/ 1712330 w 2438400"/>
+                <a:gd name="csY10" fmla="*/ 276225 h 2438401"/>
+                <a:gd name="csX11" fmla="*/ 1720699 w 2438400"/>
+                <a:gd name="csY11" fmla="*/ 303185 h 2438401"/>
+                <a:gd name="csX12" fmla="*/ 2135212 w 2438400"/>
+                <a:gd name="csY12" fmla="*/ 717698 h 2438401"/>
+                <a:gd name="csX13" fmla="*/ 2162174 w 2438400"/>
+                <a:gd name="csY13" fmla="*/ 726067 h 2438401"/>
+                <a:gd name="csX14" fmla="*/ 2162174 w 2438400"/>
+                <a:gd name="csY14" fmla="*/ 726067 h 2438401"/>
+                <a:gd name="csX15" fmla="*/ 2281422 w 2438400"/>
+                <a:gd name="csY15" fmla="*/ 763084 h 2438401"/>
+                <a:gd name="csX16" fmla="*/ 2438400 w 2438400"/>
+                <a:gd name="csY16" fmla="*/ 778909 h 2438401"/>
+                <a:gd name="csX17" fmla="*/ 2438400 w 2438400"/>
+                <a:gd name="csY17" fmla="*/ 1053350 h 2438401"/>
+                <a:gd name="csX18" fmla="*/ 2226113 w 2438400"/>
+                <a:gd name="csY18" fmla="*/ 1031950 h 2438401"/>
+                <a:gd name="csX19" fmla="*/ 2162174 w 2438400"/>
+                <a:gd name="csY19" fmla="*/ 1015509 h 2438401"/>
+                <a:gd name="csX20" fmla="*/ 2162174 w 2438400"/>
+                <a:gd name="csY20" fmla="*/ 1015509 h 2438401"/>
+                <a:gd name="csX21" fmla="*/ 2125165 w 2438400"/>
+                <a:gd name="csY21" fmla="*/ 1005993 h 2438401"/>
+                <a:gd name="csX22" fmla="*/ 1432404 w 2438400"/>
+                <a:gd name="csY22" fmla="*/ 313232 h 2438401"/>
+                <a:gd name="csX23" fmla="*/ 1422888 w 2438400"/>
+                <a:gd name="csY23" fmla="*/ 276225 h 2438401"/>
+                <a:gd name="csX24" fmla="*/ 1422889 w 2438400"/>
+                <a:gd name="csY24" fmla="*/ 276225 h 2438401"/>
+                <a:gd name="csX25" fmla="*/ 1406448 w 2438400"/>
+                <a:gd name="csY25" fmla="*/ 212284 h 2438401"/>
+                <a:gd name="csX26" fmla="*/ 1390486 w 2438400"/>
+                <a:gd name="csY26" fmla="*/ 107696 h 2438401"/>
+                <a:gd name="csX27" fmla="*/ 0 w 2438400"/>
+                <a:gd name="csY27" fmla="*/ 0 h 2438401"/>
+                <a:gd name="csX28" fmla="*/ 1385047 w 2438400"/>
+                <a:gd name="csY28" fmla="*/ 0 h 2438401"/>
+                <a:gd name="csX29" fmla="*/ 1390485 w 2438400"/>
+                <a:gd name="csY29" fmla="*/ 107696 h 2438401"/>
+                <a:gd name="csX30" fmla="*/ 1406447 w 2438400"/>
+                <a:gd name="csY30" fmla="*/ 212284 h 2438401"/>
+                <a:gd name="csX31" fmla="*/ 1422888 w 2438400"/>
+                <a:gd name="csY31" fmla="*/ 276225 h 2438401"/>
+                <a:gd name="csX32" fmla="*/ 0 w 2438400"/>
+                <a:gd name="csY32" fmla="*/ 276225 h 2438401"/>
+              </a:gdLst>
+              <a:ahLst/>
+              <a:cxnLst>
+                <a:cxn ang="0">
+                  <a:pos x="csX0" y="csY0"/>
+                </a:cxn>
+                <a:cxn ang="0">
+                  <a:pos x="csX1" y="csY1"/>
+                </a:cxn>
+                <a:cxn ang="0">
+                  <a:pos x="csX2" y="csY2"/>
+                </a:cxn>
+                <a:cxn ang="0">
+                  <a:pos x="csX3" y="csY3"/>
+                </a:cxn>
+                <a:cxn ang="0">
+                  <a:pos x="csX4" y="csY4"/>
+                </a:cxn>
+                <a:cxn ang="0">
+                  <a:pos x="csX5" y="csY5"/>
+                </a:cxn>
+                <a:cxn ang="0">
+                  <a:pos x="csX6" y="csY6"/>
+                </a:cxn>
+                <a:cxn ang="0">
+                  <a:pos x="csX7" y="csY7"/>
+                </a:cxn>
+                <a:cxn ang="0">
+                  <a:pos x="csX8" y="csY8"/>
+                </a:cxn>
+                <a:cxn ang="0">
+                  <a:pos x="csX9" y="csY9"/>
+                </a:cxn>
+                <a:cxn ang="0">
+                  <a:pos x="csX10" y="csY10"/>
+                </a:cxn>
+                <a:cxn ang="0">
+                  <a:pos x="csX11" y="csY11"/>
+                </a:cxn>
+                <a:cxn ang="0">
+                  <a:pos x="csX12" y="csY12"/>
+                </a:cxn>
+                <a:cxn ang="0">
+                  <a:pos x="csX13" y="csY13"/>
+                </a:cxn>
+                <a:cxn ang="0">
+                  <a:pos x="csX14" y="csY14"/>
+                </a:cxn>
+                <a:cxn ang="0">
+                  <a:pos x="csX15" y="csY15"/>
+                </a:cxn>
+                <a:cxn ang="0">
+                  <a:pos x="csX16" y="csY16"/>
+                </a:cxn>
+                <a:cxn ang="0">
+                  <a:pos x="csX17" y="csY17"/>
+                </a:cxn>
+                <a:cxn ang="0">
+                  <a:pos x="csX18" y="csY18"/>
+                </a:cxn>
+                <a:cxn ang="0">
+                  <a:pos x="csX19" y="csY19"/>
+                </a:cxn>
+                <a:cxn ang="0">
+                  <a:pos x="csX20" y="csY20"/>
+                </a:cxn>
+                <a:cxn ang="0">
+                  <a:pos x="csX21" y="csY21"/>
+                </a:cxn>
+                <a:cxn ang="0">
+                  <a:pos x="csX22" y="csY22"/>
+                </a:cxn>
+                <a:cxn ang="0">
+                  <a:pos x="csX23" y="csY23"/>
+                </a:cxn>
+                <a:cxn ang="0">
+                  <a:pos x="csX24" y="csY24"/>
+                </a:cxn>
+                <a:cxn ang="0">
+                  <a:pos x="csX25" y="csY25"/>
+                </a:cxn>
+                <a:cxn ang="0">
+                  <a:pos x="csX26" y="csY26"/>
+                </a:cxn>
+                <a:cxn ang="0">
+                  <a:pos x="csX27" y="csY27"/>
+                </a:cxn>
+                <a:cxn ang="0">
+                  <a:pos x="csX28" y="csY28"/>
+                </a:cxn>
+                <a:cxn ang="0">
+                  <a:pos x="csX29" y="csY29"/>
+                </a:cxn>
+                <a:cxn ang="0">
+                  <a:pos x="csX30" y="csY30"/>
+                </a:cxn>
+                <a:cxn ang="0">
+                  <a:pos x="csX31" y="csY31"/>
+                </a:cxn>
+                <a:cxn ang="0">
+                  <a:pos x="csX32" y="csY32"/>
+                </a:cxn>
+              </a:cxnLst>
+              <a:rect l="l" t="t" r="r" b="b"/>
+              <a:pathLst>
+                <a:path w="2438400" h="2438401">
+                  <a:moveTo>
+                    <a:pt x="2162174" y="1015509"/>
+                  </a:moveTo>
+                  <a:lnTo>
+                    <a:pt x="2226113" y="1031950"/>
+                  </a:lnTo>
+                  <a:cubicBezTo>
+                    <a:pt x="2294683" y="1045981"/>
+                    <a:pt x="2365681" y="1053350"/>
+                    <a:pt x="2438400" y="1053350"/>
+                  </a:cubicBezTo>
+                  <a:lnTo>
+                    <a:pt x="2438400" y="2438401"/>
+                  </a:lnTo>
+                  <a:lnTo>
+                    <a:pt x="2162174" y="2438401"/>
+                  </a:lnTo>
+                  <a:close/>
+                  <a:moveTo>
+                    <a:pt x="1385048" y="0"/>
+                  </a:moveTo>
+                  <a:lnTo>
+                    <a:pt x="1659489" y="0"/>
+                  </a:lnTo>
+                  <a:lnTo>
+                    <a:pt x="1663510" y="79636"/>
+                  </a:lnTo>
+                  <a:cubicBezTo>
+                    <a:pt x="1666170" y="105821"/>
+                    <a:pt x="1670126" y="131622"/>
+                    <a:pt x="1675314" y="156975"/>
+                  </a:cubicBezTo>
+                  <a:lnTo>
+                    <a:pt x="1712331" y="276225"/>
+                  </a:lnTo>
+                  <a:lnTo>
+                    <a:pt x="1712330" y="276225"/>
+                  </a:lnTo>
+                  <a:lnTo>
+                    <a:pt x="1720699" y="303185"/>
+                  </a:lnTo>
+                  <a:cubicBezTo>
+                    <a:pt x="1799529" y="489560"/>
+                    <a:pt x="1948837" y="638868"/>
+                    <a:pt x="2135212" y="717698"/>
+                  </a:cubicBezTo>
+                  <a:lnTo>
+                    <a:pt x="2162174" y="726067"/>
+                  </a:lnTo>
+                  <a:lnTo>
+                    <a:pt x="2162174" y="726067"/>
+                  </a:lnTo>
+                  <a:lnTo>
+                    <a:pt x="2281422" y="763084"/>
+                  </a:lnTo>
+                  <a:cubicBezTo>
+                    <a:pt x="2332127" y="773460"/>
+                    <a:pt x="2384627" y="778909"/>
+                    <a:pt x="2438400" y="778909"/>
+                  </a:cubicBezTo>
+                  <a:lnTo>
+                    <a:pt x="2438400" y="1053350"/>
+                  </a:lnTo>
+                  <a:cubicBezTo>
+                    <a:pt x="2365681" y="1053350"/>
+                    <a:pt x="2294683" y="1045981"/>
+                    <a:pt x="2226113" y="1031950"/>
+                  </a:cubicBezTo>
+                  <a:lnTo>
+                    <a:pt x="2162174" y="1015509"/>
+                  </a:lnTo>
+                  <a:lnTo>
+                    <a:pt x="2162174" y="1015509"/>
+                  </a:lnTo>
+                  <a:lnTo>
+                    <a:pt x="2125165" y="1005993"/>
+                  </a:lnTo>
+                  <a:cubicBezTo>
+                    <a:pt x="1795329" y="903404"/>
+                    <a:pt x="1534993" y="643068"/>
+                    <a:pt x="1432404" y="313232"/>
+                  </a:cubicBezTo>
+                  <a:lnTo>
+                    <a:pt x="1422888" y="276225"/>
+                  </a:lnTo>
+                  <a:lnTo>
+                    <a:pt x="1422889" y="276225"/>
+                  </a:lnTo>
+                  <a:lnTo>
+                    <a:pt x="1406448" y="212284"/>
+                  </a:lnTo>
+                  <a:cubicBezTo>
+                    <a:pt x="1399433" y="177999"/>
+                    <a:pt x="1394082" y="143107"/>
+                    <a:pt x="1390486" y="107696"/>
+                  </a:cubicBezTo>
+                  <a:close/>
+                  <a:moveTo>
+                    <a:pt x="0" y="0"/>
+                  </a:moveTo>
+                  <a:lnTo>
+                    <a:pt x="1385047" y="0"/>
+                  </a:lnTo>
+                  <a:lnTo>
+                    <a:pt x="1390485" y="107696"/>
+                  </a:lnTo>
+                  <a:cubicBezTo>
+                    <a:pt x="1394081" y="143107"/>
+                    <a:pt x="1399432" y="177999"/>
+                    <a:pt x="1406447" y="212284"/>
+                  </a:cubicBezTo>
+                  <a:lnTo>
+                    <a:pt x="1422888" y="276225"/>
+                  </a:lnTo>
+                  <a:lnTo>
+                    <a:pt x="0" y="276225"/>
+                  </a:lnTo>
+                  <a:close/>
+                </a:path>
+              </a:pathLst>
+            </a:custGeom>
+            <a:grpFill/>
+            <a:ln>
+              <a:noFill/>
+            </a:ln>
+          </p:spPr>
+          <p:style>
+            <a:lnRef idx="2">
+              <a:schemeClr val="accent1">
+                <a:shade val="15000"/>
+              </a:schemeClr>
+            </a:lnRef>
+            <a:fillRef idx="1">
+              <a:schemeClr val="accent1"/>
+            </a:fillRef>
+            <a:effectRef idx="0">
+              <a:schemeClr val="accent1"/>
+            </a:effectRef>
+            <a:fontRef idx="minor">
+              <a:schemeClr val="lt1"/>
+            </a:fontRef>
+          </p:style>
+          <p:txBody>
+            <a:bodyPr wrap="square" rtlCol="0" anchor="ctr">
+              <a:noAutofit/>
+            </a:bodyPr>
+            <a:lstStyle/>
+            <a:p>
+              <a:pPr algn="ctr"/>
+              <a:endParaRPr lang="ko-KR" altLang="en-US"/>
+            </a:p>
+          </p:txBody>
+        </p:sp>
+      </p:grpSp>
+      <p:sp>
+        <p:nvSpPr>
+          <p:cNvPr id="3" name="Rectangle 2">
+            <a:extLst>
+              <a:ext uri="{FF2B5EF4-FFF2-40B4-BE49-F238E27FC236}">
+                <a16:creationId xmlns:a16="http://schemas.microsoft.com/office/drawing/2014/main" id="{EDAFC0B2-1987-CD97-9F8E-ECEC13F6C2C3}"/>
+              </a:ext>
+            </a:extLst>
+          </p:cNvPr>
+          <p:cNvSpPr/>
+          <p:nvPr/>
+        </p:nvSpPr>
+        <p:spPr>
+          <a:xfrm>
+            <a:off x="-1" y="4876800"/>
+            <a:ext cx="4876800" cy="4876800"/>
+          </a:xfrm>
+          <a:prstGeom prst="rect">
+            <a:avLst/>
+          </a:prstGeom>
+          <a:gradFill>
+            <a:gsLst>
+              <a:gs pos="0">
+                <a:schemeClr val="accent1">
+                  <a:lumMod val="5000"/>
+                  <a:lumOff val="95000"/>
+                </a:schemeClr>
+              </a:gs>
+              <a:gs pos="100000">
+                <a:schemeClr val="tx1">
+                  <a:alpha val="0"/>
+                </a:schemeClr>
+              </a:gs>
+            </a:gsLst>
+            <a:lin ang="5400000" scaled="1"/>
+          </a:gradFill>
+          <a:ln>
+            <a:noFill/>
+          </a:ln>
+        </p:spPr>
+        <p:style>
+          <a:lnRef idx="2">
+            <a:schemeClr val="accent1">
+              <a:shade val="15000"/>
+            </a:schemeClr>
+          </a:lnRef>
+          <a:fillRef idx="1">
+            <a:schemeClr val="accent1"/>
+          </a:fillRef>
+          <a:effectRef idx="0">
+            <a:schemeClr val="accent1"/>
+          </a:effectRef>
+          <a:fontRef idx="minor">
+            <a:schemeClr val="lt1"/>
+          </a:fontRef>
+        </p:style>
+        <p:txBody>
+          <a:bodyPr rtlCol="0" anchor="ctr"/>
+          <a:lstStyle/>
+          <a:p>
+            <a:pPr algn="ctr"/>
+            <a:endParaRPr lang="ko-KR" altLang="en-US"/>
+          </a:p>
+        </p:txBody>
+      </p:sp>
+      <p:sp>
+        <p:nvSpPr>
+          <p:cNvPr id="6" name="Rectangle 5">
+            <a:extLst>
+              <a:ext uri="{FF2B5EF4-FFF2-40B4-BE49-F238E27FC236}">
+                <a16:creationId xmlns:a16="http://schemas.microsoft.com/office/drawing/2014/main" id="{13F2FFF7-D666-36AC-2E9D-B53E0171ABC9}"/>
+              </a:ext>
+            </a:extLst>
+          </p:cNvPr>
+          <p:cNvSpPr/>
+          <p:nvPr/>
+        </p:nvSpPr>
+        <p:spPr>
+          <a:xfrm rot="5400000">
+            <a:off x="4876799" y="4876800"/>
+            <a:ext cx="4876800" cy="4876800"/>
+          </a:xfrm>
+          <a:prstGeom prst="rect">
+            <a:avLst/>
+          </a:prstGeom>
+          <a:gradFill>
+            <a:gsLst>
+              <a:gs pos="0">
+                <a:schemeClr val="accent1">
+                  <a:lumMod val="5000"/>
+                  <a:lumOff val="95000"/>
+                </a:schemeClr>
+              </a:gs>
+              <a:gs pos="100000">
+                <a:schemeClr val="tx1">
+                  <a:alpha val="0"/>
+                </a:schemeClr>
+              </a:gs>
+            </a:gsLst>
+            <a:lin ang="5400000" scaled="1"/>
+          </a:gradFill>
+          <a:ln>
+            <a:noFill/>
+          </a:ln>
+        </p:spPr>
+        <p:style>
+          <a:lnRef idx="2">
+            <a:schemeClr val="accent1">
+              <a:shade val="15000"/>
+            </a:schemeClr>
+          </a:lnRef>
+          <a:fillRef idx="1">
+            <a:schemeClr val="accent1"/>
+          </a:fillRef>
+          <a:effectRef idx="0">
+            <a:schemeClr val="accent1"/>
+          </a:effectRef>
+          <a:fontRef idx="minor">
+            <a:schemeClr val="lt1"/>
+          </a:fontRef>
+        </p:style>
+        <p:txBody>
+          <a:bodyPr rtlCol="0" anchor="ctr"/>
+          <a:lstStyle/>
+          <a:p>
+            <a:pPr algn="ctr"/>
+            <a:endParaRPr lang="ko-KR" altLang="en-US"/>
+          </a:p>
+        </p:txBody>
+      </p:sp>
+    </p:spTree>
+    <p:extLst>
+      <p:ext uri="{BB962C8B-B14F-4D97-AF65-F5344CB8AC3E}">
+        <p14:creationId xmlns:p14="http://schemas.microsoft.com/office/powerpoint/2010/main" val="802462154"/>
+      </p:ext>
+    </p:extLst>
+  </p:cSld>
+  <p:clrMapOvr>
+    <a:masterClrMapping/>
+  </p:clrMapOvr>
+</p:sld>
+</file>
+
 <file path=ppt/theme/theme1.xml><?xml version="1.0" encoding="utf-8"?>
 <a:theme xmlns:a="http://schemas.openxmlformats.org/drawingml/2006/main" name="Office Theme">
   <a:themeElements>
-    <a:clrScheme name="Office Theme">
+    <a:clrScheme name="Custom 1">
       <a:dk1>
         <a:sysClr val="windowText" lastClr="000000"/>
       </a:dk1>
@@ -3238,34 +4945,34 @@
         <a:sysClr val="window" lastClr="FFFFFF"/>
       </a:lt1>
       <a:dk2>
-        <a:srgbClr val="0E2841"/>
+        <a:srgbClr val="10013F"/>
       </a:dk2>
       <a:lt2>
-        <a:srgbClr val="E8E8E8"/>
+        <a:srgbClr val="F2F0FF"/>
       </a:lt2>
       <a:accent1>
-        <a:srgbClr val="156082"/>
+        <a:srgbClr val="CEB17E"/>
       </a:accent1>
       <a:accent2>
-        <a:srgbClr val="E97132"/>
+        <a:srgbClr val="4D6ED7"/>
       </a:accent2>
       <a:accent3>
-        <a:srgbClr val="196B24"/>
+        <a:srgbClr val="D24646"/>
       </a:accent3>
       <a:accent4>
-        <a:srgbClr val="0F9ED5"/>
+        <a:srgbClr val="5CC670"/>
       </a:accent4>
       <a:accent5>
-        <a:srgbClr val="A02B93"/>
+        <a:srgbClr val="6E97B0"/>
       </a:accent5>
       <a:accent6>
-        <a:srgbClr val="4EA72E"/>
+        <a:srgbClr val="F5ADC8"/>
       </a:accent6>
       <a:hlink>
-        <a:srgbClr val="467886"/>
+        <a:srgbClr val="0563C1"/>
       </a:hlink>
       <a:folHlink>
-        <a:srgbClr val="96607D"/>
+        <a:srgbClr val="954F72"/>
       </a:folHlink>
     </a:clrScheme>
     <a:fontScheme name="Office Theme">

</xml_diff>

<commit_message>
Added BG Highlights and Catch breath appearance condition
</commit_message>
<xml_diff>
--- a/Assets/Sprites/rockin_rackin_Logo.pptx
+++ b/Assets/Sprites/rockin_rackin_Logo.pptx
@@ -2977,10 +2977,10 @@
       </p:grpSpPr>
       <p:grpSp>
         <p:nvGrpSpPr>
-          <p:cNvPr id="11" name="Group 10">
+          <p:cNvPr id="29" name="Group 28">
             <a:extLst>
               <a:ext uri="{FF2B5EF4-FFF2-40B4-BE49-F238E27FC236}">
-                <a16:creationId xmlns:a16="http://schemas.microsoft.com/office/drawing/2014/main" id="{E5E79948-C4DB-7076-9689-DE618D6C564E}"/>
+                <a16:creationId xmlns:a16="http://schemas.microsoft.com/office/drawing/2014/main" id="{C685B1BA-7B98-B725-E8D1-BA365DBD0206}"/>
               </a:ext>
             </a:extLst>
           </p:cNvPr>
@@ -2989,50 +2989,83 @@
         </p:nvGrpSpPr>
         <p:grpSpPr>
           <a:xfrm>
-            <a:off x="1362634" y="3034798"/>
-            <a:ext cx="7028330" cy="4424340"/>
-            <a:chOff x="1362634" y="3034798"/>
-            <a:chExt cx="7028330" cy="4424340"/>
+            <a:off x="1288268" y="2909048"/>
+            <a:ext cx="7177061" cy="3935504"/>
+            <a:chOff x="1288268" y="2909048"/>
+            <a:chExt cx="7177061" cy="3935504"/>
           </a:xfrm>
         </p:grpSpPr>
-        <p:sp>
-          <p:nvSpPr>
-            <p:cNvPr id="4" name="TextBox 3">
+        <p:grpSp>
+          <p:nvGrpSpPr>
+            <p:cNvPr id="11" name="Group 10">
               <a:extLst>
                 <a:ext uri="{FF2B5EF4-FFF2-40B4-BE49-F238E27FC236}">
-                  <a16:creationId xmlns:a16="http://schemas.microsoft.com/office/drawing/2014/main" id="{067CD1CB-CCB6-FDCF-FD63-A6445651DD1E}"/>
+                  <a16:creationId xmlns:a16="http://schemas.microsoft.com/office/drawing/2014/main" id="{E5E79948-C4DB-7076-9689-DE618D6C564E}"/>
                 </a:ext>
               </a:extLst>
             </p:cNvPr>
-            <p:cNvSpPr txBox="1"/>
+            <p:cNvGrpSpPr/>
             <p:nvPr/>
-          </p:nvSpPr>
-          <p:spPr>
-            <a:xfrm>
-              <a:off x="1362634" y="3582148"/>
-              <a:ext cx="7028330" cy="1664820"/>
+          </p:nvGrpSpPr>
+          <p:grpSpPr>
+            <a:xfrm rot="20956873">
+              <a:off x="1362634" y="3211980"/>
+              <a:ext cx="7028330" cy="3329640"/>
+              <a:chOff x="1362634" y="3582148"/>
+              <a:chExt cx="7028330" cy="3329640"/>
             </a:xfrm>
-            <a:prstGeom prst="rect">
-              <a:avLst/>
-            </a:prstGeom>
-            <a:noFill/>
-            <a:scene3d>
-              <a:camera prst="perspectiveRight" fov="6000000">
-                <a:rot lat="0" lon="19499991" rev="21299994"/>
-              </a:camera>
-              <a:lightRig rig="balanced" dir="t"/>
-            </a:scene3d>
-            <a:sp3d prstMaterial="matte"/>
-          </p:spPr>
-          <p:txBody>
-            <a:bodyPr wrap="none" rtlCol="0" anchor="ctr">
-              <a:noAutofit/>
-            </a:bodyPr>
-            <a:lstStyle/>
-            <a:p>
-              <a:pPr algn="r"/>
-              <a:r>
-                <a:rPr lang="en-US" altLang="ko-KR" sz="14400" b="1" dirty="0" err="1">
+          </p:grpSpPr>
+          <p:sp>
+            <p:nvSpPr>
+              <p:cNvPr id="4" name="TextBox 3">
+                <a:extLst>
+                  <a:ext uri="{FF2B5EF4-FFF2-40B4-BE49-F238E27FC236}">
+                    <a16:creationId xmlns:a16="http://schemas.microsoft.com/office/drawing/2014/main" id="{067CD1CB-CCB6-FDCF-FD63-A6445651DD1E}"/>
+                  </a:ext>
+                </a:extLst>
+              </p:cNvPr>
+              <p:cNvSpPr txBox="1"/>
+              <p:nvPr/>
+            </p:nvSpPr>
+            <p:spPr>
+              <a:xfrm>
+                <a:off x="1362634" y="3582148"/>
+                <a:ext cx="7028330" cy="1664820"/>
+              </a:xfrm>
+              <a:prstGeom prst="rect">
+                <a:avLst/>
+              </a:prstGeom>
+              <a:noFill/>
+              <a:scene3d>
+                <a:camera prst="perspectiveRight" fov="6000000">
+                  <a:rot lat="0" lon="19499991" rev="21299994"/>
+                </a:camera>
+                <a:lightRig rig="balanced" dir="t"/>
+              </a:scene3d>
+              <a:sp3d prstMaterial="matte"/>
+            </p:spPr>
+            <p:txBody>
+              <a:bodyPr wrap="none" rtlCol="0" anchor="ctr">
+                <a:noAutofit/>
+              </a:bodyPr>
+              <a:lstStyle/>
+              <a:p>
+                <a:pPr algn="r"/>
+                <a:r>
+                  <a:rPr lang="en-US" altLang="ko-KR" sz="14400" b="1" dirty="0" err="1">
+                    <a:ln w="50800">
+                      <a:solidFill>
+                        <a:schemeClr val="tx1"/>
+                      </a:solidFill>
+                    </a:ln>
+                    <a:noFill/>
+                    <a:latin typeface="Pretendard" panose="02000503000000020004" pitchFamily="50" charset="-127"/>
+                    <a:ea typeface="Pretendard" panose="02000503000000020004" pitchFamily="50" charset="-127"/>
+                    <a:cs typeface="Pretendard" panose="02000503000000020004" pitchFamily="50" charset="-127"/>
+                  </a:rPr>
+                  <a:t>Rockin</a:t>
+                </a:r>
+                <a:endParaRPr lang="ko-KR" altLang="en-US" sz="14400" b="1" dirty="0">
                   <a:ln w="50800">
                     <a:solidFill>
                       <a:schemeClr val="tx1"/>
@@ -3042,86 +3075,2427 @@
                   <a:latin typeface="Pretendard" panose="02000503000000020004" pitchFamily="50" charset="-127"/>
                   <a:ea typeface="Pretendard" panose="02000503000000020004" pitchFamily="50" charset="-127"/>
                   <a:cs typeface="Pretendard" panose="02000503000000020004" pitchFamily="50" charset="-127"/>
-                </a:rPr>
-                <a:t>Rockin</a:t>
-              </a:r>
-              <a:endParaRPr lang="ko-KR" altLang="en-US" sz="14400" b="1" dirty="0">
-                <a:ln w="50800">
-                  <a:solidFill>
-                    <a:schemeClr val="tx1"/>
-                  </a:solidFill>
-                </a:ln>
-                <a:noFill/>
-                <a:latin typeface="Pretendard" panose="02000503000000020004" pitchFamily="50" charset="-127"/>
-                <a:ea typeface="Pretendard" panose="02000503000000020004" pitchFamily="50" charset="-127"/>
-                <a:cs typeface="Pretendard" panose="02000503000000020004" pitchFamily="50" charset="-127"/>
-              </a:endParaRPr>
-            </a:p>
-          </p:txBody>
-        </p:sp>
-        <p:sp>
-          <p:nvSpPr>
-            <p:cNvPr id="6" name="TextBox 5">
-              <a:extLst>
-                <a:ext uri="{FF2B5EF4-FFF2-40B4-BE49-F238E27FC236}">
-                  <a16:creationId xmlns:a16="http://schemas.microsoft.com/office/drawing/2014/main" id="{DB3622E9-6BB4-C120-6B85-CBB70D8EC406}"/>
-                </a:ext>
-              </a:extLst>
-            </p:cNvPr>
-            <p:cNvSpPr txBox="1"/>
-            <p:nvPr/>
-          </p:nvSpPr>
-          <p:spPr>
-            <a:xfrm>
-              <a:off x="1362634" y="5246968"/>
-              <a:ext cx="7028330" cy="1664820"/>
-            </a:xfrm>
-            <a:prstGeom prst="rect">
-              <a:avLst/>
-            </a:prstGeom>
-            <a:noFill/>
-            <a:scene3d>
-              <a:camera prst="perspectiveRight" fov="6000000">
-                <a:rot lat="0" lon="2100000" rev="21299999"/>
-              </a:camera>
-              <a:lightRig rig="balanced" dir="t"/>
-            </a:scene3d>
-            <a:sp3d prstMaterial="matte"/>
-          </p:spPr>
-          <p:txBody>
-            <a:bodyPr wrap="none" rtlCol="0" anchor="ctr">
-              <a:noAutofit/>
-            </a:bodyPr>
-            <a:lstStyle/>
-            <a:p>
-              <a:r>
-                <a:rPr lang="en-US" altLang="ko-KR" sz="14400" b="1" dirty="0" err="1">
+                </a:endParaRPr>
+              </a:p>
+            </p:txBody>
+          </p:sp>
+          <p:sp>
+            <p:nvSpPr>
+              <p:cNvPr id="6" name="TextBox 5">
+                <a:extLst>
+                  <a:ext uri="{FF2B5EF4-FFF2-40B4-BE49-F238E27FC236}">
+                    <a16:creationId xmlns:a16="http://schemas.microsoft.com/office/drawing/2014/main" id="{DB3622E9-6BB4-C120-6B85-CBB70D8EC406}"/>
+                  </a:ext>
+                </a:extLst>
+              </p:cNvPr>
+              <p:cNvSpPr txBox="1"/>
+              <p:nvPr/>
+            </p:nvSpPr>
+            <p:spPr>
+              <a:xfrm>
+                <a:off x="1362634" y="5246968"/>
+                <a:ext cx="7028330" cy="1664820"/>
+              </a:xfrm>
+              <a:prstGeom prst="rect">
+                <a:avLst/>
+              </a:prstGeom>
+              <a:noFill/>
+              <a:scene3d>
+                <a:camera prst="perspectiveRight" fov="6000000">
+                  <a:rot lat="0" lon="2100000" rev="21299999"/>
+                </a:camera>
+                <a:lightRig rig="balanced" dir="t"/>
+              </a:scene3d>
+              <a:sp3d prstMaterial="matte"/>
+            </p:spPr>
+            <p:txBody>
+              <a:bodyPr wrap="none" rtlCol="0" anchor="ctr">
+                <a:noAutofit/>
+              </a:bodyPr>
+              <a:lstStyle/>
+              <a:p>
+                <a:r>
+                  <a:rPr lang="en-US" altLang="ko-KR" sz="14400" b="1" dirty="0" err="1">
+                    <a:ln w="50800">
+                      <a:noFill/>
+                    </a:ln>
+                    <a:latin typeface="Pretendard" panose="02000503000000020004" pitchFamily="50" charset="-127"/>
+                    <a:ea typeface="Pretendard" panose="02000503000000020004" pitchFamily="50" charset="-127"/>
+                    <a:cs typeface="Pretendard" panose="02000503000000020004" pitchFamily="50" charset="-127"/>
+                  </a:rPr>
+                  <a:t>Rackin</a:t>
+                </a:r>
+                <a:endParaRPr lang="ko-KR" altLang="en-US" sz="14400" b="1" dirty="0">
                   <a:ln w="50800">
                     <a:noFill/>
                   </a:ln>
                   <a:latin typeface="Pretendard" panose="02000503000000020004" pitchFamily="50" charset="-127"/>
                   <a:ea typeface="Pretendard" panose="02000503000000020004" pitchFamily="50" charset="-127"/>
                   <a:cs typeface="Pretendard" panose="02000503000000020004" pitchFamily="50" charset="-127"/>
-                </a:rPr>
-                <a:t>Rackin</a:t>
-              </a:r>
-              <a:endParaRPr lang="ko-KR" altLang="en-US" sz="14400" b="1" dirty="0">
-                <a:ln w="50800">
-                  <a:noFill/>
-                </a:ln>
-                <a:latin typeface="Pretendard" panose="02000503000000020004" pitchFamily="50" charset="-127"/>
-                <a:ea typeface="Pretendard" panose="02000503000000020004" pitchFamily="50" charset="-127"/>
-                <a:cs typeface="Pretendard" panose="02000503000000020004" pitchFamily="50" charset="-127"/>
-              </a:endParaRPr>
-            </a:p>
-          </p:txBody>
-        </p:sp>
+                </a:endParaRPr>
+              </a:p>
+            </p:txBody>
+          </p:sp>
+        </p:grpSp>
+        <p:grpSp>
+          <p:nvGrpSpPr>
+            <p:cNvPr id="17" name="Group 16">
+              <a:extLst>
+                <a:ext uri="{FF2B5EF4-FFF2-40B4-BE49-F238E27FC236}">
+                  <a16:creationId xmlns:a16="http://schemas.microsoft.com/office/drawing/2014/main" id="{0CFAF05F-B5C6-5B2F-938B-3EAD9634601D}"/>
+                </a:ext>
+              </a:extLst>
+            </p:cNvPr>
+            <p:cNvGrpSpPr/>
+            <p:nvPr/>
+          </p:nvGrpSpPr>
+          <p:grpSpPr>
+            <a:xfrm>
+              <a:off x="1288271" y="2909049"/>
+              <a:ext cx="7177058" cy="3935503"/>
+              <a:chOff x="1288271" y="2909049"/>
+              <a:chExt cx="7177058" cy="3935503"/>
+            </a:xfrm>
+          </p:grpSpPr>
+          <p:sp>
+            <p:nvSpPr>
+              <p:cNvPr id="7" name="Freeform: Shape 6">
+                <a:extLst>
+                  <a:ext uri="{FF2B5EF4-FFF2-40B4-BE49-F238E27FC236}">
+                    <a16:creationId xmlns:a16="http://schemas.microsoft.com/office/drawing/2014/main" id="{11906196-F6E0-B6CC-54DA-D95ADC4F7F74}"/>
+                  </a:ext>
+                </a:extLst>
+              </p:cNvPr>
+              <p:cNvSpPr/>
+              <p:nvPr/>
+            </p:nvSpPr>
+            <p:spPr>
+              <a:xfrm rot="16200000">
+                <a:off x="1288271" y="2909049"/>
+                <a:ext cx="1362631" cy="1362632"/>
+              </a:xfrm>
+              <a:custGeom>
+                <a:avLst/>
+                <a:gdLst>
+                  <a:gd name="csX0" fmla="*/ 2162174 w 2438400"/>
+                  <a:gd name="csY0" fmla="*/ 1015509 h 2438401"/>
+                  <a:gd name="csX1" fmla="*/ 2226113 w 2438400"/>
+                  <a:gd name="csY1" fmla="*/ 1031950 h 2438401"/>
+                  <a:gd name="csX2" fmla="*/ 2438400 w 2438400"/>
+                  <a:gd name="csY2" fmla="*/ 1053350 h 2438401"/>
+                  <a:gd name="csX3" fmla="*/ 2438400 w 2438400"/>
+                  <a:gd name="csY3" fmla="*/ 2438401 h 2438401"/>
+                  <a:gd name="csX4" fmla="*/ 2162174 w 2438400"/>
+                  <a:gd name="csY4" fmla="*/ 2438401 h 2438401"/>
+                  <a:gd name="csX5" fmla="*/ 1385048 w 2438400"/>
+                  <a:gd name="csY5" fmla="*/ 0 h 2438401"/>
+                  <a:gd name="csX6" fmla="*/ 1659489 w 2438400"/>
+                  <a:gd name="csY6" fmla="*/ 0 h 2438401"/>
+                  <a:gd name="csX7" fmla="*/ 1663510 w 2438400"/>
+                  <a:gd name="csY7" fmla="*/ 79636 h 2438401"/>
+                  <a:gd name="csX8" fmla="*/ 1675314 w 2438400"/>
+                  <a:gd name="csY8" fmla="*/ 156975 h 2438401"/>
+                  <a:gd name="csX9" fmla="*/ 1712331 w 2438400"/>
+                  <a:gd name="csY9" fmla="*/ 276225 h 2438401"/>
+                  <a:gd name="csX10" fmla="*/ 1712330 w 2438400"/>
+                  <a:gd name="csY10" fmla="*/ 276225 h 2438401"/>
+                  <a:gd name="csX11" fmla="*/ 1720699 w 2438400"/>
+                  <a:gd name="csY11" fmla="*/ 303185 h 2438401"/>
+                  <a:gd name="csX12" fmla="*/ 2135212 w 2438400"/>
+                  <a:gd name="csY12" fmla="*/ 717698 h 2438401"/>
+                  <a:gd name="csX13" fmla="*/ 2162174 w 2438400"/>
+                  <a:gd name="csY13" fmla="*/ 726067 h 2438401"/>
+                  <a:gd name="csX14" fmla="*/ 2162174 w 2438400"/>
+                  <a:gd name="csY14" fmla="*/ 726067 h 2438401"/>
+                  <a:gd name="csX15" fmla="*/ 2281422 w 2438400"/>
+                  <a:gd name="csY15" fmla="*/ 763084 h 2438401"/>
+                  <a:gd name="csX16" fmla="*/ 2438400 w 2438400"/>
+                  <a:gd name="csY16" fmla="*/ 778909 h 2438401"/>
+                  <a:gd name="csX17" fmla="*/ 2438400 w 2438400"/>
+                  <a:gd name="csY17" fmla="*/ 1053350 h 2438401"/>
+                  <a:gd name="csX18" fmla="*/ 2226113 w 2438400"/>
+                  <a:gd name="csY18" fmla="*/ 1031950 h 2438401"/>
+                  <a:gd name="csX19" fmla="*/ 2162174 w 2438400"/>
+                  <a:gd name="csY19" fmla="*/ 1015509 h 2438401"/>
+                  <a:gd name="csX20" fmla="*/ 2162174 w 2438400"/>
+                  <a:gd name="csY20" fmla="*/ 1015509 h 2438401"/>
+                  <a:gd name="csX21" fmla="*/ 2125165 w 2438400"/>
+                  <a:gd name="csY21" fmla="*/ 1005993 h 2438401"/>
+                  <a:gd name="csX22" fmla="*/ 1432404 w 2438400"/>
+                  <a:gd name="csY22" fmla="*/ 313232 h 2438401"/>
+                  <a:gd name="csX23" fmla="*/ 1422888 w 2438400"/>
+                  <a:gd name="csY23" fmla="*/ 276225 h 2438401"/>
+                  <a:gd name="csX24" fmla="*/ 1422889 w 2438400"/>
+                  <a:gd name="csY24" fmla="*/ 276225 h 2438401"/>
+                  <a:gd name="csX25" fmla="*/ 1406448 w 2438400"/>
+                  <a:gd name="csY25" fmla="*/ 212284 h 2438401"/>
+                  <a:gd name="csX26" fmla="*/ 1390486 w 2438400"/>
+                  <a:gd name="csY26" fmla="*/ 107696 h 2438401"/>
+                  <a:gd name="csX27" fmla="*/ 0 w 2438400"/>
+                  <a:gd name="csY27" fmla="*/ 0 h 2438401"/>
+                  <a:gd name="csX28" fmla="*/ 1385047 w 2438400"/>
+                  <a:gd name="csY28" fmla="*/ 0 h 2438401"/>
+                  <a:gd name="csX29" fmla="*/ 1390485 w 2438400"/>
+                  <a:gd name="csY29" fmla="*/ 107696 h 2438401"/>
+                  <a:gd name="csX30" fmla="*/ 1406447 w 2438400"/>
+                  <a:gd name="csY30" fmla="*/ 212284 h 2438401"/>
+                  <a:gd name="csX31" fmla="*/ 1422888 w 2438400"/>
+                  <a:gd name="csY31" fmla="*/ 276225 h 2438401"/>
+                  <a:gd name="csX32" fmla="*/ 0 w 2438400"/>
+                  <a:gd name="csY32" fmla="*/ 276225 h 2438401"/>
+                </a:gdLst>
+                <a:ahLst/>
+                <a:cxnLst>
+                  <a:cxn ang="0">
+                    <a:pos x="csX0" y="csY0"/>
+                  </a:cxn>
+                  <a:cxn ang="0">
+                    <a:pos x="csX1" y="csY1"/>
+                  </a:cxn>
+                  <a:cxn ang="0">
+                    <a:pos x="csX2" y="csY2"/>
+                  </a:cxn>
+                  <a:cxn ang="0">
+                    <a:pos x="csX3" y="csY3"/>
+                  </a:cxn>
+                  <a:cxn ang="0">
+                    <a:pos x="csX4" y="csY4"/>
+                  </a:cxn>
+                  <a:cxn ang="0">
+                    <a:pos x="csX5" y="csY5"/>
+                  </a:cxn>
+                  <a:cxn ang="0">
+                    <a:pos x="csX6" y="csY6"/>
+                  </a:cxn>
+                  <a:cxn ang="0">
+                    <a:pos x="csX7" y="csY7"/>
+                  </a:cxn>
+                  <a:cxn ang="0">
+                    <a:pos x="csX8" y="csY8"/>
+                  </a:cxn>
+                  <a:cxn ang="0">
+                    <a:pos x="csX9" y="csY9"/>
+                  </a:cxn>
+                  <a:cxn ang="0">
+                    <a:pos x="csX10" y="csY10"/>
+                  </a:cxn>
+                  <a:cxn ang="0">
+                    <a:pos x="csX11" y="csY11"/>
+                  </a:cxn>
+                  <a:cxn ang="0">
+                    <a:pos x="csX12" y="csY12"/>
+                  </a:cxn>
+                  <a:cxn ang="0">
+                    <a:pos x="csX13" y="csY13"/>
+                  </a:cxn>
+                  <a:cxn ang="0">
+                    <a:pos x="csX14" y="csY14"/>
+                  </a:cxn>
+                  <a:cxn ang="0">
+                    <a:pos x="csX15" y="csY15"/>
+                  </a:cxn>
+                  <a:cxn ang="0">
+                    <a:pos x="csX16" y="csY16"/>
+                  </a:cxn>
+                  <a:cxn ang="0">
+                    <a:pos x="csX17" y="csY17"/>
+                  </a:cxn>
+                  <a:cxn ang="0">
+                    <a:pos x="csX18" y="csY18"/>
+                  </a:cxn>
+                  <a:cxn ang="0">
+                    <a:pos x="csX19" y="csY19"/>
+                  </a:cxn>
+                  <a:cxn ang="0">
+                    <a:pos x="csX20" y="csY20"/>
+                  </a:cxn>
+                  <a:cxn ang="0">
+                    <a:pos x="csX21" y="csY21"/>
+                  </a:cxn>
+                  <a:cxn ang="0">
+                    <a:pos x="csX22" y="csY22"/>
+                  </a:cxn>
+                  <a:cxn ang="0">
+                    <a:pos x="csX23" y="csY23"/>
+                  </a:cxn>
+                  <a:cxn ang="0">
+                    <a:pos x="csX24" y="csY24"/>
+                  </a:cxn>
+                  <a:cxn ang="0">
+                    <a:pos x="csX25" y="csY25"/>
+                  </a:cxn>
+                  <a:cxn ang="0">
+                    <a:pos x="csX26" y="csY26"/>
+                  </a:cxn>
+                  <a:cxn ang="0">
+                    <a:pos x="csX27" y="csY27"/>
+                  </a:cxn>
+                  <a:cxn ang="0">
+                    <a:pos x="csX28" y="csY28"/>
+                  </a:cxn>
+                  <a:cxn ang="0">
+                    <a:pos x="csX29" y="csY29"/>
+                  </a:cxn>
+                  <a:cxn ang="0">
+                    <a:pos x="csX30" y="csY30"/>
+                  </a:cxn>
+                  <a:cxn ang="0">
+                    <a:pos x="csX31" y="csY31"/>
+                  </a:cxn>
+                  <a:cxn ang="0">
+                    <a:pos x="csX32" y="csY32"/>
+                  </a:cxn>
+                </a:cxnLst>
+                <a:rect l="l" t="t" r="r" b="b"/>
+                <a:pathLst>
+                  <a:path w="2438400" h="2438401">
+                    <a:moveTo>
+                      <a:pt x="2162174" y="1015509"/>
+                    </a:moveTo>
+                    <a:lnTo>
+                      <a:pt x="2226113" y="1031950"/>
+                    </a:lnTo>
+                    <a:cubicBezTo>
+                      <a:pt x="2294683" y="1045981"/>
+                      <a:pt x="2365681" y="1053350"/>
+                      <a:pt x="2438400" y="1053350"/>
+                    </a:cubicBezTo>
+                    <a:lnTo>
+                      <a:pt x="2438400" y="2438401"/>
+                    </a:lnTo>
+                    <a:lnTo>
+                      <a:pt x="2162174" y="2438401"/>
+                    </a:lnTo>
+                    <a:close/>
+                    <a:moveTo>
+                      <a:pt x="1385048" y="0"/>
+                    </a:moveTo>
+                    <a:lnTo>
+                      <a:pt x="1659489" y="0"/>
+                    </a:lnTo>
+                    <a:lnTo>
+                      <a:pt x="1663510" y="79636"/>
+                    </a:lnTo>
+                    <a:cubicBezTo>
+                      <a:pt x="1666170" y="105821"/>
+                      <a:pt x="1670126" y="131622"/>
+                      <a:pt x="1675314" y="156975"/>
+                    </a:cubicBezTo>
+                    <a:lnTo>
+                      <a:pt x="1712331" y="276225"/>
+                    </a:lnTo>
+                    <a:lnTo>
+                      <a:pt x="1712330" y="276225"/>
+                    </a:lnTo>
+                    <a:lnTo>
+                      <a:pt x="1720699" y="303185"/>
+                    </a:lnTo>
+                    <a:cubicBezTo>
+                      <a:pt x="1799529" y="489560"/>
+                      <a:pt x="1948837" y="638868"/>
+                      <a:pt x="2135212" y="717698"/>
+                    </a:cubicBezTo>
+                    <a:lnTo>
+                      <a:pt x="2162174" y="726067"/>
+                    </a:lnTo>
+                    <a:lnTo>
+                      <a:pt x="2162174" y="726067"/>
+                    </a:lnTo>
+                    <a:lnTo>
+                      <a:pt x="2281422" y="763084"/>
+                    </a:lnTo>
+                    <a:cubicBezTo>
+                      <a:pt x="2332127" y="773460"/>
+                      <a:pt x="2384627" y="778909"/>
+                      <a:pt x="2438400" y="778909"/>
+                    </a:cubicBezTo>
+                    <a:lnTo>
+                      <a:pt x="2438400" y="1053350"/>
+                    </a:lnTo>
+                    <a:cubicBezTo>
+                      <a:pt x="2365681" y="1053350"/>
+                      <a:pt x="2294683" y="1045981"/>
+                      <a:pt x="2226113" y="1031950"/>
+                    </a:cubicBezTo>
+                    <a:lnTo>
+                      <a:pt x="2162174" y="1015509"/>
+                    </a:lnTo>
+                    <a:lnTo>
+                      <a:pt x="2162174" y="1015509"/>
+                    </a:lnTo>
+                    <a:lnTo>
+                      <a:pt x="2125165" y="1005993"/>
+                    </a:lnTo>
+                    <a:cubicBezTo>
+                      <a:pt x="1795329" y="903404"/>
+                      <a:pt x="1534993" y="643068"/>
+                      <a:pt x="1432404" y="313232"/>
+                    </a:cubicBezTo>
+                    <a:lnTo>
+                      <a:pt x="1422888" y="276225"/>
+                    </a:lnTo>
+                    <a:lnTo>
+                      <a:pt x="1422889" y="276225"/>
+                    </a:lnTo>
+                    <a:lnTo>
+                      <a:pt x="1406448" y="212284"/>
+                    </a:lnTo>
+                    <a:cubicBezTo>
+                      <a:pt x="1399433" y="177999"/>
+                      <a:pt x="1394082" y="143107"/>
+                      <a:pt x="1390486" y="107696"/>
+                    </a:cubicBezTo>
+                    <a:close/>
+                    <a:moveTo>
+                      <a:pt x="0" y="0"/>
+                    </a:moveTo>
+                    <a:lnTo>
+                      <a:pt x="1385047" y="0"/>
+                    </a:lnTo>
+                    <a:lnTo>
+                      <a:pt x="1390485" y="107696"/>
+                    </a:lnTo>
+                    <a:cubicBezTo>
+                      <a:pt x="1394081" y="143107"/>
+                      <a:pt x="1399432" y="177999"/>
+                      <a:pt x="1406447" y="212284"/>
+                    </a:cubicBezTo>
+                    <a:lnTo>
+                      <a:pt x="1422888" y="276225"/>
+                    </a:lnTo>
+                    <a:lnTo>
+                      <a:pt x="0" y="276225"/>
+                    </a:lnTo>
+                    <a:close/>
+                  </a:path>
+                </a:pathLst>
+              </a:custGeom>
+              <a:solidFill>
+                <a:schemeClr val="tx1"/>
+              </a:solidFill>
+              <a:ln>
+                <a:noFill/>
+              </a:ln>
+            </p:spPr>
+            <p:style>
+              <a:lnRef idx="2">
+                <a:schemeClr val="accent1">
+                  <a:shade val="15000"/>
+                </a:schemeClr>
+              </a:lnRef>
+              <a:fillRef idx="1">
+                <a:schemeClr val="accent1"/>
+              </a:fillRef>
+              <a:effectRef idx="0">
+                <a:schemeClr val="accent1"/>
+              </a:effectRef>
+              <a:fontRef idx="minor">
+                <a:schemeClr val="lt1"/>
+              </a:fontRef>
+            </p:style>
+            <p:txBody>
+              <a:bodyPr wrap="square" rtlCol="0" anchor="ctr">
+                <a:noAutofit/>
+              </a:bodyPr>
+              <a:lstStyle/>
+              <a:p>
+                <a:pPr algn="ctr"/>
+                <a:endParaRPr lang="ko-KR" altLang="en-US" dirty="0"/>
+              </a:p>
+            </p:txBody>
+          </p:sp>
+          <p:sp>
+            <p:nvSpPr>
+              <p:cNvPr id="12" name="Freeform: Shape 11">
+                <a:extLst>
+                  <a:ext uri="{FF2B5EF4-FFF2-40B4-BE49-F238E27FC236}">
+                    <a16:creationId xmlns:a16="http://schemas.microsoft.com/office/drawing/2014/main" id="{938AFE60-1BA5-D131-B1D2-86C4035959AE}"/>
+                  </a:ext>
+                </a:extLst>
+              </p:cNvPr>
+              <p:cNvSpPr/>
+              <p:nvPr/>
+            </p:nvSpPr>
+            <p:spPr>
+              <a:xfrm rot="5400000">
+                <a:off x="7102697" y="5481921"/>
+                <a:ext cx="1362631" cy="1362632"/>
+              </a:xfrm>
+              <a:custGeom>
+                <a:avLst/>
+                <a:gdLst>
+                  <a:gd name="csX0" fmla="*/ 2162174 w 2438400"/>
+                  <a:gd name="csY0" fmla="*/ 1015509 h 2438401"/>
+                  <a:gd name="csX1" fmla="*/ 2226113 w 2438400"/>
+                  <a:gd name="csY1" fmla="*/ 1031950 h 2438401"/>
+                  <a:gd name="csX2" fmla="*/ 2438400 w 2438400"/>
+                  <a:gd name="csY2" fmla="*/ 1053350 h 2438401"/>
+                  <a:gd name="csX3" fmla="*/ 2438400 w 2438400"/>
+                  <a:gd name="csY3" fmla="*/ 2438401 h 2438401"/>
+                  <a:gd name="csX4" fmla="*/ 2162174 w 2438400"/>
+                  <a:gd name="csY4" fmla="*/ 2438401 h 2438401"/>
+                  <a:gd name="csX5" fmla="*/ 1385048 w 2438400"/>
+                  <a:gd name="csY5" fmla="*/ 0 h 2438401"/>
+                  <a:gd name="csX6" fmla="*/ 1659489 w 2438400"/>
+                  <a:gd name="csY6" fmla="*/ 0 h 2438401"/>
+                  <a:gd name="csX7" fmla="*/ 1663510 w 2438400"/>
+                  <a:gd name="csY7" fmla="*/ 79636 h 2438401"/>
+                  <a:gd name="csX8" fmla="*/ 1675314 w 2438400"/>
+                  <a:gd name="csY8" fmla="*/ 156975 h 2438401"/>
+                  <a:gd name="csX9" fmla="*/ 1712331 w 2438400"/>
+                  <a:gd name="csY9" fmla="*/ 276225 h 2438401"/>
+                  <a:gd name="csX10" fmla="*/ 1712330 w 2438400"/>
+                  <a:gd name="csY10" fmla="*/ 276225 h 2438401"/>
+                  <a:gd name="csX11" fmla="*/ 1720699 w 2438400"/>
+                  <a:gd name="csY11" fmla="*/ 303185 h 2438401"/>
+                  <a:gd name="csX12" fmla="*/ 2135212 w 2438400"/>
+                  <a:gd name="csY12" fmla="*/ 717698 h 2438401"/>
+                  <a:gd name="csX13" fmla="*/ 2162174 w 2438400"/>
+                  <a:gd name="csY13" fmla="*/ 726067 h 2438401"/>
+                  <a:gd name="csX14" fmla="*/ 2162174 w 2438400"/>
+                  <a:gd name="csY14" fmla="*/ 726067 h 2438401"/>
+                  <a:gd name="csX15" fmla="*/ 2281422 w 2438400"/>
+                  <a:gd name="csY15" fmla="*/ 763084 h 2438401"/>
+                  <a:gd name="csX16" fmla="*/ 2438400 w 2438400"/>
+                  <a:gd name="csY16" fmla="*/ 778909 h 2438401"/>
+                  <a:gd name="csX17" fmla="*/ 2438400 w 2438400"/>
+                  <a:gd name="csY17" fmla="*/ 1053350 h 2438401"/>
+                  <a:gd name="csX18" fmla="*/ 2226113 w 2438400"/>
+                  <a:gd name="csY18" fmla="*/ 1031950 h 2438401"/>
+                  <a:gd name="csX19" fmla="*/ 2162174 w 2438400"/>
+                  <a:gd name="csY19" fmla="*/ 1015509 h 2438401"/>
+                  <a:gd name="csX20" fmla="*/ 2162174 w 2438400"/>
+                  <a:gd name="csY20" fmla="*/ 1015509 h 2438401"/>
+                  <a:gd name="csX21" fmla="*/ 2125165 w 2438400"/>
+                  <a:gd name="csY21" fmla="*/ 1005993 h 2438401"/>
+                  <a:gd name="csX22" fmla="*/ 1432404 w 2438400"/>
+                  <a:gd name="csY22" fmla="*/ 313232 h 2438401"/>
+                  <a:gd name="csX23" fmla="*/ 1422888 w 2438400"/>
+                  <a:gd name="csY23" fmla="*/ 276225 h 2438401"/>
+                  <a:gd name="csX24" fmla="*/ 1422889 w 2438400"/>
+                  <a:gd name="csY24" fmla="*/ 276225 h 2438401"/>
+                  <a:gd name="csX25" fmla="*/ 1406448 w 2438400"/>
+                  <a:gd name="csY25" fmla="*/ 212284 h 2438401"/>
+                  <a:gd name="csX26" fmla="*/ 1390486 w 2438400"/>
+                  <a:gd name="csY26" fmla="*/ 107696 h 2438401"/>
+                  <a:gd name="csX27" fmla="*/ 0 w 2438400"/>
+                  <a:gd name="csY27" fmla="*/ 0 h 2438401"/>
+                  <a:gd name="csX28" fmla="*/ 1385047 w 2438400"/>
+                  <a:gd name="csY28" fmla="*/ 0 h 2438401"/>
+                  <a:gd name="csX29" fmla="*/ 1390485 w 2438400"/>
+                  <a:gd name="csY29" fmla="*/ 107696 h 2438401"/>
+                  <a:gd name="csX30" fmla="*/ 1406447 w 2438400"/>
+                  <a:gd name="csY30" fmla="*/ 212284 h 2438401"/>
+                  <a:gd name="csX31" fmla="*/ 1422888 w 2438400"/>
+                  <a:gd name="csY31" fmla="*/ 276225 h 2438401"/>
+                  <a:gd name="csX32" fmla="*/ 0 w 2438400"/>
+                  <a:gd name="csY32" fmla="*/ 276225 h 2438401"/>
+                </a:gdLst>
+                <a:ahLst/>
+                <a:cxnLst>
+                  <a:cxn ang="0">
+                    <a:pos x="csX0" y="csY0"/>
+                  </a:cxn>
+                  <a:cxn ang="0">
+                    <a:pos x="csX1" y="csY1"/>
+                  </a:cxn>
+                  <a:cxn ang="0">
+                    <a:pos x="csX2" y="csY2"/>
+                  </a:cxn>
+                  <a:cxn ang="0">
+                    <a:pos x="csX3" y="csY3"/>
+                  </a:cxn>
+                  <a:cxn ang="0">
+                    <a:pos x="csX4" y="csY4"/>
+                  </a:cxn>
+                  <a:cxn ang="0">
+                    <a:pos x="csX5" y="csY5"/>
+                  </a:cxn>
+                  <a:cxn ang="0">
+                    <a:pos x="csX6" y="csY6"/>
+                  </a:cxn>
+                  <a:cxn ang="0">
+                    <a:pos x="csX7" y="csY7"/>
+                  </a:cxn>
+                  <a:cxn ang="0">
+                    <a:pos x="csX8" y="csY8"/>
+                  </a:cxn>
+                  <a:cxn ang="0">
+                    <a:pos x="csX9" y="csY9"/>
+                  </a:cxn>
+                  <a:cxn ang="0">
+                    <a:pos x="csX10" y="csY10"/>
+                  </a:cxn>
+                  <a:cxn ang="0">
+                    <a:pos x="csX11" y="csY11"/>
+                  </a:cxn>
+                  <a:cxn ang="0">
+                    <a:pos x="csX12" y="csY12"/>
+                  </a:cxn>
+                  <a:cxn ang="0">
+                    <a:pos x="csX13" y="csY13"/>
+                  </a:cxn>
+                  <a:cxn ang="0">
+                    <a:pos x="csX14" y="csY14"/>
+                  </a:cxn>
+                  <a:cxn ang="0">
+                    <a:pos x="csX15" y="csY15"/>
+                  </a:cxn>
+                  <a:cxn ang="0">
+                    <a:pos x="csX16" y="csY16"/>
+                  </a:cxn>
+                  <a:cxn ang="0">
+                    <a:pos x="csX17" y="csY17"/>
+                  </a:cxn>
+                  <a:cxn ang="0">
+                    <a:pos x="csX18" y="csY18"/>
+                  </a:cxn>
+                  <a:cxn ang="0">
+                    <a:pos x="csX19" y="csY19"/>
+                  </a:cxn>
+                  <a:cxn ang="0">
+                    <a:pos x="csX20" y="csY20"/>
+                  </a:cxn>
+                  <a:cxn ang="0">
+                    <a:pos x="csX21" y="csY21"/>
+                  </a:cxn>
+                  <a:cxn ang="0">
+                    <a:pos x="csX22" y="csY22"/>
+                  </a:cxn>
+                  <a:cxn ang="0">
+                    <a:pos x="csX23" y="csY23"/>
+                  </a:cxn>
+                  <a:cxn ang="0">
+                    <a:pos x="csX24" y="csY24"/>
+                  </a:cxn>
+                  <a:cxn ang="0">
+                    <a:pos x="csX25" y="csY25"/>
+                  </a:cxn>
+                  <a:cxn ang="0">
+                    <a:pos x="csX26" y="csY26"/>
+                  </a:cxn>
+                  <a:cxn ang="0">
+                    <a:pos x="csX27" y="csY27"/>
+                  </a:cxn>
+                  <a:cxn ang="0">
+                    <a:pos x="csX28" y="csY28"/>
+                  </a:cxn>
+                  <a:cxn ang="0">
+                    <a:pos x="csX29" y="csY29"/>
+                  </a:cxn>
+                  <a:cxn ang="0">
+                    <a:pos x="csX30" y="csY30"/>
+                  </a:cxn>
+                  <a:cxn ang="0">
+                    <a:pos x="csX31" y="csY31"/>
+                  </a:cxn>
+                  <a:cxn ang="0">
+                    <a:pos x="csX32" y="csY32"/>
+                  </a:cxn>
+                </a:cxnLst>
+                <a:rect l="l" t="t" r="r" b="b"/>
+                <a:pathLst>
+                  <a:path w="2438400" h="2438401">
+                    <a:moveTo>
+                      <a:pt x="2162174" y="1015509"/>
+                    </a:moveTo>
+                    <a:lnTo>
+                      <a:pt x="2226113" y="1031950"/>
+                    </a:lnTo>
+                    <a:cubicBezTo>
+                      <a:pt x="2294683" y="1045981"/>
+                      <a:pt x="2365681" y="1053350"/>
+                      <a:pt x="2438400" y="1053350"/>
+                    </a:cubicBezTo>
+                    <a:lnTo>
+                      <a:pt x="2438400" y="2438401"/>
+                    </a:lnTo>
+                    <a:lnTo>
+                      <a:pt x="2162174" y="2438401"/>
+                    </a:lnTo>
+                    <a:close/>
+                    <a:moveTo>
+                      <a:pt x="1385048" y="0"/>
+                    </a:moveTo>
+                    <a:lnTo>
+                      <a:pt x="1659489" y="0"/>
+                    </a:lnTo>
+                    <a:lnTo>
+                      <a:pt x="1663510" y="79636"/>
+                    </a:lnTo>
+                    <a:cubicBezTo>
+                      <a:pt x="1666170" y="105821"/>
+                      <a:pt x="1670126" y="131622"/>
+                      <a:pt x="1675314" y="156975"/>
+                    </a:cubicBezTo>
+                    <a:lnTo>
+                      <a:pt x="1712331" y="276225"/>
+                    </a:lnTo>
+                    <a:lnTo>
+                      <a:pt x="1712330" y="276225"/>
+                    </a:lnTo>
+                    <a:lnTo>
+                      <a:pt x="1720699" y="303185"/>
+                    </a:lnTo>
+                    <a:cubicBezTo>
+                      <a:pt x="1799529" y="489560"/>
+                      <a:pt x="1948837" y="638868"/>
+                      <a:pt x="2135212" y="717698"/>
+                    </a:cubicBezTo>
+                    <a:lnTo>
+                      <a:pt x="2162174" y="726067"/>
+                    </a:lnTo>
+                    <a:lnTo>
+                      <a:pt x="2162174" y="726067"/>
+                    </a:lnTo>
+                    <a:lnTo>
+                      <a:pt x="2281422" y="763084"/>
+                    </a:lnTo>
+                    <a:cubicBezTo>
+                      <a:pt x="2332127" y="773460"/>
+                      <a:pt x="2384627" y="778909"/>
+                      <a:pt x="2438400" y="778909"/>
+                    </a:cubicBezTo>
+                    <a:lnTo>
+                      <a:pt x="2438400" y="1053350"/>
+                    </a:lnTo>
+                    <a:cubicBezTo>
+                      <a:pt x="2365681" y="1053350"/>
+                      <a:pt x="2294683" y="1045981"/>
+                      <a:pt x="2226113" y="1031950"/>
+                    </a:cubicBezTo>
+                    <a:lnTo>
+                      <a:pt x="2162174" y="1015509"/>
+                    </a:lnTo>
+                    <a:lnTo>
+                      <a:pt x="2162174" y="1015509"/>
+                    </a:lnTo>
+                    <a:lnTo>
+                      <a:pt x="2125165" y="1005993"/>
+                    </a:lnTo>
+                    <a:cubicBezTo>
+                      <a:pt x="1795329" y="903404"/>
+                      <a:pt x="1534993" y="643068"/>
+                      <a:pt x="1432404" y="313232"/>
+                    </a:cubicBezTo>
+                    <a:lnTo>
+                      <a:pt x="1422888" y="276225"/>
+                    </a:lnTo>
+                    <a:lnTo>
+                      <a:pt x="1422889" y="276225"/>
+                    </a:lnTo>
+                    <a:lnTo>
+                      <a:pt x="1406448" y="212284"/>
+                    </a:lnTo>
+                    <a:cubicBezTo>
+                      <a:pt x="1399433" y="177999"/>
+                      <a:pt x="1394082" y="143107"/>
+                      <a:pt x="1390486" y="107696"/>
+                    </a:cubicBezTo>
+                    <a:close/>
+                    <a:moveTo>
+                      <a:pt x="0" y="0"/>
+                    </a:moveTo>
+                    <a:lnTo>
+                      <a:pt x="1385047" y="0"/>
+                    </a:lnTo>
+                    <a:lnTo>
+                      <a:pt x="1390485" y="107696"/>
+                    </a:lnTo>
+                    <a:cubicBezTo>
+                      <a:pt x="1394081" y="143107"/>
+                      <a:pt x="1399432" y="177999"/>
+                      <a:pt x="1406447" y="212284"/>
+                    </a:cubicBezTo>
+                    <a:lnTo>
+                      <a:pt x="1422888" y="276225"/>
+                    </a:lnTo>
+                    <a:lnTo>
+                      <a:pt x="0" y="276225"/>
+                    </a:lnTo>
+                    <a:close/>
+                  </a:path>
+                </a:pathLst>
+              </a:custGeom>
+              <a:solidFill>
+                <a:schemeClr val="tx1"/>
+              </a:solidFill>
+              <a:ln>
+                <a:noFill/>
+              </a:ln>
+            </p:spPr>
+            <p:style>
+              <a:lnRef idx="2">
+                <a:schemeClr val="accent1">
+                  <a:shade val="15000"/>
+                </a:schemeClr>
+              </a:lnRef>
+              <a:fillRef idx="1">
+                <a:schemeClr val="accent1"/>
+              </a:fillRef>
+              <a:effectRef idx="0">
+                <a:schemeClr val="accent1"/>
+              </a:effectRef>
+              <a:fontRef idx="minor">
+                <a:schemeClr val="lt1"/>
+              </a:fontRef>
+            </p:style>
+            <p:txBody>
+              <a:bodyPr wrap="square" rtlCol="0" anchor="ctr">
+                <a:noAutofit/>
+              </a:bodyPr>
+              <a:lstStyle/>
+              <a:p>
+                <a:pPr algn="ctr"/>
+                <a:endParaRPr lang="ko-KR" altLang="en-US" dirty="0"/>
+              </a:p>
+            </p:txBody>
+          </p:sp>
+          <p:sp>
+            <p:nvSpPr>
+              <p:cNvPr id="14" name="Rectangle 13">
+                <a:extLst>
+                  <a:ext uri="{FF2B5EF4-FFF2-40B4-BE49-F238E27FC236}">
+                    <a16:creationId xmlns:a16="http://schemas.microsoft.com/office/drawing/2014/main" id="{2799D7C3-2052-0A3A-8C3B-41882A1A8E29}"/>
+                  </a:ext>
+                </a:extLst>
+              </p:cNvPr>
+              <p:cNvSpPr/>
+              <p:nvPr/>
+            </p:nvSpPr>
+            <p:spPr>
+              <a:xfrm>
+                <a:off x="8310562" y="4271680"/>
+                <a:ext cx="154765" cy="1210241"/>
+              </a:xfrm>
+              <a:prstGeom prst="rect">
+                <a:avLst/>
+              </a:prstGeom>
+              <a:solidFill>
+                <a:schemeClr val="tx1"/>
+              </a:solidFill>
+              <a:ln>
+                <a:noFill/>
+              </a:ln>
+            </p:spPr>
+            <p:style>
+              <a:lnRef idx="2">
+                <a:schemeClr val="accent1">
+                  <a:shade val="15000"/>
+                </a:schemeClr>
+              </a:lnRef>
+              <a:fillRef idx="1">
+                <a:schemeClr val="accent1"/>
+              </a:fillRef>
+              <a:effectRef idx="0">
+                <a:schemeClr val="accent1"/>
+              </a:effectRef>
+              <a:fontRef idx="minor">
+                <a:schemeClr val="lt1"/>
+              </a:fontRef>
+            </p:style>
+            <p:txBody>
+              <a:bodyPr rtlCol="0" anchor="ctr"/>
+              <a:lstStyle/>
+              <a:p>
+                <a:pPr algn="ctr"/>
+                <a:endParaRPr lang="ko-KR" altLang="en-US"/>
+              </a:p>
+            </p:txBody>
+          </p:sp>
+          <p:sp>
+            <p:nvSpPr>
+              <p:cNvPr id="16" name="Rectangle 15">
+                <a:extLst>
+                  <a:ext uri="{FF2B5EF4-FFF2-40B4-BE49-F238E27FC236}">
+                    <a16:creationId xmlns:a16="http://schemas.microsoft.com/office/drawing/2014/main" id="{62349A6E-9CCF-42E7-28E7-54921984F555}"/>
+                  </a:ext>
+                </a:extLst>
+              </p:cNvPr>
+              <p:cNvSpPr/>
+              <p:nvPr/>
+            </p:nvSpPr>
+            <p:spPr>
+              <a:xfrm rot="5400000">
+                <a:off x="4799416" y="4541272"/>
+                <a:ext cx="154765" cy="4451793"/>
+              </a:xfrm>
+              <a:prstGeom prst="rect">
+                <a:avLst/>
+              </a:prstGeom>
+              <a:solidFill>
+                <a:schemeClr val="tx1"/>
+              </a:solidFill>
+              <a:ln>
+                <a:noFill/>
+              </a:ln>
+            </p:spPr>
+            <p:style>
+              <a:lnRef idx="2">
+                <a:schemeClr val="accent1">
+                  <a:shade val="15000"/>
+                </a:schemeClr>
+              </a:lnRef>
+              <a:fillRef idx="1">
+                <a:schemeClr val="accent1"/>
+              </a:fillRef>
+              <a:effectRef idx="0">
+                <a:schemeClr val="accent1"/>
+              </a:effectRef>
+              <a:fontRef idx="minor">
+                <a:schemeClr val="lt1"/>
+              </a:fontRef>
+            </p:style>
+            <p:txBody>
+              <a:bodyPr rtlCol="0" anchor="ctr"/>
+              <a:lstStyle/>
+              <a:p>
+                <a:pPr algn="ctr"/>
+                <a:endParaRPr lang="ko-KR" altLang="en-US"/>
+              </a:p>
+            </p:txBody>
+          </p:sp>
+        </p:grpSp>
+        <p:grpSp>
+          <p:nvGrpSpPr>
+            <p:cNvPr id="18" name="Group 17">
+              <a:extLst>
+                <a:ext uri="{FF2B5EF4-FFF2-40B4-BE49-F238E27FC236}">
+                  <a16:creationId xmlns:a16="http://schemas.microsoft.com/office/drawing/2014/main" id="{BB5B425F-7C3D-BBD4-315B-76A38761866D}"/>
+                </a:ext>
+              </a:extLst>
+            </p:cNvPr>
+            <p:cNvGrpSpPr/>
+            <p:nvPr/>
+          </p:nvGrpSpPr>
+          <p:grpSpPr>
+            <a:xfrm>
+              <a:off x="1288269" y="2909049"/>
+              <a:ext cx="7177058" cy="3935503"/>
+              <a:chOff x="1288271" y="2909049"/>
+              <a:chExt cx="7177058" cy="3935503"/>
+            </a:xfrm>
+          </p:grpSpPr>
+          <p:sp>
+            <p:nvSpPr>
+              <p:cNvPr id="19" name="Freeform: Shape 18">
+                <a:extLst>
+                  <a:ext uri="{FF2B5EF4-FFF2-40B4-BE49-F238E27FC236}">
+                    <a16:creationId xmlns:a16="http://schemas.microsoft.com/office/drawing/2014/main" id="{17AF2FB1-7C84-97BE-738B-B08201A54AEE}"/>
+                  </a:ext>
+                </a:extLst>
+              </p:cNvPr>
+              <p:cNvSpPr/>
+              <p:nvPr/>
+            </p:nvSpPr>
+            <p:spPr>
+              <a:xfrm rot="16200000">
+                <a:off x="1288271" y="2909049"/>
+                <a:ext cx="1362631" cy="1362632"/>
+              </a:xfrm>
+              <a:custGeom>
+                <a:avLst/>
+                <a:gdLst>
+                  <a:gd name="csX0" fmla="*/ 2162174 w 2438400"/>
+                  <a:gd name="csY0" fmla="*/ 1015509 h 2438401"/>
+                  <a:gd name="csX1" fmla="*/ 2226113 w 2438400"/>
+                  <a:gd name="csY1" fmla="*/ 1031950 h 2438401"/>
+                  <a:gd name="csX2" fmla="*/ 2438400 w 2438400"/>
+                  <a:gd name="csY2" fmla="*/ 1053350 h 2438401"/>
+                  <a:gd name="csX3" fmla="*/ 2438400 w 2438400"/>
+                  <a:gd name="csY3" fmla="*/ 2438401 h 2438401"/>
+                  <a:gd name="csX4" fmla="*/ 2162174 w 2438400"/>
+                  <a:gd name="csY4" fmla="*/ 2438401 h 2438401"/>
+                  <a:gd name="csX5" fmla="*/ 1385048 w 2438400"/>
+                  <a:gd name="csY5" fmla="*/ 0 h 2438401"/>
+                  <a:gd name="csX6" fmla="*/ 1659489 w 2438400"/>
+                  <a:gd name="csY6" fmla="*/ 0 h 2438401"/>
+                  <a:gd name="csX7" fmla="*/ 1663510 w 2438400"/>
+                  <a:gd name="csY7" fmla="*/ 79636 h 2438401"/>
+                  <a:gd name="csX8" fmla="*/ 1675314 w 2438400"/>
+                  <a:gd name="csY8" fmla="*/ 156975 h 2438401"/>
+                  <a:gd name="csX9" fmla="*/ 1712331 w 2438400"/>
+                  <a:gd name="csY9" fmla="*/ 276225 h 2438401"/>
+                  <a:gd name="csX10" fmla="*/ 1712330 w 2438400"/>
+                  <a:gd name="csY10" fmla="*/ 276225 h 2438401"/>
+                  <a:gd name="csX11" fmla="*/ 1720699 w 2438400"/>
+                  <a:gd name="csY11" fmla="*/ 303185 h 2438401"/>
+                  <a:gd name="csX12" fmla="*/ 2135212 w 2438400"/>
+                  <a:gd name="csY12" fmla="*/ 717698 h 2438401"/>
+                  <a:gd name="csX13" fmla="*/ 2162174 w 2438400"/>
+                  <a:gd name="csY13" fmla="*/ 726067 h 2438401"/>
+                  <a:gd name="csX14" fmla="*/ 2162174 w 2438400"/>
+                  <a:gd name="csY14" fmla="*/ 726067 h 2438401"/>
+                  <a:gd name="csX15" fmla="*/ 2281422 w 2438400"/>
+                  <a:gd name="csY15" fmla="*/ 763084 h 2438401"/>
+                  <a:gd name="csX16" fmla="*/ 2438400 w 2438400"/>
+                  <a:gd name="csY16" fmla="*/ 778909 h 2438401"/>
+                  <a:gd name="csX17" fmla="*/ 2438400 w 2438400"/>
+                  <a:gd name="csY17" fmla="*/ 1053350 h 2438401"/>
+                  <a:gd name="csX18" fmla="*/ 2226113 w 2438400"/>
+                  <a:gd name="csY18" fmla="*/ 1031950 h 2438401"/>
+                  <a:gd name="csX19" fmla="*/ 2162174 w 2438400"/>
+                  <a:gd name="csY19" fmla="*/ 1015509 h 2438401"/>
+                  <a:gd name="csX20" fmla="*/ 2162174 w 2438400"/>
+                  <a:gd name="csY20" fmla="*/ 1015509 h 2438401"/>
+                  <a:gd name="csX21" fmla="*/ 2125165 w 2438400"/>
+                  <a:gd name="csY21" fmla="*/ 1005993 h 2438401"/>
+                  <a:gd name="csX22" fmla="*/ 1432404 w 2438400"/>
+                  <a:gd name="csY22" fmla="*/ 313232 h 2438401"/>
+                  <a:gd name="csX23" fmla="*/ 1422888 w 2438400"/>
+                  <a:gd name="csY23" fmla="*/ 276225 h 2438401"/>
+                  <a:gd name="csX24" fmla="*/ 1422889 w 2438400"/>
+                  <a:gd name="csY24" fmla="*/ 276225 h 2438401"/>
+                  <a:gd name="csX25" fmla="*/ 1406448 w 2438400"/>
+                  <a:gd name="csY25" fmla="*/ 212284 h 2438401"/>
+                  <a:gd name="csX26" fmla="*/ 1390486 w 2438400"/>
+                  <a:gd name="csY26" fmla="*/ 107696 h 2438401"/>
+                  <a:gd name="csX27" fmla="*/ 0 w 2438400"/>
+                  <a:gd name="csY27" fmla="*/ 0 h 2438401"/>
+                  <a:gd name="csX28" fmla="*/ 1385047 w 2438400"/>
+                  <a:gd name="csY28" fmla="*/ 0 h 2438401"/>
+                  <a:gd name="csX29" fmla="*/ 1390485 w 2438400"/>
+                  <a:gd name="csY29" fmla="*/ 107696 h 2438401"/>
+                  <a:gd name="csX30" fmla="*/ 1406447 w 2438400"/>
+                  <a:gd name="csY30" fmla="*/ 212284 h 2438401"/>
+                  <a:gd name="csX31" fmla="*/ 1422888 w 2438400"/>
+                  <a:gd name="csY31" fmla="*/ 276225 h 2438401"/>
+                  <a:gd name="csX32" fmla="*/ 0 w 2438400"/>
+                  <a:gd name="csY32" fmla="*/ 276225 h 2438401"/>
+                </a:gdLst>
+                <a:ahLst/>
+                <a:cxnLst>
+                  <a:cxn ang="0">
+                    <a:pos x="csX0" y="csY0"/>
+                  </a:cxn>
+                  <a:cxn ang="0">
+                    <a:pos x="csX1" y="csY1"/>
+                  </a:cxn>
+                  <a:cxn ang="0">
+                    <a:pos x="csX2" y="csY2"/>
+                  </a:cxn>
+                  <a:cxn ang="0">
+                    <a:pos x="csX3" y="csY3"/>
+                  </a:cxn>
+                  <a:cxn ang="0">
+                    <a:pos x="csX4" y="csY4"/>
+                  </a:cxn>
+                  <a:cxn ang="0">
+                    <a:pos x="csX5" y="csY5"/>
+                  </a:cxn>
+                  <a:cxn ang="0">
+                    <a:pos x="csX6" y="csY6"/>
+                  </a:cxn>
+                  <a:cxn ang="0">
+                    <a:pos x="csX7" y="csY7"/>
+                  </a:cxn>
+                  <a:cxn ang="0">
+                    <a:pos x="csX8" y="csY8"/>
+                  </a:cxn>
+                  <a:cxn ang="0">
+                    <a:pos x="csX9" y="csY9"/>
+                  </a:cxn>
+                  <a:cxn ang="0">
+                    <a:pos x="csX10" y="csY10"/>
+                  </a:cxn>
+                  <a:cxn ang="0">
+                    <a:pos x="csX11" y="csY11"/>
+                  </a:cxn>
+                  <a:cxn ang="0">
+                    <a:pos x="csX12" y="csY12"/>
+                  </a:cxn>
+                  <a:cxn ang="0">
+                    <a:pos x="csX13" y="csY13"/>
+                  </a:cxn>
+                  <a:cxn ang="0">
+                    <a:pos x="csX14" y="csY14"/>
+                  </a:cxn>
+                  <a:cxn ang="0">
+                    <a:pos x="csX15" y="csY15"/>
+                  </a:cxn>
+                  <a:cxn ang="0">
+                    <a:pos x="csX16" y="csY16"/>
+                  </a:cxn>
+                  <a:cxn ang="0">
+                    <a:pos x="csX17" y="csY17"/>
+                  </a:cxn>
+                  <a:cxn ang="0">
+                    <a:pos x="csX18" y="csY18"/>
+                  </a:cxn>
+                  <a:cxn ang="0">
+                    <a:pos x="csX19" y="csY19"/>
+                  </a:cxn>
+                  <a:cxn ang="0">
+                    <a:pos x="csX20" y="csY20"/>
+                  </a:cxn>
+                  <a:cxn ang="0">
+                    <a:pos x="csX21" y="csY21"/>
+                  </a:cxn>
+                  <a:cxn ang="0">
+                    <a:pos x="csX22" y="csY22"/>
+                  </a:cxn>
+                  <a:cxn ang="0">
+                    <a:pos x="csX23" y="csY23"/>
+                  </a:cxn>
+                  <a:cxn ang="0">
+                    <a:pos x="csX24" y="csY24"/>
+                  </a:cxn>
+                  <a:cxn ang="0">
+                    <a:pos x="csX25" y="csY25"/>
+                  </a:cxn>
+                  <a:cxn ang="0">
+                    <a:pos x="csX26" y="csY26"/>
+                  </a:cxn>
+                  <a:cxn ang="0">
+                    <a:pos x="csX27" y="csY27"/>
+                  </a:cxn>
+                  <a:cxn ang="0">
+                    <a:pos x="csX28" y="csY28"/>
+                  </a:cxn>
+                  <a:cxn ang="0">
+                    <a:pos x="csX29" y="csY29"/>
+                  </a:cxn>
+                  <a:cxn ang="0">
+                    <a:pos x="csX30" y="csY30"/>
+                  </a:cxn>
+                  <a:cxn ang="0">
+                    <a:pos x="csX31" y="csY31"/>
+                  </a:cxn>
+                  <a:cxn ang="0">
+                    <a:pos x="csX32" y="csY32"/>
+                  </a:cxn>
+                </a:cxnLst>
+                <a:rect l="l" t="t" r="r" b="b"/>
+                <a:pathLst>
+                  <a:path w="2438400" h="2438401">
+                    <a:moveTo>
+                      <a:pt x="2162174" y="1015509"/>
+                    </a:moveTo>
+                    <a:lnTo>
+                      <a:pt x="2226113" y="1031950"/>
+                    </a:lnTo>
+                    <a:cubicBezTo>
+                      <a:pt x="2294683" y="1045981"/>
+                      <a:pt x="2365681" y="1053350"/>
+                      <a:pt x="2438400" y="1053350"/>
+                    </a:cubicBezTo>
+                    <a:lnTo>
+                      <a:pt x="2438400" y="2438401"/>
+                    </a:lnTo>
+                    <a:lnTo>
+                      <a:pt x="2162174" y="2438401"/>
+                    </a:lnTo>
+                    <a:close/>
+                    <a:moveTo>
+                      <a:pt x="1385048" y="0"/>
+                    </a:moveTo>
+                    <a:lnTo>
+                      <a:pt x="1659489" y="0"/>
+                    </a:lnTo>
+                    <a:lnTo>
+                      <a:pt x="1663510" y="79636"/>
+                    </a:lnTo>
+                    <a:cubicBezTo>
+                      <a:pt x="1666170" y="105821"/>
+                      <a:pt x="1670126" y="131622"/>
+                      <a:pt x="1675314" y="156975"/>
+                    </a:cubicBezTo>
+                    <a:lnTo>
+                      <a:pt x="1712331" y="276225"/>
+                    </a:lnTo>
+                    <a:lnTo>
+                      <a:pt x="1712330" y="276225"/>
+                    </a:lnTo>
+                    <a:lnTo>
+                      <a:pt x="1720699" y="303185"/>
+                    </a:lnTo>
+                    <a:cubicBezTo>
+                      <a:pt x="1799529" y="489560"/>
+                      <a:pt x="1948837" y="638868"/>
+                      <a:pt x="2135212" y="717698"/>
+                    </a:cubicBezTo>
+                    <a:lnTo>
+                      <a:pt x="2162174" y="726067"/>
+                    </a:lnTo>
+                    <a:lnTo>
+                      <a:pt x="2162174" y="726067"/>
+                    </a:lnTo>
+                    <a:lnTo>
+                      <a:pt x="2281422" y="763084"/>
+                    </a:lnTo>
+                    <a:cubicBezTo>
+                      <a:pt x="2332127" y="773460"/>
+                      <a:pt x="2384627" y="778909"/>
+                      <a:pt x="2438400" y="778909"/>
+                    </a:cubicBezTo>
+                    <a:lnTo>
+                      <a:pt x="2438400" y="1053350"/>
+                    </a:lnTo>
+                    <a:cubicBezTo>
+                      <a:pt x="2365681" y="1053350"/>
+                      <a:pt x="2294683" y="1045981"/>
+                      <a:pt x="2226113" y="1031950"/>
+                    </a:cubicBezTo>
+                    <a:lnTo>
+                      <a:pt x="2162174" y="1015509"/>
+                    </a:lnTo>
+                    <a:lnTo>
+                      <a:pt x="2162174" y="1015509"/>
+                    </a:lnTo>
+                    <a:lnTo>
+                      <a:pt x="2125165" y="1005993"/>
+                    </a:lnTo>
+                    <a:cubicBezTo>
+                      <a:pt x="1795329" y="903404"/>
+                      <a:pt x="1534993" y="643068"/>
+                      <a:pt x="1432404" y="313232"/>
+                    </a:cubicBezTo>
+                    <a:lnTo>
+                      <a:pt x="1422888" y="276225"/>
+                    </a:lnTo>
+                    <a:lnTo>
+                      <a:pt x="1422889" y="276225"/>
+                    </a:lnTo>
+                    <a:lnTo>
+                      <a:pt x="1406448" y="212284"/>
+                    </a:lnTo>
+                    <a:cubicBezTo>
+                      <a:pt x="1399433" y="177999"/>
+                      <a:pt x="1394082" y="143107"/>
+                      <a:pt x="1390486" y="107696"/>
+                    </a:cubicBezTo>
+                    <a:close/>
+                    <a:moveTo>
+                      <a:pt x="0" y="0"/>
+                    </a:moveTo>
+                    <a:lnTo>
+                      <a:pt x="1385047" y="0"/>
+                    </a:lnTo>
+                    <a:lnTo>
+                      <a:pt x="1390485" y="107696"/>
+                    </a:lnTo>
+                    <a:cubicBezTo>
+                      <a:pt x="1394081" y="143107"/>
+                      <a:pt x="1399432" y="177999"/>
+                      <a:pt x="1406447" y="212284"/>
+                    </a:cubicBezTo>
+                    <a:lnTo>
+                      <a:pt x="1422888" y="276225"/>
+                    </a:lnTo>
+                    <a:lnTo>
+                      <a:pt x="0" y="276225"/>
+                    </a:lnTo>
+                    <a:close/>
+                  </a:path>
+                </a:pathLst>
+              </a:custGeom>
+              <a:solidFill>
+                <a:schemeClr val="tx1"/>
+              </a:solidFill>
+              <a:ln>
+                <a:noFill/>
+              </a:ln>
+            </p:spPr>
+            <p:style>
+              <a:lnRef idx="2">
+                <a:schemeClr val="accent1">
+                  <a:shade val="15000"/>
+                </a:schemeClr>
+              </a:lnRef>
+              <a:fillRef idx="1">
+                <a:schemeClr val="accent1"/>
+              </a:fillRef>
+              <a:effectRef idx="0">
+                <a:schemeClr val="accent1"/>
+              </a:effectRef>
+              <a:fontRef idx="minor">
+                <a:schemeClr val="lt1"/>
+              </a:fontRef>
+            </p:style>
+            <p:txBody>
+              <a:bodyPr wrap="square" rtlCol="0" anchor="ctr">
+                <a:noAutofit/>
+              </a:bodyPr>
+              <a:lstStyle/>
+              <a:p>
+                <a:pPr algn="ctr"/>
+                <a:endParaRPr lang="ko-KR" altLang="en-US" dirty="0"/>
+              </a:p>
+            </p:txBody>
+          </p:sp>
+          <p:sp>
+            <p:nvSpPr>
+              <p:cNvPr id="20" name="Freeform: Shape 19">
+                <a:extLst>
+                  <a:ext uri="{FF2B5EF4-FFF2-40B4-BE49-F238E27FC236}">
+                    <a16:creationId xmlns:a16="http://schemas.microsoft.com/office/drawing/2014/main" id="{67323404-D13B-252F-EF5D-D3375CD975D6}"/>
+                  </a:ext>
+                </a:extLst>
+              </p:cNvPr>
+              <p:cNvSpPr/>
+              <p:nvPr/>
+            </p:nvSpPr>
+            <p:spPr>
+              <a:xfrm rot="5400000">
+                <a:off x="7102697" y="5481921"/>
+                <a:ext cx="1362631" cy="1362632"/>
+              </a:xfrm>
+              <a:custGeom>
+                <a:avLst/>
+                <a:gdLst>
+                  <a:gd name="csX0" fmla="*/ 2162174 w 2438400"/>
+                  <a:gd name="csY0" fmla="*/ 1015509 h 2438401"/>
+                  <a:gd name="csX1" fmla="*/ 2226113 w 2438400"/>
+                  <a:gd name="csY1" fmla="*/ 1031950 h 2438401"/>
+                  <a:gd name="csX2" fmla="*/ 2438400 w 2438400"/>
+                  <a:gd name="csY2" fmla="*/ 1053350 h 2438401"/>
+                  <a:gd name="csX3" fmla="*/ 2438400 w 2438400"/>
+                  <a:gd name="csY3" fmla="*/ 2438401 h 2438401"/>
+                  <a:gd name="csX4" fmla="*/ 2162174 w 2438400"/>
+                  <a:gd name="csY4" fmla="*/ 2438401 h 2438401"/>
+                  <a:gd name="csX5" fmla="*/ 1385048 w 2438400"/>
+                  <a:gd name="csY5" fmla="*/ 0 h 2438401"/>
+                  <a:gd name="csX6" fmla="*/ 1659489 w 2438400"/>
+                  <a:gd name="csY6" fmla="*/ 0 h 2438401"/>
+                  <a:gd name="csX7" fmla="*/ 1663510 w 2438400"/>
+                  <a:gd name="csY7" fmla="*/ 79636 h 2438401"/>
+                  <a:gd name="csX8" fmla="*/ 1675314 w 2438400"/>
+                  <a:gd name="csY8" fmla="*/ 156975 h 2438401"/>
+                  <a:gd name="csX9" fmla="*/ 1712331 w 2438400"/>
+                  <a:gd name="csY9" fmla="*/ 276225 h 2438401"/>
+                  <a:gd name="csX10" fmla="*/ 1712330 w 2438400"/>
+                  <a:gd name="csY10" fmla="*/ 276225 h 2438401"/>
+                  <a:gd name="csX11" fmla="*/ 1720699 w 2438400"/>
+                  <a:gd name="csY11" fmla="*/ 303185 h 2438401"/>
+                  <a:gd name="csX12" fmla="*/ 2135212 w 2438400"/>
+                  <a:gd name="csY12" fmla="*/ 717698 h 2438401"/>
+                  <a:gd name="csX13" fmla="*/ 2162174 w 2438400"/>
+                  <a:gd name="csY13" fmla="*/ 726067 h 2438401"/>
+                  <a:gd name="csX14" fmla="*/ 2162174 w 2438400"/>
+                  <a:gd name="csY14" fmla="*/ 726067 h 2438401"/>
+                  <a:gd name="csX15" fmla="*/ 2281422 w 2438400"/>
+                  <a:gd name="csY15" fmla="*/ 763084 h 2438401"/>
+                  <a:gd name="csX16" fmla="*/ 2438400 w 2438400"/>
+                  <a:gd name="csY16" fmla="*/ 778909 h 2438401"/>
+                  <a:gd name="csX17" fmla="*/ 2438400 w 2438400"/>
+                  <a:gd name="csY17" fmla="*/ 1053350 h 2438401"/>
+                  <a:gd name="csX18" fmla="*/ 2226113 w 2438400"/>
+                  <a:gd name="csY18" fmla="*/ 1031950 h 2438401"/>
+                  <a:gd name="csX19" fmla="*/ 2162174 w 2438400"/>
+                  <a:gd name="csY19" fmla="*/ 1015509 h 2438401"/>
+                  <a:gd name="csX20" fmla="*/ 2162174 w 2438400"/>
+                  <a:gd name="csY20" fmla="*/ 1015509 h 2438401"/>
+                  <a:gd name="csX21" fmla="*/ 2125165 w 2438400"/>
+                  <a:gd name="csY21" fmla="*/ 1005993 h 2438401"/>
+                  <a:gd name="csX22" fmla="*/ 1432404 w 2438400"/>
+                  <a:gd name="csY22" fmla="*/ 313232 h 2438401"/>
+                  <a:gd name="csX23" fmla="*/ 1422888 w 2438400"/>
+                  <a:gd name="csY23" fmla="*/ 276225 h 2438401"/>
+                  <a:gd name="csX24" fmla="*/ 1422889 w 2438400"/>
+                  <a:gd name="csY24" fmla="*/ 276225 h 2438401"/>
+                  <a:gd name="csX25" fmla="*/ 1406448 w 2438400"/>
+                  <a:gd name="csY25" fmla="*/ 212284 h 2438401"/>
+                  <a:gd name="csX26" fmla="*/ 1390486 w 2438400"/>
+                  <a:gd name="csY26" fmla="*/ 107696 h 2438401"/>
+                  <a:gd name="csX27" fmla="*/ 0 w 2438400"/>
+                  <a:gd name="csY27" fmla="*/ 0 h 2438401"/>
+                  <a:gd name="csX28" fmla="*/ 1385047 w 2438400"/>
+                  <a:gd name="csY28" fmla="*/ 0 h 2438401"/>
+                  <a:gd name="csX29" fmla="*/ 1390485 w 2438400"/>
+                  <a:gd name="csY29" fmla="*/ 107696 h 2438401"/>
+                  <a:gd name="csX30" fmla="*/ 1406447 w 2438400"/>
+                  <a:gd name="csY30" fmla="*/ 212284 h 2438401"/>
+                  <a:gd name="csX31" fmla="*/ 1422888 w 2438400"/>
+                  <a:gd name="csY31" fmla="*/ 276225 h 2438401"/>
+                  <a:gd name="csX32" fmla="*/ 0 w 2438400"/>
+                  <a:gd name="csY32" fmla="*/ 276225 h 2438401"/>
+                </a:gdLst>
+                <a:ahLst/>
+                <a:cxnLst>
+                  <a:cxn ang="0">
+                    <a:pos x="csX0" y="csY0"/>
+                  </a:cxn>
+                  <a:cxn ang="0">
+                    <a:pos x="csX1" y="csY1"/>
+                  </a:cxn>
+                  <a:cxn ang="0">
+                    <a:pos x="csX2" y="csY2"/>
+                  </a:cxn>
+                  <a:cxn ang="0">
+                    <a:pos x="csX3" y="csY3"/>
+                  </a:cxn>
+                  <a:cxn ang="0">
+                    <a:pos x="csX4" y="csY4"/>
+                  </a:cxn>
+                  <a:cxn ang="0">
+                    <a:pos x="csX5" y="csY5"/>
+                  </a:cxn>
+                  <a:cxn ang="0">
+                    <a:pos x="csX6" y="csY6"/>
+                  </a:cxn>
+                  <a:cxn ang="0">
+                    <a:pos x="csX7" y="csY7"/>
+                  </a:cxn>
+                  <a:cxn ang="0">
+                    <a:pos x="csX8" y="csY8"/>
+                  </a:cxn>
+                  <a:cxn ang="0">
+                    <a:pos x="csX9" y="csY9"/>
+                  </a:cxn>
+                  <a:cxn ang="0">
+                    <a:pos x="csX10" y="csY10"/>
+                  </a:cxn>
+                  <a:cxn ang="0">
+                    <a:pos x="csX11" y="csY11"/>
+                  </a:cxn>
+                  <a:cxn ang="0">
+                    <a:pos x="csX12" y="csY12"/>
+                  </a:cxn>
+                  <a:cxn ang="0">
+                    <a:pos x="csX13" y="csY13"/>
+                  </a:cxn>
+                  <a:cxn ang="0">
+                    <a:pos x="csX14" y="csY14"/>
+                  </a:cxn>
+                  <a:cxn ang="0">
+                    <a:pos x="csX15" y="csY15"/>
+                  </a:cxn>
+                  <a:cxn ang="0">
+                    <a:pos x="csX16" y="csY16"/>
+                  </a:cxn>
+                  <a:cxn ang="0">
+                    <a:pos x="csX17" y="csY17"/>
+                  </a:cxn>
+                  <a:cxn ang="0">
+                    <a:pos x="csX18" y="csY18"/>
+                  </a:cxn>
+                  <a:cxn ang="0">
+                    <a:pos x="csX19" y="csY19"/>
+                  </a:cxn>
+                  <a:cxn ang="0">
+                    <a:pos x="csX20" y="csY20"/>
+                  </a:cxn>
+                  <a:cxn ang="0">
+                    <a:pos x="csX21" y="csY21"/>
+                  </a:cxn>
+                  <a:cxn ang="0">
+                    <a:pos x="csX22" y="csY22"/>
+                  </a:cxn>
+                  <a:cxn ang="0">
+                    <a:pos x="csX23" y="csY23"/>
+                  </a:cxn>
+                  <a:cxn ang="0">
+                    <a:pos x="csX24" y="csY24"/>
+                  </a:cxn>
+                  <a:cxn ang="0">
+                    <a:pos x="csX25" y="csY25"/>
+                  </a:cxn>
+                  <a:cxn ang="0">
+                    <a:pos x="csX26" y="csY26"/>
+                  </a:cxn>
+                  <a:cxn ang="0">
+                    <a:pos x="csX27" y="csY27"/>
+                  </a:cxn>
+                  <a:cxn ang="0">
+                    <a:pos x="csX28" y="csY28"/>
+                  </a:cxn>
+                  <a:cxn ang="0">
+                    <a:pos x="csX29" y="csY29"/>
+                  </a:cxn>
+                  <a:cxn ang="0">
+                    <a:pos x="csX30" y="csY30"/>
+                  </a:cxn>
+                  <a:cxn ang="0">
+                    <a:pos x="csX31" y="csY31"/>
+                  </a:cxn>
+                  <a:cxn ang="0">
+                    <a:pos x="csX32" y="csY32"/>
+                  </a:cxn>
+                </a:cxnLst>
+                <a:rect l="l" t="t" r="r" b="b"/>
+                <a:pathLst>
+                  <a:path w="2438400" h="2438401">
+                    <a:moveTo>
+                      <a:pt x="2162174" y="1015509"/>
+                    </a:moveTo>
+                    <a:lnTo>
+                      <a:pt x="2226113" y="1031950"/>
+                    </a:lnTo>
+                    <a:cubicBezTo>
+                      <a:pt x="2294683" y="1045981"/>
+                      <a:pt x="2365681" y="1053350"/>
+                      <a:pt x="2438400" y="1053350"/>
+                    </a:cubicBezTo>
+                    <a:lnTo>
+                      <a:pt x="2438400" y="2438401"/>
+                    </a:lnTo>
+                    <a:lnTo>
+                      <a:pt x="2162174" y="2438401"/>
+                    </a:lnTo>
+                    <a:close/>
+                    <a:moveTo>
+                      <a:pt x="1385048" y="0"/>
+                    </a:moveTo>
+                    <a:lnTo>
+                      <a:pt x="1659489" y="0"/>
+                    </a:lnTo>
+                    <a:lnTo>
+                      <a:pt x="1663510" y="79636"/>
+                    </a:lnTo>
+                    <a:cubicBezTo>
+                      <a:pt x="1666170" y="105821"/>
+                      <a:pt x="1670126" y="131622"/>
+                      <a:pt x="1675314" y="156975"/>
+                    </a:cubicBezTo>
+                    <a:lnTo>
+                      <a:pt x="1712331" y="276225"/>
+                    </a:lnTo>
+                    <a:lnTo>
+                      <a:pt x="1712330" y="276225"/>
+                    </a:lnTo>
+                    <a:lnTo>
+                      <a:pt x="1720699" y="303185"/>
+                    </a:lnTo>
+                    <a:cubicBezTo>
+                      <a:pt x="1799529" y="489560"/>
+                      <a:pt x="1948837" y="638868"/>
+                      <a:pt x="2135212" y="717698"/>
+                    </a:cubicBezTo>
+                    <a:lnTo>
+                      <a:pt x="2162174" y="726067"/>
+                    </a:lnTo>
+                    <a:lnTo>
+                      <a:pt x="2162174" y="726067"/>
+                    </a:lnTo>
+                    <a:lnTo>
+                      <a:pt x="2281422" y="763084"/>
+                    </a:lnTo>
+                    <a:cubicBezTo>
+                      <a:pt x="2332127" y="773460"/>
+                      <a:pt x="2384627" y="778909"/>
+                      <a:pt x="2438400" y="778909"/>
+                    </a:cubicBezTo>
+                    <a:lnTo>
+                      <a:pt x="2438400" y="1053350"/>
+                    </a:lnTo>
+                    <a:cubicBezTo>
+                      <a:pt x="2365681" y="1053350"/>
+                      <a:pt x="2294683" y="1045981"/>
+                      <a:pt x="2226113" y="1031950"/>
+                    </a:cubicBezTo>
+                    <a:lnTo>
+                      <a:pt x="2162174" y="1015509"/>
+                    </a:lnTo>
+                    <a:lnTo>
+                      <a:pt x="2162174" y="1015509"/>
+                    </a:lnTo>
+                    <a:lnTo>
+                      <a:pt x="2125165" y="1005993"/>
+                    </a:lnTo>
+                    <a:cubicBezTo>
+                      <a:pt x="1795329" y="903404"/>
+                      <a:pt x="1534993" y="643068"/>
+                      <a:pt x="1432404" y="313232"/>
+                    </a:cubicBezTo>
+                    <a:lnTo>
+                      <a:pt x="1422888" y="276225"/>
+                    </a:lnTo>
+                    <a:lnTo>
+                      <a:pt x="1422889" y="276225"/>
+                    </a:lnTo>
+                    <a:lnTo>
+                      <a:pt x="1406448" y="212284"/>
+                    </a:lnTo>
+                    <a:cubicBezTo>
+                      <a:pt x="1399433" y="177999"/>
+                      <a:pt x="1394082" y="143107"/>
+                      <a:pt x="1390486" y="107696"/>
+                    </a:cubicBezTo>
+                    <a:close/>
+                    <a:moveTo>
+                      <a:pt x="0" y="0"/>
+                    </a:moveTo>
+                    <a:lnTo>
+                      <a:pt x="1385047" y="0"/>
+                    </a:lnTo>
+                    <a:lnTo>
+                      <a:pt x="1390485" y="107696"/>
+                    </a:lnTo>
+                    <a:cubicBezTo>
+                      <a:pt x="1394081" y="143107"/>
+                      <a:pt x="1399432" y="177999"/>
+                      <a:pt x="1406447" y="212284"/>
+                    </a:cubicBezTo>
+                    <a:lnTo>
+                      <a:pt x="1422888" y="276225"/>
+                    </a:lnTo>
+                    <a:lnTo>
+                      <a:pt x="0" y="276225"/>
+                    </a:lnTo>
+                    <a:close/>
+                  </a:path>
+                </a:pathLst>
+              </a:custGeom>
+              <a:solidFill>
+                <a:schemeClr val="tx1"/>
+              </a:solidFill>
+              <a:ln>
+                <a:noFill/>
+              </a:ln>
+            </p:spPr>
+            <p:style>
+              <a:lnRef idx="2">
+                <a:schemeClr val="accent1">
+                  <a:shade val="15000"/>
+                </a:schemeClr>
+              </a:lnRef>
+              <a:fillRef idx="1">
+                <a:schemeClr val="accent1"/>
+              </a:fillRef>
+              <a:effectRef idx="0">
+                <a:schemeClr val="accent1"/>
+              </a:effectRef>
+              <a:fontRef idx="minor">
+                <a:schemeClr val="lt1"/>
+              </a:fontRef>
+            </p:style>
+            <p:txBody>
+              <a:bodyPr wrap="square" rtlCol="0" anchor="ctr">
+                <a:noAutofit/>
+              </a:bodyPr>
+              <a:lstStyle/>
+              <a:p>
+                <a:pPr algn="ctr"/>
+                <a:endParaRPr lang="ko-KR" altLang="en-US" dirty="0"/>
+              </a:p>
+            </p:txBody>
+          </p:sp>
+          <p:sp>
+            <p:nvSpPr>
+              <p:cNvPr id="21" name="Rectangle 20">
+                <a:extLst>
+                  <a:ext uri="{FF2B5EF4-FFF2-40B4-BE49-F238E27FC236}">
+                    <a16:creationId xmlns:a16="http://schemas.microsoft.com/office/drawing/2014/main" id="{8650C2C3-349E-43F8-0E16-5180B502C03C}"/>
+                  </a:ext>
+                </a:extLst>
+              </p:cNvPr>
+              <p:cNvSpPr/>
+              <p:nvPr/>
+            </p:nvSpPr>
+            <p:spPr>
+              <a:xfrm>
+                <a:off x="8310562" y="4271680"/>
+                <a:ext cx="154765" cy="1210241"/>
+              </a:xfrm>
+              <a:prstGeom prst="rect">
+                <a:avLst/>
+              </a:prstGeom>
+              <a:solidFill>
+                <a:schemeClr val="tx1"/>
+              </a:solidFill>
+              <a:ln>
+                <a:noFill/>
+              </a:ln>
+            </p:spPr>
+            <p:style>
+              <a:lnRef idx="2">
+                <a:schemeClr val="accent1">
+                  <a:shade val="15000"/>
+                </a:schemeClr>
+              </a:lnRef>
+              <a:fillRef idx="1">
+                <a:schemeClr val="accent1"/>
+              </a:fillRef>
+              <a:effectRef idx="0">
+                <a:schemeClr val="accent1"/>
+              </a:effectRef>
+              <a:fontRef idx="minor">
+                <a:schemeClr val="lt1"/>
+              </a:fontRef>
+            </p:style>
+            <p:txBody>
+              <a:bodyPr rtlCol="0" anchor="ctr"/>
+              <a:lstStyle/>
+              <a:p>
+                <a:pPr algn="ctr"/>
+                <a:endParaRPr lang="ko-KR" altLang="en-US"/>
+              </a:p>
+            </p:txBody>
+          </p:sp>
+          <p:sp>
+            <p:nvSpPr>
+              <p:cNvPr id="22" name="Rectangle 21">
+                <a:extLst>
+                  <a:ext uri="{FF2B5EF4-FFF2-40B4-BE49-F238E27FC236}">
+                    <a16:creationId xmlns:a16="http://schemas.microsoft.com/office/drawing/2014/main" id="{0413D1E2-1257-BC66-A79A-0BE330D1E7BF}"/>
+                  </a:ext>
+                </a:extLst>
+              </p:cNvPr>
+              <p:cNvSpPr/>
+              <p:nvPr/>
+            </p:nvSpPr>
+            <p:spPr>
+              <a:xfrm rot="5400000">
+                <a:off x="4799416" y="4541272"/>
+                <a:ext cx="154765" cy="4451793"/>
+              </a:xfrm>
+              <a:prstGeom prst="rect">
+                <a:avLst/>
+              </a:prstGeom>
+              <a:solidFill>
+                <a:schemeClr val="tx1"/>
+              </a:solidFill>
+              <a:ln>
+                <a:noFill/>
+              </a:ln>
+            </p:spPr>
+            <p:style>
+              <a:lnRef idx="2">
+                <a:schemeClr val="accent1">
+                  <a:shade val="15000"/>
+                </a:schemeClr>
+              </a:lnRef>
+              <a:fillRef idx="1">
+                <a:schemeClr val="accent1"/>
+              </a:fillRef>
+              <a:effectRef idx="0">
+                <a:schemeClr val="accent1"/>
+              </a:effectRef>
+              <a:fontRef idx="minor">
+                <a:schemeClr val="lt1"/>
+              </a:fontRef>
+            </p:style>
+            <p:txBody>
+              <a:bodyPr rtlCol="0" anchor="ctr"/>
+              <a:lstStyle/>
+              <a:p>
+                <a:pPr algn="ctr"/>
+                <a:endParaRPr lang="ko-KR" altLang="en-US"/>
+              </a:p>
+            </p:txBody>
+          </p:sp>
+        </p:grpSp>
+        <p:grpSp>
+          <p:nvGrpSpPr>
+            <p:cNvPr id="28" name="Group 27">
+              <a:extLst>
+                <a:ext uri="{FF2B5EF4-FFF2-40B4-BE49-F238E27FC236}">
+                  <a16:creationId xmlns:a16="http://schemas.microsoft.com/office/drawing/2014/main" id="{BD9C92FA-95BB-271D-E063-A4B10B557D7A}"/>
+                </a:ext>
+              </a:extLst>
+            </p:cNvPr>
+            <p:cNvGrpSpPr/>
+            <p:nvPr/>
+          </p:nvGrpSpPr>
+          <p:grpSpPr>
+            <a:xfrm flipV="1">
+              <a:off x="1288268" y="2909048"/>
+              <a:ext cx="7177058" cy="3935504"/>
+              <a:chOff x="1288268" y="2909048"/>
+              <a:chExt cx="7177058" cy="3935503"/>
+            </a:xfrm>
+          </p:grpSpPr>
+          <p:sp>
+            <p:nvSpPr>
+              <p:cNvPr id="24" name="Freeform: Shape 23">
+                <a:extLst>
+                  <a:ext uri="{FF2B5EF4-FFF2-40B4-BE49-F238E27FC236}">
+                    <a16:creationId xmlns:a16="http://schemas.microsoft.com/office/drawing/2014/main" id="{BE54B3F5-812C-B087-293B-33CF4DEEAD3B}"/>
+                  </a:ext>
+                </a:extLst>
+              </p:cNvPr>
+              <p:cNvSpPr/>
+              <p:nvPr/>
+            </p:nvSpPr>
+            <p:spPr>
+              <a:xfrm rot="5400000">
+                <a:off x="7102694" y="5481920"/>
+                <a:ext cx="1362631" cy="1362632"/>
+              </a:xfrm>
+              <a:custGeom>
+                <a:avLst/>
+                <a:gdLst>
+                  <a:gd name="csX0" fmla="*/ 2162174 w 2438400"/>
+                  <a:gd name="csY0" fmla="*/ 1015509 h 2438401"/>
+                  <a:gd name="csX1" fmla="*/ 2226113 w 2438400"/>
+                  <a:gd name="csY1" fmla="*/ 1031950 h 2438401"/>
+                  <a:gd name="csX2" fmla="*/ 2438400 w 2438400"/>
+                  <a:gd name="csY2" fmla="*/ 1053350 h 2438401"/>
+                  <a:gd name="csX3" fmla="*/ 2438400 w 2438400"/>
+                  <a:gd name="csY3" fmla="*/ 2438401 h 2438401"/>
+                  <a:gd name="csX4" fmla="*/ 2162174 w 2438400"/>
+                  <a:gd name="csY4" fmla="*/ 2438401 h 2438401"/>
+                  <a:gd name="csX5" fmla="*/ 1385048 w 2438400"/>
+                  <a:gd name="csY5" fmla="*/ 0 h 2438401"/>
+                  <a:gd name="csX6" fmla="*/ 1659489 w 2438400"/>
+                  <a:gd name="csY6" fmla="*/ 0 h 2438401"/>
+                  <a:gd name="csX7" fmla="*/ 1663510 w 2438400"/>
+                  <a:gd name="csY7" fmla="*/ 79636 h 2438401"/>
+                  <a:gd name="csX8" fmla="*/ 1675314 w 2438400"/>
+                  <a:gd name="csY8" fmla="*/ 156975 h 2438401"/>
+                  <a:gd name="csX9" fmla="*/ 1712331 w 2438400"/>
+                  <a:gd name="csY9" fmla="*/ 276225 h 2438401"/>
+                  <a:gd name="csX10" fmla="*/ 1712330 w 2438400"/>
+                  <a:gd name="csY10" fmla="*/ 276225 h 2438401"/>
+                  <a:gd name="csX11" fmla="*/ 1720699 w 2438400"/>
+                  <a:gd name="csY11" fmla="*/ 303185 h 2438401"/>
+                  <a:gd name="csX12" fmla="*/ 2135212 w 2438400"/>
+                  <a:gd name="csY12" fmla="*/ 717698 h 2438401"/>
+                  <a:gd name="csX13" fmla="*/ 2162174 w 2438400"/>
+                  <a:gd name="csY13" fmla="*/ 726067 h 2438401"/>
+                  <a:gd name="csX14" fmla="*/ 2162174 w 2438400"/>
+                  <a:gd name="csY14" fmla="*/ 726067 h 2438401"/>
+                  <a:gd name="csX15" fmla="*/ 2281422 w 2438400"/>
+                  <a:gd name="csY15" fmla="*/ 763084 h 2438401"/>
+                  <a:gd name="csX16" fmla="*/ 2438400 w 2438400"/>
+                  <a:gd name="csY16" fmla="*/ 778909 h 2438401"/>
+                  <a:gd name="csX17" fmla="*/ 2438400 w 2438400"/>
+                  <a:gd name="csY17" fmla="*/ 1053350 h 2438401"/>
+                  <a:gd name="csX18" fmla="*/ 2226113 w 2438400"/>
+                  <a:gd name="csY18" fmla="*/ 1031950 h 2438401"/>
+                  <a:gd name="csX19" fmla="*/ 2162174 w 2438400"/>
+                  <a:gd name="csY19" fmla="*/ 1015509 h 2438401"/>
+                  <a:gd name="csX20" fmla="*/ 2162174 w 2438400"/>
+                  <a:gd name="csY20" fmla="*/ 1015509 h 2438401"/>
+                  <a:gd name="csX21" fmla="*/ 2125165 w 2438400"/>
+                  <a:gd name="csY21" fmla="*/ 1005993 h 2438401"/>
+                  <a:gd name="csX22" fmla="*/ 1432404 w 2438400"/>
+                  <a:gd name="csY22" fmla="*/ 313232 h 2438401"/>
+                  <a:gd name="csX23" fmla="*/ 1422888 w 2438400"/>
+                  <a:gd name="csY23" fmla="*/ 276225 h 2438401"/>
+                  <a:gd name="csX24" fmla="*/ 1422889 w 2438400"/>
+                  <a:gd name="csY24" fmla="*/ 276225 h 2438401"/>
+                  <a:gd name="csX25" fmla="*/ 1406448 w 2438400"/>
+                  <a:gd name="csY25" fmla="*/ 212284 h 2438401"/>
+                  <a:gd name="csX26" fmla="*/ 1390486 w 2438400"/>
+                  <a:gd name="csY26" fmla="*/ 107696 h 2438401"/>
+                  <a:gd name="csX27" fmla="*/ 0 w 2438400"/>
+                  <a:gd name="csY27" fmla="*/ 0 h 2438401"/>
+                  <a:gd name="csX28" fmla="*/ 1385047 w 2438400"/>
+                  <a:gd name="csY28" fmla="*/ 0 h 2438401"/>
+                  <a:gd name="csX29" fmla="*/ 1390485 w 2438400"/>
+                  <a:gd name="csY29" fmla="*/ 107696 h 2438401"/>
+                  <a:gd name="csX30" fmla="*/ 1406447 w 2438400"/>
+                  <a:gd name="csY30" fmla="*/ 212284 h 2438401"/>
+                  <a:gd name="csX31" fmla="*/ 1422888 w 2438400"/>
+                  <a:gd name="csY31" fmla="*/ 276225 h 2438401"/>
+                  <a:gd name="csX32" fmla="*/ 0 w 2438400"/>
+                  <a:gd name="csY32" fmla="*/ 276225 h 2438401"/>
+                </a:gdLst>
+                <a:ahLst/>
+                <a:cxnLst>
+                  <a:cxn ang="0">
+                    <a:pos x="csX0" y="csY0"/>
+                  </a:cxn>
+                  <a:cxn ang="0">
+                    <a:pos x="csX1" y="csY1"/>
+                  </a:cxn>
+                  <a:cxn ang="0">
+                    <a:pos x="csX2" y="csY2"/>
+                  </a:cxn>
+                  <a:cxn ang="0">
+                    <a:pos x="csX3" y="csY3"/>
+                  </a:cxn>
+                  <a:cxn ang="0">
+                    <a:pos x="csX4" y="csY4"/>
+                  </a:cxn>
+                  <a:cxn ang="0">
+                    <a:pos x="csX5" y="csY5"/>
+                  </a:cxn>
+                  <a:cxn ang="0">
+                    <a:pos x="csX6" y="csY6"/>
+                  </a:cxn>
+                  <a:cxn ang="0">
+                    <a:pos x="csX7" y="csY7"/>
+                  </a:cxn>
+                  <a:cxn ang="0">
+                    <a:pos x="csX8" y="csY8"/>
+                  </a:cxn>
+                  <a:cxn ang="0">
+                    <a:pos x="csX9" y="csY9"/>
+                  </a:cxn>
+                  <a:cxn ang="0">
+                    <a:pos x="csX10" y="csY10"/>
+                  </a:cxn>
+                  <a:cxn ang="0">
+                    <a:pos x="csX11" y="csY11"/>
+                  </a:cxn>
+                  <a:cxn ang="0">
+                    <a:pos x="csX12" y="csY12"/>
+                  </a:cxn>
+                  <a:cxn ang="0">
+                    <a:pos x="csX13" y="csY13"/>
+                  </a:cxn>
+                  <a:cxn ang="0">
+                    <a:pos x="csX14" y="csY14"/>
+                  </a:cxn>
+                  <a:cxn ang="0">
+                    <a:pos x="csX15" y="csY15"/>
+                  </a:cxn>
+                  <a:cxn ang="0">
+                    <a:pos x="csX16" y="csY16"/>
+                  </a:cxn>
+                  <a:cxn ang="0">
+                    <a:pos x="csX17" y="csY17"/>
+                  </a:cxn>
+                  <a:cxn ang="0">
+                    <a:pos x="csX18" y="csY18"/>
+                  </a:cxn>
+                  <a:cxn ang="0">
+                    <a:pos x="csX19" y="csY19"/>
+                  </a:cxn>
+                  <a:cxn ang="0">
+                    <a:pos x="csX20" y="csY20"/>
+                  </a:cxn>
+                  <a:cxn ang="0">
+                    <a:pos x="csX21" y="csY21"/>
+                  </a:cxn>
+                  <a:cxn ang="0">
+                    <a:pos x="csX22" y="csY22"/>
+                  </a:cxn>
+                  <a:cxn ang="0">
+                    <a:pos x="csX23" y="csY23"/>
+                  </a:cxn>
+                  <a:cxn ang="0">
+                    <a:pos x="csX24" y="csY24"/>
+                  </a:cxn>
+                  <a:cxn ang="0">
+                    <a:pos x="csX25" y="csY25"/>
+                  </a:cxn>
+                  <a:cxn ang="0">
+                    <a:pos x="csX26" y="csY26"/>
+                  </a:cxn>
+                  <a:cxn ang="0">
+                    <a:pos x="csX27" y="csY27"/>
+                  </a:cxn>
+                  <a:cxn ang="0">
+                    <a:pos x="csX28" y="csY28"/>
+                  </a:cxn>
+                  <a:cxn ang="0">
+                    <a:pos x="csX29" y="csY29"/>
+                  </a:cxn>
+                  <a:cxn ang="0">
+                    <a:pos x="csX30" y="csY30"/>
+                  </a:cxn>
+                  <a:cxn ang="0">
+                    <a:pos x="csX31" y="csY31"/>
+                  </a:cxn>
+                  <a:cxn ang="0">
+                    <a:pos x="csX32" y="csY32"/>
+                  </a:cxn>
+                </a:cxnLst>
+                <a:rect l="l" t="t" r="r" b="b"/>
+                <a:pathLst>
+                  <a:path w="2438400" h="2438401">
+                    <a:moveTo>
+                      <a:pt x="2162174" y="1015509"/>
+                    </a:moveTo>
+                    <a:lnTo>
+                      <a:pt x="2226113" y="1031950"/>
+                    </a:lnTo>
+                    <a:cubicBezTo>
+                      <a:pt x="2294683" y="1045981"/>
+                      <a:pt x="2365681" y="1053350"/>
+                      <a:pt x="2438400" y="1053350"/>
+                    </a:cubicBezTo>
+                    <a:lnTo>
+                      <a:pt x="2438400" y="2438401"/>
+                    </a:lnTo>
+                    <a:lnTo>
+                      <a:pt x="2162174" y="2438401"/>
+                    </a:lnTo>
+                    <a:close/>
+                    <a:moveTo>
+                      <a:pt x="1385048" y="0"/>
+                    </a:moveTo>
+                    <a:lnTo>
+                      <a:pt x="1659489" y="0"/>
+                    </a:lnTo>
+                    <a:lnTo>
+                      <a:pt x="1663510" y="79636"/>
+                    </a:lnTo>
+                    <a:cubicBezTo>
+                      <a:pt x="1666170" y="105821"/>
+                      <a:pt x="1670126" y="131622"/>
+                      <a:pt x="1675314" y="156975"/>
+                    </a:cubicBezTo>
+                    <a:lnTo>
+                      <a:pt x="1712331" y="276225"/>
+                    </a:lnTo>
+                    <a:lnTo>
+                      <a:pt x="1712330" y="276225"/>
+                    </a:lnTo>
+                    <a:lnTo>
+                      <a:pt x="1720699" y="303185"/>
+                    </a:lnTo>
+                    <a:cubicBezTo>
+                      <a:pt x="1799529" y="489560"/>
+                      <a:pt x="1948837" y="638868"/>
+                      <a:pt x="2135212" y="717698"/>
+                    </a:cubicBezTo>
+                    <a:lnTo>
+                      <a:pt x="2162174" y="726067"/>
+                    </a:lnTo>
+                    <a:lnTo>
+                      <a:pt x="2162174" y="726067"/>
+                    </a:lnTo>
+                    <a:lnTo>
+                      <a:pt x="2281422" y="763084"/>
+                    </a:lnTo>
+                    <a:cubicBezTo>
+                      <a:pt x="2332127" y="773460"/>
+                      <a:pt x="2384627" y="778909"/>
+                      <a:pt x="2438400" y="778909"/>
+                    </a:cubicBezTo>
+                    <a:lnTo>
+                      <a:pt x="2438400" y="1053350"/>
+                    </a:lnTo>
+                    <a:cubicBezTo>
+                      <a:pt x="2365681" y="1053350"/>
+                      <a:pt x="2294683" y="1045981"/>
+                      <a:pt x="2226113" y="1031950"/>
+                    </a:cubicBezTo>
+                    <a:lnTo>
+                      <a:pt x="2162174" y="1015509"/>
+                    </a:lnTo>
+                    <a:lnTo>
+                      <a:pt x="2162174" y="1015509"/>
+                    </a:lnTo>
+                    <a:lnTo>
+                      <a:pt x="2125165" y="1005993"/>
+                    </a:lnTo>
+                    <a:cubicBezTo>
+                      <a:pt x="1795329" y="903404"/>
+                      <a:pt x="1534993" y="643068"/>
+                      <a:pt x="1432404" y="313232"/>
+                    </a:cubicBezTo>
+                    <a:lnTo>
+                      <a:pt x="1422888" y="276225"/>
+                    </a:lnTo>
+                    <a:lnTo>
+                      <a:pt x="1422889" y="276225"/>
+                    </a:lnTo>
+                    <a:lnTo>
+                      <a:pt x="1406448" y="212284"/>
+                    </a:lnTo>
+                    <a:cubicBezTo>
+                      <a:pt x="1399433" y="177999"/>
+                      <a:pt x="1394082" y="143107"/>
+                      <a:pt x="1390486" y="107696"/>
+                    </a:cubicBezTo>
+                    <a:close/>
+                    <a:moveTo>
+                      <a:pt x="0" y="0"/>
+                    </a:moveTo>
+                    <a:lnTo>
+                      <a:pt x="1385047" y="0"/>
+                    </a:lnTo>
+                    <a:lnTo>
+                      <a:pt x="1390485" y="107696"/>
+                    </a:lnTo>
+                    <a:cubicBezTo>
+                      <a:pt x="1394081" y="143107"/>
+                      <a:pt x="1399432" y="177999"/>
+                      <a:pt x="1406447" y="212284"/>
+                    </a:cubicBezTo>
+                    <a:lnTo>
+                      <a:pt x="1422888" y="276225"/>
+                    </a:lnTo>
+                    <a:lnTo>
+                      <a:pt x="0" y="276225"/>
+                    </a:lnTo>
+                    <a:close/>
+                  </a:path>
+                </a:pathLst>
+              </a:custGeom>
+              <a:solidFill>
+                <a:schemeClr val="tx1"/>
+              </a:solidFill>
+              <a:ln>
+                <a:noFill/>
+              </a:ln>
+            </p:spPr>
+            <p:style>
+              <a:lnRef idx="2">
+                <a:schemeClr val="accent1">
+                  <a:shade val="15000"/>
+                </a:schemeClr>
+              </a:lnRef>
+              <a:fillRef idx="1">
+                <a:schemeClr val="accent1"/>
+              </a:fillRef>
+              <a:effectRef idx="0">
+                <a:schemeClr val="accent1"/>
+              </a:effectRef>
+              <a:fontRef idx="minor">
+                <a:schemeClr val="lt1"/>
+              </a:fontRef>
+            </p:style>
+            <p:txBody>
+              <a:bodyPr wrap="square" rtlCol="0" anchor="ctr">
+                <a:noAutofit/>
+              </a:bodyPr>
+              <a:lstStyle/>
+              <a:p>
+                <a:pPr algn="ctr"/>
+                <a:endParaRPr lang="ko-KR" altLang="en-US" dirty="0"/>
+              </a:p>
+            </p:txBody>
+          </p:sp>
+          <p:sp>
+            <p:nvSpPr>
+              <p:cNvPr id="25" name="Freeform: Shape 24">
+                <a:extLst>
+                  <a:ext uri="{FF2B5EF4-FFF2-40B4-BE49-F238E27FC236}">
+                    <a16:creationId xmlns:a16="http://schemas.microsoft.com/office/drawing/2014/main" id="{452F7CE3-0F27-E568-0CA1-C036B45E03F4}"/>
+                  </a:ext>
+                </a:extLst>
+              </p:cNvPr>
+              <p:cNvSpPr/>
+              <p:nvPr/>
+            </p:nvSpPr>
+            <p:spPr>
+              <a:xfrm rot="16200000">
+                <a:off x="1288268" y="2909048"/>
+                <a:ext cx="1362631" cy="1362632"/>
+              </a:xfrm>
+              <a:custGeom>
+                <a:avLst/>
+                <a:gdLst>
+                  <a:gd name="csX0" fmla="*/ 2162174 w 2438400"/>
+                  <a:gd name="csY0" fmla="*/ 1015509 h 2438401"/>
+                  <a:gd name="csX1" fmla="*/ 2226113 w 2438400"/>
+                  <a:gd name="csY1" fmla="*/ 1031950 h 2438401"/>
+                  <a:gd name="csX2" fmla="*/ 2438400 w 2438400"/>
+                  <a:gd name="csY2" fmla="*/ 1053350 h 2438401"/>
+                  <a:gd name="csX3" fmla="*/ 2438400 w 2438400"/>
+                  <a:gd name="csY3" fmla="*/ 2438401 h 2438401"/>
+                  <a:gd name="csX4" fmla="*/ 2162174 w 2438400"/>
+                  <a:gd name="csY4" fmla="*/ 2438401 h 2438401"/>
+                  <a:gd name="csX5" fmla="*/ 1385048 w 2438400"/>
+                  <a:gd name="csY5" fmla="*/ 0 h 2438401"/>
+                  <a:gd name="csX6" fmla="*/ 1659489 w 2438400"/>
+                  <a:gd name="csY6" fmla="*/ 0 h 2438401"/>
+                  <a:gd name="csX7" fmla="*/ 1663510 w 2438400"/>
+                  <a:gd name="csY7" fmla="*/ 79636 h 2438401"/>
+                  <a:gd name="csX8" fmla="*/ 1675314 w 2438400"/>
+                  <a:gd name="csY8" fmla="*/ 156975 h 2438401"/>
+                  <a:gd name="csX9" fmla="*/ 1712331 w 2438400"/>
+                  <a:gd name="csY9" fmla="*/ 276225 h 2438401"/>
+                  <a:gd name="csX10" fmla="*/ 1712330 w 2438400"/>
+                  <a:gd name="csY10" fmla="*/ 276225 h 2438401"/>
+                  <a:gd name="csX11" fmla="*/ 1720699 w 2438400"/>
+                  <a:gd name="csY11" fmla="*/ 303185 h 2438401"/>
+                  <a:gd name="csX12" fmla="*/ 2135212 w 2438400"/>
+                  <a:gd name="csY12" fmla="*/ 717698 h 2438401"/>
+                  <a:gd name="csX13" fmla="*/ 2162174 w 2438400"/>
+                  <a:gd name="csY13" fmla="*/ 726067 h 2438401"/>
+                  <a:gd name="csX14" fmla="*/ 2162174 w 2438400"/>
+                  <a:gd name="csY14" fmla="*/ 726067 h 2438401"/>
+                  <a:gd name="csX15" fmla="*/ 2281422 w 2438400"/>
+                  <a:gd name="csY15" fmla="*/ 763084 h 2438401"/>
+                  <a:gd name="csX16" fmla="*/ 2438400 w 2438400"/>
+                  <a:gd name="csY16" fmla="*/ 778909 h 2438401"/>
+                  <a:gd name="csX17" fmla="*/ 2438400 w 2438400"/>
+                  <a:gd name="csY17" fmla="*/ 1053350 h 2438401"/>
+                  <a:gd name="csX18" fmla="*/ 2226113 w 2438400"/>
+                  <a:gd name="csY18" fmla="*/ 1031950 h 2438401"/>
+                  <a:gd name="csX19" fmla="*/ 2162174 w 2438400"/>
+                  <a:gd name="csY19" fmla="*/ 1015509 h 2438401"/>
+                  <a:gd name="csX20" fmla="*/ 2162174 w 2438400"/>
+                  <a:gd name="csY20" fmla="*/ 1015509 h 2438401"/>
+                  <a:gd name="csX21" fmla="*/ 2125165 w 2438400"/>
+                  <a:gd name="csY21" fmla="*/ 1005993 h 2438401"/>
+                  <a:gd name="csX22" fmla="*/ 1432404 w 2438400"/>
+                  <a:gd name="csY22" fmla="*/ 313232 h 2438401"/>
+                  <a:gd name="csX23" fmla="*/ 1422888 w 2438400"/>
+                  <a:gd name="csY23" fmla="*/ 276225 h 2438401"/>
+                  <a:gd name="csX24" fmla="*/ 1422889 w 2438400"/>
+                  <a:gd name="csY24" fmla="*/ 276225 h 2438401"/>
+                  <a:gd name="csX25" fmla="*/ 1406448 w 2438400"/>
+                  <a:gd name="csY25" fmla="*/ 212284 h 2438401"/>
+                  <a:gd name="csX26" fmla="*/ 1390486 w 2438400"/>
+                  <a:gd name="csY26" fmla="*/ 107696 h 2438401"/>
+                  <a:gd name="csX27" fmla="*/ 0 w 2438400"/>
+                  <a:gd name="csY27" fmla="*/ 0 h 2438401"/>
+                  <a:gd name="csX28" fmla="*/ 1385047 w 2438400"/>
+                  <a:gd name="csY28" fmla="*/ 0 h 2438401"/>
+                  <a:gd name="csX29" fmla="*/ 1390485 w 2438400"/>
+                  <a:gd name="csY29" fmla="*/ 107696 h 2438401"/>
+                  <a:gd name="csX30" fmla="*/ 1406447 w 2438400"/>
+                  <a:gd name="csY30" fmla="*/ 212284 h 2438401"/>
+                  <a:gd name="csX31" fmla="*/ 1422888 w 2438400"/>
+                  <a:gd name="csY31" fmla="*/ 276225 h 2438401"/>
+                  <a:gd name="csX32" fmla="*/ 0 w 2438400"/>
+                  <a:gd name="csY32" fmla="*/ 276225 h 2438401"/>
+                </a:gdLst>
+                <a:ahLst/>
+                <a:cxnLst>
+                  <a:cxn ang="0">
+                    <a:pos x="csX0" y="csY0"/>
+                  </a:cxn>
+                  <a:cxn ang="0">
+                    <a:pos x="csX1" y="csY1"/>
+                  </a:cxn>
+                  <a:cxn ang="0">
+                    <a:pos x="csX2" y="csY2"/>
+                  </a:cxn>
+                  <a:cxn ang="0">
+                    <a:pos x="csX3" y="csY3"/>
+                  </a:cxn>
+                  <a:cxn ang="0">
+                    <a:pos x="csX4" y="csY4"/>
+                  </a:cxn>
+                  <a:cxn ang="0">
+                    <a:pos x="csX5" y="csY5"/>
+                  </a:cxn>
+                  <a:cxn ang="0">
+                    <a:pos x="csX6" y="csY6"/>
+                  </a:cxn>
+                  <a:cxn ang="0">
+                    <a:pos x="csX7" y="csY7"/>
+                  </a:cxn>
+                  <a:cxn ang="0">
+                    <a:pos x="csX8" y="csY8"/>
+                  </a:cxn>
+                  <a:cxn ang="0">
+                    <a:pos x="csX9" y="csY9"/>
+                  </a:cxn>
+                  <a:cxn ang="0">
+                    <a:pos x="csX10" y="csY10"/>
+                  </a:cxn>
+                  <a:cxn ang="0">
+                    <a:pos x="csX11" y="csY11"/>
+                  </a:cxn>
+                  <a:cxn ang="0">
+                    <a:pos x="csX12" y="csY12"/>
+                  </a:cxn>
+                  <a:cxn ang="0">
+                    <a:pos x="csX13" y="csY13"/>
+                  </a:cxn>
+                  <a:cxn ang="0">
+                    <a:pos x="csX14" y="csY14"/>
+                  </a:cxn>
+                  <a:cxn ang="0">
+                    <a:pos x="csX15" y="csY15"/>
+                  </a:cxn>
+                  <a:cxn ang="0">
+                    <a:pos x="csX16" y="csY16"/>
+                  </a:cxn>
+                  <a:cxn ang="0">
+                    <a:pos x="csX17" y="csY17"/>
+                  </a:cxn>
+                  <a:cxn ang="0">
+                    <a:pos x="csX18" y="csY18"/>
+                  </a:cxn>
+                  <a:cxn ang="0">
+                    <a:pos x="csX19" y="csY19"/>
+                  </a:cxn>
+                  <a:cxn ang="0">
+                    <a:pos x="csX20" y="csY20"/>
+                  </a:cxn>
+                  <a:cxn ang="0">
+                    <a:pos x="csX21" y="csY21"/>
+                  </a:cxn>
+                  <a:cxn ang="0">
+                    <a:pos x="csX22" y="csY22"/>
+                  </a:cxn>
+                  <a:cxn ang="0">
+                    <a:pos x="csX23" y="csY23"/>
+                  </a:cxn>
+                  <a:cxn ang="0">
+                    <a:pos x="csX24" y="csY24"/>
+                  </a:cxn>
+                  <a:cxn ang="0">
+                    <a:pos x="csX25" y="csY25"/>
+                  </a:cxn>
+                  <a:cxn ang="0">
+                    <a:pos x="csX26" y="csY26"/>
+                  </a:cxn>
+                  <a:cxn ang="0">
+                    <a:pos x="csX27" y="csY27"/>
+                  </a:cxn>
+                  <a:cxn ang="0">
+                    <a:pos x="csX28" y="csY28"/>
+                  </a:cxn>
+                  <a:cxn ang="0">
+                    <a:pos x="csX29" y="csY29"/>
+                  </a:cxn>
+                  <a:cxn ang="0">
+                    <a:pos x="csX30" y="csY30"/>
+                  </a:cxn>
+                  <a:cxn ang="0">
+                    <a:pos x="csX31" y="csY31"/>
+                  </a:cxn>
+                  <a:cxn ang="0">
+                    <a:pos x="csX32" y="csY32"/>
+                  </a:cxn>
+                </a:cxnLst>
+                <a:rect l="l" t="t" r="r" b="b"/>
+                <a:pathLst>
+                  <a:path w="2438400" h="2438401">
+                    <a:moveTo>
+                      <a:pt x="2162174" y="1015509"/>
+                    </a:moveTo>
+                    <a:lnTo>
+                      <a:pt x="2226113" y="1031950"/>
+                    </a:lnTo>
+                    <a:cubicBezTo>
+                      <a:pt x="2294683" y="1045981"/>
+                      <a:pt x="2365681" y="1053350"/>
+                      <a:pt x="2438400" y="1053350"/>
+                    </a:cubicBezTo>
+                    <a:lnTo>
+                      <a:pt x="2438400" y="2438401"/>
+                    </a:lnTo>
+                    <a:lnTo>
+                      <a:pt x="2162174" y="2438401"/>
+                    </a:lnTo>
+                    <a:close/>
+                    <a:moveTo>
+                      <a:pt x="1385048" y="0"/>
+                    </a:moveTo>
+                    <a:lnTo>
+                      <a:pt x="1659489" y="0"/>
+                    </a:lnTo>
+                    <a:lnTo>
+                      <a:pt x="1663510" y="79636"/>
+                    </a:lnTo>
+                    <a:cubicBezTo>
+                      <a:pt x="1666170" y="105821"/>
+                      <a:pt x="1670126" y="131622"/>
+                      <a:pt x="1675314" y="156975"/>
+                    </a:cubicBezTo>
+                    <a:lnTo>
+                      <a:pt x="1712331" y="276225"/>
+                    </a:lnTo>
+                    <a:lnTo>
+                      <a:pt x="1712330" y="276225"/>
+                    </a:lnTo>
+                    <a:lnTo>
+                      <a:pt x="1720699" y="303185"/>
+                    </a:lnTo>
+                    <a:cubicBezTo>
+                      <a:pt x="1799529" y="489560"/>
+                      <a:pt x="1948837" y="638868"/>
+                      <a:pt x="2135212" y="717698"/>
+                    </a:cubicBezTo>
+                    <a:lnTo>
+                      <a:pt x="2162174" y="726067"/>
+                    </a:lnTo>
+                    <a:lnTo>
+                      <a:pt x="2162174" y="726067"/>
+                    </a:lnTo>
+                    <a:lnTo>
+                      <a:pt x="2281422" y="763084"/>
+                    </a:lnTo>
+                    <a:cubicBezTo>
+                      <a:pt x="2332127" y="773460"/>
+                      <a:pt x="2384627" y="778909"/>
+                      <a:pt x="2438400" y="778909"/>
+                    </a:cubicBezTo>
+                    <a:lnTo>
+                      <a:pt x="2438400" y="1053350"/>
+                    </a:lnTo>
+                    <a:cubicBezTo>
+                      <a:pt x="2365681" y="1053350"/>
+                      <a:pt x="2294683" y="1045981"/>
+                      <a:pt x="2226113" y="1031950"/>
+                    </a:cubicBezTo>
+                    <a:lnTo>
+                      <a:pt x="2162174" y="1015509"/>
+                    </a:lnTo>
+                    <a:lnTo>
+                      <a:pt x="2162174" y="1015509"/>
+                    </a:lnTo>
+                    <a:lnTo>
+                      <a:pt x="2125165" y="1005993"/>
+                    </a:lnTo>
+                    <a:cubicBezTo>
+                      <a:pt x="1795329" y="903404"/>
+                      <a:pt x="1534993" y="643068"/>
+                      <a:pt x="1432404" y="313232"/>
+                    </a:cubicBezTo>
+                    <a:lnTo>
+                      <a:pt x="1422888" y="276225"/>
+                    </a:lnTo>
+                    <a:lnTo>
+                      <a:pt x="1422889" y="276225"/>
+                    </a:lnTo>
+                    <a:lnTo>
+                      <a:pt x="1406448" y="212284"/>
+                    </a:lnTo>
+                    <a:cubicBezTo>
+                      <a:pt x="1399433" y="177999"/>
+                      <a:pt x="1394082" y="143107"/>
+                      <a:pt x="1390486" y="107696"/>
+                    </a:cubicBezTo>
+                    <a:close/>
+                    <a:moveTo>
+                      <a:pt x="0" y="0"/>
+                    </a:moveTo>
+                    <a:lnTo>
+                      <a:pt x="1385047" y="0"/>
+                    </a:lnTo>
+                    <a:lnTo>
+                      <a:pt x="1390485" y="107696"/>
+                    </a:lnTo>
+                    <a:cubicBezTo>
+                      <a:pt x="1394081" y="143107"/>
+                      <a:pt x="1399432" y="177999"/>
+                      <a:pt x="1406447" y="212284"/>
+                    </a:cubicBezTo>
+                    <a:lnTo>
+                      <a:pt x="1422888" y="276225"/>
+                    </a:lnTo>
+                    <a:lnTo>
+                      <a:pt x="0" y="276225"/>
+                    </a:lnTo>
+                    <a:close/>
+                  </a:path>
+                </a:pathLst>
+              </a:custGeom>
+              <a:solidFill>
+                <a:schemeClr val="tx1"/>
+              </a:solidFill>
+              <a:ln>
+                <a:noFill/>
+              </a:ln>
+            </p:spPr>
+            <p:style>
+              <a:lnRef idx="2">
+                <a:schemeClr val="accent1">
+                  <a:shade val="15000"/>
+                </a:schemeClr>
+              </a:lnRef>
+              <a:fillRef idx="1">
+                <a:schemeClr val="accent1"/>
+              </a:fillRef>
+              <a:effectRef idx="0">
+                <a:schemeClr val="accent1"/>
+              </a:effectRef>
+              <a:fontRef idx="minor">
+                <a:schemeClr val="lt1"/>
+              </a:fontRef>
+            </p:style>
+            <p:txBody>
+              <a:bodyPr wrap="square" rtlCol="0" anchor="ctr">
+                <a:noAutofit/>
+              </a:bodyPr>
+              <a:lstStyle/>
+              <a:p>
+                <a:pPr algn="ctr"/>
+                <a:endParaRPr lang="ko-KR" altLang="en-US" dirty="0"/>
+              </a:p>
+            </p:txBody>
+          </p:sp>
+        </p:grpSp>
         <p:sp>
           <p:nvSpPr>
-            <p:cNvPr id="8" name="Rectangle 7">
+            <p:cNvPr id="26" name="Rectangle 25">
               <a:extLst>
                 <a:ext uri="{FF2B5EF4-FFF2-40B4-BE49-F238E27FC236}">
-                  <a16:creationId xmlns:a16="http://schemas.microsoft.com/office/drawing/2014/main" id="{64A15853-7C01-C8F4-DE25-B880DB17FEEF}"/>
+                  <a16:creationId xmlns:a16="http://schemas.microsoft.com/office/drawing/2014/main" id="{8D0A6BC9-DFAE-754B-8C4D-F73A44EE6918}"/>
                 </a:ext>
               </a:extLst>
             </p:cNvPr>
@@ -3129,18 +5503,18 @@
             <p:nvPr/>
           </p:nvSpPr>
           <p:spPr>
-            <a:xfrm rot="337805">
-              <a:off x="1825538" y="3324872"/>
-              <a:ext cx="6102522" cy="3844192"/>
+            <a:xfrm rot="10800000">
+              <a:off x="1288269" y="4271680"/>
+              <a:ext cx="154765" cy="1210241"/>
             </a:xfrm>
             <a:prstGeom prst="rect">
               <a:avLst/>
             </a:prstGeom>
-            <a:noFill/>
-            <a:ln w="50800">
-              <a:solidFill>
-                <a:schemeClr val="tx1"/>
-              </a:solidFill>
+            <a:solidFill>
+              <a:schemeClr val="tx1"/>
+            </a:solidFill>
+            <a:ln>
+              <a:noFill/>
             </a:ln>
           </p:spPr>
           <p:style>
@@ -3170,10 +5544,10 @@
         </p:sp>
         <p:sp>
           <p:nvSpPr>
-            <p:cNvPr id="10" name="Rectangle 9">
+            <p:cNvPr id="27" name="Rectangle 26">
               <a:extLst>
                 <a:ext uri="{FF2B5EF4-FFF2-40B4-BE49-F238E27FC236}">
-                  <a16:creationId xmlns:a16="http://schemas.microsoft.com/office/drawing/2014/main" id="{622712AF-B2F5-E14D-03CD-F3E49E52DD40}"/>
+                  <a16:creationId xmlns:a16="http://schemas.microsoft.com/office/drawing/2014/main" id="{897C9D18-74B8-23A5-3D3B-96443147DA72}"/>
                 </a:ext>
               </a:extLst>
             </p:cNvPr>
@@ -3181,18 +5555,18 @@
             <p:nvPr/>
           </p:nvSpPr>
           <p:spPr>
-            <a:xfrm>
-              <a:off x="1651689" y="3034798"/>
-              <a:ext cx="6450220" cy="4424340"/>
+            <a:xfrm rot="16200000">
+              <a:off x="4799415" y="760536"/>
+              <a:ext cx="154765" cy="4451793"/>
             </a:xfrm>
             <a:prstGeom prst="rect">
               <a:avLst/>
             </a:prstGeom>
-            <a:noFill/>
-            <a:ln w="50800">
-              <a:solidFill>
-                <a:schemeClr val="tx1"/>
-              </a:solidFill>
+            <a:solidFill>
+              <a:schemeClr val="tx1"/>
+            </a:solidFill>
+            <a:ln>
+              <a:noFill/>
             </a:ln>
           </p:spPr>
           <p:style>
@@ -3216,7 +5590,7 @@
             <a:lstStyle/>
             <a:p>
               <a:pPr algn="ctr"/>
-              <a:endParaRPr lang="ko-KR" altLang="en-US" dirty="0"/>
+              <a:endParaRPr lang="ko-KR" altLang="en-US"/>
             </a:p>
           </p:txBody>
         </p:sp>
@@ -4787,7 +7161,7 @@
             <a:lstStyle/>
             <a:p>
               <a:pPr algn="ctr"/>
-              <a:endParaRPr lang="ko-KR" altLang="en-US"/>
+              <a:endParaRPr lang="ko-KR" altLang="en-US" dirty="0"/>
             </a:p>
           </p:txBody>
         </p:sp>
@@ -5559,6 +7933,362 @@
           </p:sp>
         </p:grpSp>
       </p:grpSp>
+      <p:grpSp>
+        <p:nvGrpSpPr>
+          <p:cNvPr id="25" name="Group 24">
+            <a:extLst>
+              <a:ext uri="{FF2B5EF4-FFF2-40B4-BE49-F238E27FC236}">
+                <a16:creationId xmlns:a16="http://schemas.microsoft.com/office/drawing/2014/main" id="{61F939B0-0B2D-3D77-3D37-01B0DA46AD86}"/>
+              </a:ext>
+            </a:extLst>
+          </p:cNvPr>
+          <p:cNvGrpSpPr/>
+          <p:nvPr/>
+        </p:nvGrpSpPr>
+        <p:grpSpPr>
+          <a:xfrm>
+            <a:off x="0" y="4876799"/>
+            <a:ext cx="9753600" cy="4876801"/>
+            <a:chOff x="0" y="4876799"/>
+            <a:chExt cx="9753600" cy="4876801"/>
+          </a:xfrm>
+        </p:grpSpPr>
+        <p:sp>
+          <p:nvSpPr>
+            <p:cNvPr id="11" name="Frame 10">
+              <a:extLst>
+                <a:ext uri="{FF2B5EF4-FFF2-40B4-BE49-F238E27FC236}">
+                  <a16:creationId xmlns:a16="http://schemas.microsoft.com/office/drawing/2014/main" id="{CE90E667-EC19-2FF5-9EBE-1C96CE421C90}"/>
+                </a:ext>
+              </a:extLst>
+            </p:cNvPr>
+            <p:cNvSpPr/>
+            <p:nvPr/>
+          </p:nvSpPr>
+          <p:spPr>
+            <a:xfrm rot="2700000">
+              <a:off x="3557719" y="6001835"/>
+              <a:ext cx="2626730" cy="2626730"/>
+            </a:xfrm>
+            <a:prstGeom prst="frame">
+              <a:avLst/>
+            </a:prstGeom>
+            <a:solidFill>
+              <a:schemeClr val="tx1"/>
+            </a:solidFill>
+            <a:ln>
+              <a:noFill/>
+            </a:ln>
+          </p:spPr>
+          <p:style>
+            <a:lnRef idx="2">
+              <a:schemeClr val="accent1">
+                <a:shade val="15000"/>
+              </a:schemeClr>
+            </a:lnRef>
+            <a:fillRef idx="1">
+              <a:schemeClr val="accent1"/>
+            </a:fillRef>
+            <a:effectRef idx="0">
+              <a:schemeClr val="accent1"/>
+            </a:effectRef>
+            <a:fontRef idx="minor">
+              <a:schemeClr val="lt1"/>
+            </a:fontRef>
+          </p:style>
+          <p:txBody>
+            <a:bodyPr rtlCol="0" anchor="ctr"/>
+            <a:lstStyle/>
+            <a:p>
+              <a:pPr algn="ctr"/>
+              <a:endParaRPr lang="ko-KR" altLang="en-US"/>
+            </a:p>
+          </p:txBody>
+        </p:sp>
+        <p:sp>
+          <p:nvSpPr>
+            <p:cNvPr id="15" name="Rectangle: Diagonal Corners Snipped 14">
+              <a:extLst>
+                <a:ext uri="{FF2B5EF4-FFF2-40B4-BE49-F238E27FC236}">
+                  <a16:creationId xmlns:a16="http://schemas.microsoft.com/office/drawing/2014/main" id="{6196D6F6-F456-BDA1-BB9F-124D06B41322}"/>
+                </a:ext>
+              </a:extLst>
+            </p:cNvPr>
+            <p:cNvSpPr/>
+            <p:nvPr/>
+          </p:nvSpPr>
+          <p:spPr>
+            <a:xfrm>
+              <a:off x="218523" y="7139942"/>
+              <a:ext cx="3277712" cy="350518"/>
+            </a:xfrm>
+            <a:prstGeom prst="snip2DiagRect">
+              <a:avLst>
+                <a:gd name="adj1" fmla="val 50000"/>
+                <a:gd name="adj2" fmla="val 50000"/>
+              </a:avLst>
+            </a:prstGeom>
+            <a:solidFill>
+              <a:schemeClr val="tx1"/>
+            </a:solidFill>
+            <a:ln>
+              <a:noFill/>
+            </a:ln>
+          </p:spPr>
+          <p:style>
+            <a:lnRef idx="2">
+              <a:schemeClr val="accent1">
+                <a:shade val="15000"/>
+              </a:schemeClr>
+            </a:lnRef>
+            <a:fillRef idx="1">
+              <a:schemeClr val="accent1"/>
+            </a:fillRef>
+            <a:effectRef idx="0">
+              <a:schemeClr val="accent1"/>
+            </a:effectRef>
+            <a:fontRef idx="minor">
+              <a:schemeClr val="lt1"/>
+            </a:fontRef>
+          </p:style>
+          <p:txBody>
+            <a:bodyPr rtlCol="0" anchor="ctr"/>
+            <a:lstStyle/>
+            <a:p>
+              <a:pPr algn="ctr"/>
+              <a:endParaRPr lang="ko-KR" altLang="en-US"/>
+            </a:p>
+          </p:txBody>
+        </p:sp>
+        <p:sp>
+          <p:nvSpPr>
+            <p:cNvPr id="23" name="Rectangle: Diagonal Corners Snipped 22">
+              <a:extLst>
+                <a:ext uri="{FF2B5EF4-FFF2-40B4-BE49-F238E27FC236}">
+                  <a16:creationId xmlns:a16="http://schemas.microsoft.com/office/drawing/2014/main" id="{2CB364CE-E61E-1FC4-3214-4A97BDD85903}"/>
+                </a:ext>
+              </a:extLst>
+            </p:cNvPr>
+            <p:cNvSpPr/>
+            <p:nvPr/>
+          </p:nvSpPr>
+          <p:spPr>
+            <a:xfrm>
+              <a:off x="6245933" y="7139941"/>
+              <a:ext cx="3277712" cy="350518"/>
+            </a:xfrm>
+            <a:prstGeom prst="snip2DiagRect">
+              <a:avLst>
+                <a:gd name="adj1" fmla="val 50000"/>
+                <a:gd name="adj2" fmla="val 50000"/>
+              </a:avLst>
+            </a:prstGeom>
+            <a:solidFill>
+              <a:schemeClr val="tx1"/>
+            </a:solidFill>
+            <a:ln>
+              <a:noFill/>
+            </a:ln>
+          </p:spPr>
+          <p:style>
+            <a:lnRef idx="2">
+              <a:schemeClr val="accent1">
+                <a:shade val="15000"/>
+              </a:schemeClr>
+            </a:lnRef>
+            <a:fillRef idx="1">
+              <a:schemeClr val="accent1"/>
+            </a:fillRef>
+            <a:effectRef idx="0">
+              <a:schemeClr val="accent1"/>
+            </a:effectRef>
+            <a:fontRef idx="minor">
+              <a:schemeClr val="lt1"/>
+            </a:fontRef>
+          </p:style>
+          <p:txBody>
+            <a:bodyPr rtlCol="0" anchor="ctr"/>
+            <a:lstStyle/>
+            <a:p>
+              <a:pPr algn="ctr"/>
+              <a:endParaRPr lang="ko-KR" altLang="en-US"/>
+            </a:p>
+          </p:txBody>
+        </p:sp>
+        <p:sp>
+          <p:nvSpPr>
+            <p:cNvPr id="24" name="Rectangle 23">
+              <a:extLst>
+                <a:ext uri="{FF2B5EF4-FFF2-40B4-BE49-F238E27FC236}">
+                  <a16:creationId xmlns:a16="http://schemas.microsoft.com/office/drawing/2014/main" id="{26E95506-1DAE-9784-BCC2-5D5194120768}"/>
+                </a:ext>
+              </a:extLst>
+            </p:cNvPr>
+            <p:cNvSpPr/>
+            <p:nvPr/>
+          </p:nvSpPr>
+          <p:spPr>
+            <a:xfrm>
+              <a:off x="0" y="4876799"/>
+              <a:ext cx="9753600" cy="4876801"/>
+            </a:xfrm>
+            <a:prstGeom prst="rect">
+              <a:avLst/>
+            </a:prstGeom>
+            <a:noFill/>
+            <a:ln>
+              <a:noFill/>
+            </a:ln>
+          </p:spPr>
+          <p:style>
+            <a:lnRef idx="2">
+              <a:schemeClr val="accent1">
+                <a:shade val="15000"/>
+              </a:schemeClr>
+            </a:lnRef>
+            <a:fillRef idx="1">
+              <a:schemeClr val="accent1"/>
+            </a:fillRef>
+            <a:effectRef idx="0">
+              <a:schemeClr val="accent1"/>
+            </a:effectRef>
+            <a:fontRef idx="minor">
+              <a:schemeClr val="lt1"/>
+            </a:fontRef>
+          </p:style>
+          <p:txBody>
+            <a:bodyPr rtlCol="0" anchor="ctr"/>
+            <a:lstStyle/>
+            <a:p>
+              <a:pPr algn="ctr"/>
+              <a:endParaRPr lang="ko-KR" altLang="en-US" dirty="0"/>
+            </a:p>
+          </p:txBody>
+        </p:sp>
+      </p:grpSp>
+      <p:grpSp>
+        <p:nvGrpSpPr>
+          <p:cNvPr id="30" name="Group 29">
+            <a:extLst>
+              <a:ext uri="{FF2B5EF4-FFF2-40B4-BE49-F238E27FC236}">
+                <a16:creationId xmlns:a16="http://schemas.microsoft.com/office/drawing/2014/main" id="{D7082256-F48F-C51D-E993-08ADF91B50A1}"/>
+              </a:ext>
+            </a:extLst>
+          </p:cNvPr>
+          <p:cNvGrpSpPr/>
+          <p:nvPr/>
+        </p:nvGrpSpPr>
+        <p:grpSpPr>
+          <a:xfrm>
+            <a:off x="0" y="4876799"/>
+            <a:ext cx="9753600" cy="4876801"/>
+            <a:chOff x="0" y="4876799"/>
+            <a:chExt cx="9753600" cy="4876801"/>
+          </a:xfrm>
+        </p:grpSpPr>
+        <p:sp>
+          <p:nvSpPr>
+            <p:cNvPr id="3" name="Diamond 2">
+              <a:extLst>
+                <a:ext uri="{FF2B5EF4-FFF2-40B4-BE49-F238E27FC236}">
+                  <a16:creationId xmlns:a16="http://schemas.microsoft.com/office/drawing/2014/main" id="{B9A1BF94-D5F9-D62B-4CAC-FA845689DD70}"/>
+                </a:ext>
+              </a:extLst>
+            </p:cNvPr>
+            <p:cNvSpPr/>
+            <p:nvPr/>
+          </p:nvSpPr>
+          <p:spPr>
+            <a:xfrm>
+              <a:off x="3777390" y="6221506"/>
+              <a:ext cx="2187388" cy="2187388"/>
+            </a:xfrm>
+            <a:prstGeom prst="diamond">
+              <a:avLst/>
+            </a:prstGeom>
+            <a:solidFill>
+              <a:schemeClr val="tx1"/>
+            </a:solidFill>
+            <a:ln>
+              <a:noFill/>
+            </a:ln>
+          </p:spPr>
+          <p:style>
+            <a:lnRef idx="2">
+              <a:schemeClr val="accent1">
+                <a:shade val="15000"/>
+              </a:schemeClr>
+            </a:lnRef>
+            <a:fillRef idx="1">
+              <a:schemeClr val="accent1"/>
+            </a:fillRef>
+            <a:effectRef idx="0">
+              <a:schemeClr val="accent1"/>
+            </a:effectRef>
+            <a:fontRef idx="minor">
+              <a:schemeClr val="lt1"/>
+            </a:fontRef>
+          </p:style>
+          <p:txBody>
+            <a:bodyPr rtlCol="0" anchor="ctr"/>
+            <a:lstStyle/>
+            <a:p>
+              <a:pPr algn="ctr"/>
+              <a:endParaRPr lang="ko-KR" altLang="en-US"/>
+            </a:p>
+          </p:txBody>
+        </p:sp>
+        <p:sp>
+          <p:nvSpPr>
+            <p:cNvPr id="29" name="Rectangle 28">
+              <a:extLst>
+                <a:ext uri="{FF2B5EF4-FFF2-40B4-BE49-F238E27FC236}">
+                  <a16:creationId xmlns:a16="http://schemas.microsoft.com/office/drawing/2014/main" id="{3E9D2A3F-1D4E-9A0C-90ED-FA06EC8F067E}"/>
+                </a:ext>
+              </a:extLst>
+            </p:cNvPr>
+            <p:cNvSpPr/>
+            <p:nvPr/>
+          </p:nvSpPr>
+          <p:spPr>
+            <a:xfrm>
+              <a:off x="0" y="4876799"/>
+              <a:ext cx="9753600" cy="4876801"/>
+            </a:xfrm>
+            <a:prstGeom prst="rect">
+              <a:avLst/>
+            </a:prstGeom>
+            <a:noFill/>
+            <a:ln>
+              <a:noFill/>
+            </a:ln>
+          </p:spPr>
+          <p:style>
+            <a:lnRef idx="2">
+              <a:schemeClr val="accent1">
+                <a:shade val="15000"/>
+              </a:schemeClr>
+            </a:lnRef>
+            <a:fillRef idx="1">
+              <a:schemeClr val="accent1"/>
+            </a:fillRef>
+            <a:effectRef idx="0">
+              <a:schemeClr val="accent1"/>
+            </a:effectRef>
+            <a:fontRef idx="minor">
+              <a:schemeClr val="lt1"/>
+            </a:fontRef>
+          </p:style>
+          <p:txBody>
+            <a:bodyPr rtlCol="0" anchor="ctr"/>
+            <a:lstStyle/>
+            <a:p>
+              <a:pPr algn="ctr"/>
+              <a:endParaRPr lang="ko-KR" altLang="en-US" dirty="0"/>
+            </a:p>
+          </p:txBody>
+        </p:sp>
+      </p:grpSp>
     </p:spTree>
     <p:extLst>
       <p:ext uri="{BB962C8B-B14F-4D97-AF65-F5344CB8AC3E}">

</xml_diff>

<commit_message>
Added Icon on upgrade slot
</commit_message>
<xml_diff>
--- a/Assets/Sprites/rockin_rackin_Logo.pptx
+++ b/Assets/Sprites/rockin_rackin_Logo.pptx
@@ -8,6 +8,7 @@
     <p:sldId id="256" r:id="rId2"/>
     <p:sldId id="257" r:id="rId3"/>
     <p:sldId id="258" r:id="rId4"/>
+    <p:sldId id="259" r:id="rId5"/>
   </p:sldIdLst>
   <p:sldSz cx="9753600" cy="9753600"/>
   <p:notesSz cx="6858000" cy="9144000"/>
@@ -245,7 +246,7 @@
           <a:p>
             <a:fld id="{E6DAED35-DFB6-4BA2-A5B6-52D99E578295}" type="datetimeFigureOut">
               <a:rPr lang="ko-KR" altLang="en-US" smtClean="0"/>
-              <a:t>2026-08-05</a:t>
+              <a:t>2026-08-08</a:t>
             </a:fld>
             <a:endParaRPr lang="ko-KR" altLang="en-US"/>
           </a:p>
@@ -415,7 +416,7 @@
           <a:p>
             <a:fld id="{E6DAED35-DFB6-4BA2-A5B6-52D99E578295}" type="datetimeFigureOut">
               <a:rPr lang="ko-KR" altLang="en-US" smtClean="0"/>
-              <a:t>2026-08-05</a:t>
+              <a:t>2026-08-08</a:t>
             </a:fld>
             <a:endParaRPr lang="ko-KR" altLang="en-US"/>
           </a:p>
@@ -595,7 +596,7 @@
           <a:p>
             <a:fld id="{E6DAED35-DFB6-4BA2-A5B6-52D99E578295}" type="datetimeFigureOut">
               <a:rPr lang="ko-KR" altLang="en-US" smtClean="0"/>
-              <a:t>2026-08-05</a:t>
+              <a:t>2026-08-08</a:t>
             </a:fld>
             <a:endParaRPr lang="ko-KR" altLang="en-US"/>
           </a:p>
@@ -765,7 +766,7 @@
           <a:p>
             <a:fld id="{E6DAED35-DFB6-4BA2-A5B6-52D99E578295}" type="datetimeFigureOut">
               <a:rPr lang="ko-KR" altLang="en-US" smtClean="0"/>
-              <a:t>2026-08-05</a:t>
+              <a:t>2026-08-08</a:t>
             </a:fld>
             <a:endParaRPr lang="ko-KR" altLang="en-US"/>
           </a:p>
@@ -1011,7 +1012,7 @@
           <a:p>
             <a:fld id="{E6DAED35-DFB6-4BA2-A5B6-52D99E578295}" type="datetimeFigureOut">
               <a:rPr lang="ko-KR" altLang="en-US" smtClean="0"/>
-              <a:t>2026-08-05</a:t>
+              <a:t>2026-08-08</a:t>
             </a:fld>
             <a:endParaRPr lang="ko-KR" altLang="en-US"/>
           </a:p>
@@ -1243,7 +1244,7 @@
           <a:p>
             <a:fld id="{E6DAED35-DFB6-4BA2-A5B6-52D99E578295}" type="datetimeFigureOut">
               <a:rPr lang="ko-KR" altLang="en-US" smtClean="0"/>
-              <a:t>2026-08-05</a:t>
+              <a:t>2026-08-08</a:t>
             </a:fld>
             <a:endParaRPr lang="ko-KR" altLang="en-US"/>
           </a:p>
@@ -1610,7 +1611,7 @@
           <a:p>
             <a:fld id="{E6DAED35-DFB6-4BA2-A5B6-52D99E578295}" type="datetimeFigureOut">
               <a:rPr lang="ko-KR" altLang="en-US" smtClean="0"/>
-              <a:t>2026-08-05</a:t>
+              <a:t>2026-08-08</a:t>
             </a:fld>
             <a:endParaRPr lang="ko-KR" altLang="en-US"/>
           </a:p>
@@ -1728,7 +1729,7 @@
           <a:p>
             <a:fld id="{E6DAED35-DFB6-4BA2-A5B6-52D99E578295}" type="datetimeFigureOut">
               <a:rPr lang="ko-KR" altLang="en-US" smtClean="0"/>
-              <a:t>2026-08-05</a:t>
+              <a:t>2026-08-08</a:t>
             </a:fld>
             <a:endParaRPr lang="ko-KR" altLang="en-US"/>
           </a:p>
@@ -1823,7 +1824,7 @@
           <a:p>
             <a:fld id="{E6DAED35-DFB6-4BA2-A5B6-52D99E578295}" type="datetimeFigureOut">
               <a:rPr lang="ko-KR" altLang="en-US" smtClean="0"/>
-              <a:t>2026-08-05</a:t>
+              <a:t>2026-08-08</a:t>
             </a:fld>
             <a:endParaRPr lang="ko-KR" altLang="en-US"/>
           </a:p>
@@ -2100,7 +2101,7 @@
           <a:p>
             <a:fld id="{E6DAED35-DFB6-4BA2-A5B6-52D99E578295}" type="datetimeFigureOut">
               <a:rPr lang="ko-KR" altLang="en-US" smtClean="0"/>
-              <a:t>2026-08-05</a:t>
+              <a:t>2026-08-08</a:t>
             </a:fld>
             <a:endParaRPr lang="ko-KR" altLang="en-US"/>
           </a:p>
@@ -2357,7 +2358,7 @@
           <a:p>
             <a:fld id="{E6DAED35-DFB6-4BA2-A5B6-52D99E578295}" type="datetimeFigureOut">
               <a:rPr lang="ko-KR" altLang="en-US" smtClean="0"/>
-              <a:t>2026-08-05</a:t>
+              <a:t>2026-08-08</a:t>
             </a:fld>
             <a:endParaRPr lang="ko-KR" altLang="en-US"/>
           </a:p>
@@ -2570,7 +2571,7 @@
           <a:p>
             <a:fld id="{E6DAED35-DFB6-4BA2-A5B6-52D99E578295}" type="datetimeFigureOut">
               <a:rPr lang="ko-KR" altLang="en-US" smtClean="0"/>
-              <a:t>2026-08-05</a:t>
+              <a:t>2026-08-08</a:t>
             </a:fld>
             <a:endParaRPr lang="ko-KR" altLang="en-US"/>
           </a:p>
@@ -8302,6 +8303,2107 @@
 </p:sld>
 </file>
 
+<file path=ppt/slides/slide4.xml><?xml version="1.0" encoding="utf-8"?>
+<p:sld xmlns:a="http://schemas.openxmlformats.org/drawingml/2006/main" xmlns:r="http://schemas.openxmlformats.org/officeDocument/2006/relationships" xmlns:p="http://schemas.openxmlformats.org/presentationml/2006/main">
+  <p:cSld>
+    <p:spTree>
+      <p:nvGrpSpPr>
+        <p:cNvPr id="1" name=""/>
+        <p:cNvGrpSpPr/>
+        <p:nvPr/>
+      </p:nvGrpSpPr>
+      <p:grpSpPr>
+        <a:xfrm>
+          <a:off x="0" y="0"/>
+          <a:ext cx="0" cy="0"/>
+          <a:chOff x="0" y="0"/>
+          <a:chExt cx="0" cy="0"/>
+        </a:xfrm>
+      </p:grpSpPr>
+      <p:grpSp>
+        <p:nvGrpSpPr>
+          <p:cNvPr id="3" name="Group 2">
+            <a:extLst>
+              <a:ext uri="{FF2B5EF4-FFF2-40B4-BE49-F238E27FC236}">
+                <a16:creationId xmlns:a16="http://schemas.microsoft.com/office/drawing/2014/main" id="{570295CD-6E8F-523A-2D42-8EB5E5DF6B68}"/>
+              </a:ext>
+            </a:extLst>
+          </p:cNvPr>
+          <p:cNvGrpSpPr/>
+          <p:nvPr/>
+        </p:nvGrpSpPr>
+        <p:grpSpPr>
+          <a:xfrm>
+            <a:off x="0" y="0"/>
+            <a:ext cx="9753600" cy="4876800"/>
+            <a:chOff x="0" y="0"/>
+            <a:chExt cx="9753600" cy="4876800"/>
+          </a:xfrm>
+        </p:grpSpPr>
+        <p:sp>
+          <p:nvSpPr>
+            <p:cNvPr id="2" name="Trapezoid 1">
+              <a:extLst>
+                <a:ext uri="{FF2B5EF4-FFF2-40B4-BE49-F238E27FC236}">
+                  <a16:creationId xmlns:a16="http://schemas.microsoft.com/office/drawing/2014/main" id="{BA5B2660-B707-7EF6-1331-42E39E415590}"/>
+                </a:ext>
+              </a:extLst>
+            </p:cNvPr>
+            <p:cNvSpPr/>
+            <p:nvPr/>
+          </p:nvSpPr>
+          <p:spPr>
+            <a:xfrm rot="19800000">
+              <a:off x="452303" y="1318254"/>
+              <a:ext cx="1783977" cy="230263"/>
+            </a:xfrm>
+            <a:prstGeom prst="trapezoid">
+              <a:avLst>
+                <a:gd name="adj" fmla="val 100222"/>
+              </a:avLst>
+            </a:prstGeom>
+            <a:solidFill>
+              <a:schemeClr val="tx1"/>
+            </a:solidFill>
+            <a:ln>
+              <a:noFill/>
+            </a:ln>
+          </p:spPr>
+          <p:style>
+            <a:lnRef idx="2">
+              <a:schemeClr val="accent1">
+                <a:shade val="15000"/>
+              </a:schemeClr>
+            </a:lnRef>
+            <a:fillRef idx="1">
+              <a:schemeClr val="accent1"/>
+            </a:fillRef>
+            <a:effectRef idx="0">
+              <a:schemeClr val="accent1"/>
+            </a:effectRef>
+            <a:fontRef idx="minor">
+              <a:schemeClr val="lt1"/>
+            </a:fontRef>
+          </p:style>
+          <p:txBody>
+            <a:bodyPr rtlCol="0" anchor="ctr"/>
+            <a:lstStyle/>
+            <a:p>
+              <a:pPr algn="ctr"/>
+              <a:endParaRPr lang="ko-KR" altLang="en-US"/>
+            </a:p>
+          </p:txBody>
+        </p:sp>
+        <p:sp>
+          <p:nvSpPr>
+            <p:cNvPr id="5" name="Circle: Hollow 4">
+              <a:extLst>
+                <a:ext uri="{FF2B5EF4-FFF2-40B4-BE49-F238E27FC236}">
+                  <a16:creationId xmlns:a16="http://schemas.microsoft.com/office/drawing/2014/main" id="{7D73830E-B5FC-61C2-2798-15118ADEDB8A}"/>
+                </a:ext>
+              </a:extLst>
+            </p:cNvPr>
+            <p:cNvSpPr/>
+            <p:nvPr/>
+          </p:nvSpPr>
+          <p:spPr>
+            <a:xfrm>
+              <a:off x="0" y="0"/>
+              <a:ext cx="2438400" cy="2438400"/>
+            </a:xfrm>
+            <a:prstGeom prst="donut">
+              <a:avLst>
+                <a:gd name="adj" fmla="val 4226"/>
+              </a:avLst>
+            </a:prstGeom>
+            <a:solidFill>
+              <a:schemeClr val="tx1"/>
+            </a:solidFill>
+            <a:ln>
+              <a:noFill/>
+            </a:ln>
+          </p:spPr>
+          <p:style>
+            <a:lnRef idx="2">
+              <a:schemeClr val="accent1">
+                <a:shade val="15000"/>
+              </a:schemeClr>
+            </a:lnRef>
+            <a:fillRef idx="1">
+              <a:schemeClr val="accent1"/>
+            </a:fillRef>
+            <a:effectRef idx="0">
+              <a:schemeClr val="accent1"/>
+            </a:effectRef>
+            <a:fontRef idx="minor">
+              <a:schemeClr val="lt1"/>
+            </a:fontRef>
+          </p:style>
+          <p:txBody>
+            <a:bodyPr rtlCol="0" anchor="ctr"/>
+            <a:lstStyle/>
+            <a:p>
+              <a:pPr algn="ctr"/>
+              <a:endParaRPr lang="ko-KR" altLang="en-US"/>
+            </a:p>
+          </p:txBody>
+        </p:sp>
+        <p:sp>
+          <p:nvSpPr>
+            <p:cNvPr id="7" name="Circle: Hollow 6">
+              <a:extLst>
+                <a:ext uri="{FF2B5EF4-FFF2-40B4-BE49-F238E27FC236}">
+                  <a16:creationId xmlns:a16="http://schemas.microsoft.com/office/drawing/2014/main" id="{34C15AB7-C98A-CDEC-8084-AFCBD3D3CE39}"/>
+                </a:ext>
+              </a:extLst>
+            </p:cNvPr>
+            <p:cNvSpPr/>
+            <p:nvPr/>
+          </p:nvSpPr>
+          <p:spPr>
+            <a:xfrm>
+              <a:off x="2438400" y="0"/>
+              <a:ext cx="2438400" cy="2438400"/>
+            </a:xfrm>
+            <a:prstGeom prst="donut">
+              <a:avLst>
+                <a:gd name="adj" fmla="val 4226"/>
+              </a:avLst>
+            </a:prstGeom>
+            <a:solidFill>
+              <a:schemeClr val="tx1"/>
+            </a:solidFill>
+            <a:ln>
+              <a:noFill/>
+            </a:ln>
+          </p:spPr>
+          <p:style>
+            <a:lnRef idx="2">
+              <a:schemeClr val="accent1">
+                <a:shade val="15000"/>
+              </a:schemeClr>
+            </a:lnRef>
+            <a:fillRef idx="1">
+              <a:schemeClr val="accent1"/>
+            </a:fillRef>
+            <a:effectRef idx="0">
+              <a:schemeClr val="accent1"/>
+            </a:effectRef>
+            <a:fontRef idx="minor">
+              <a:schemeClr val="lt1"/>
+            </a:fontRef>
+          </p:style>
+          <p:txBody>
+            <a:bodyPr rtlCol="0" anchor="ctr"/>
+            <a:lstStyle/>
+            <a:p>
+              <a:pPr algn="ctr"/>
+              <a:endParaRPr lang="ko-KR" altLang="en-US"/>
+            </a:p>
+          </p:txBody>
+        </p:sp>
+        <p:grpSp>
+          <p:nvGrpSpPr>
+            <p:cNvPr id="11" name="Group 10">
+              <a:extLst>
+                <a:ext uri="{FF2B5EF4-FFF2-40B4-BE49-F238E27FC236}">
+                  <a16:creationId xmlns:a16="http://schemas.microsoft.com/office/drawing/2014/main" id="{8293A8B6-E341-B674-2BDC-8780872877A1}"/>
+                </a:ext>
+              </a:extLst>
+            </p:cNvPr>
+            <p:cNvGrpSpPr/>
+            <p:nvPr/>
+          </p:nvGrpSpPr>
+          <p:grpSpPr>
+            <a:xfrm>
+              <a:off x="2671482" y="352896"/>
+              <a:ext cx="1972236" cy="1732608"/>
+              <a:chOff x="5342964" y="775447"/>
+              <a:chExt cx="3944471" cy="3465216"/>
+            </a:xfrm>
+            <a:solidFill>
+              <a:schemeClr val="tx1"/>
+            </a:solidFill>
+          </p:grpSpPr>
+          <p:sp>
+            <p:nvSpPr>
+              <p:cNvPr id="8" name="Plus Sign 7">
+                <a:extLst>
+                  <a:ext uri="{FF2B5EF4-FFF2-40B4-BE49-F238E27FC236}">
+                    <a16:creationId xmlns:a16="http://schemas.microsoft.com/office/drawing/2014/main" id="{17A44CAB-2EF2-FAB6-FAA3-80A097A42B64}"/>
+                  </a:ext>
+                </a:extLst>
+              </p:cNvPr>
+              <p:cNvSpPr/>
+              <p:nvPr/>
+            </p:nvSpPr>
+            <p:spPr>
+              <a:xfrm>
+                <a:off x="5342964" y="775447"/>
+                <a:ext cx="2411506" cy="2411506"/>
+              </a:xfrm>
+              <a:prstGeom prst="mathPlus">
+                <a:avLst/>
+              </a:prstGeom>
+              <a:grpFill/>
+              <a:ln>
+                <a:noFill/>
+              </a:ln>
+            </p:spPr>
+            <p:style>
+              <a:lnRef idx="2">
+                <a:schemeClr val="accent1">
+                  <a:shade val="15000"/>
+                </a:schemeClr>
+              </a:lnRef>
+              <a:fillRef idx="1">
+                <a:schemeClr val="accent1"/>
+              </a:fillRef>
+              <a:effectRef idx="0">
+                <a:schemeClr val="accent1"/>
+              </a:effectRef>
+              <a:fontRef idx="minor">
+                <a:schemeClr val="lt1"/>
+              </a:fontRef>
+            </p:style>
+            <p:txBody>
+              <a:bodyPr rtlCol="0" anchor="ctr"/>
+              <a:lstStyle/>
+              <a:p>
+                <a:pPr algn="ctr"/>
+                <a:endParaRPr lang="ko-KR" altLang="en-US"/>
+              </a:p>
+            </p:txBody>
+          </p:sp>
+          <p:sp>
+            <p:nvSpPr>
+              <p:cNvPr id="10" name="Plus Sign 9">
+                <a:extLst>
+                  <a:ext uri="{FF2B5EF4-FFF2-40B4-BE49-F238E27FC236}">
+                    <a16:creationId xmlns:a16="http://schemas.microsoft.com/office/drawing/2014/main" id="{5D3FF9C0-022E-0DCA-BD0D-27C4A91FC43E}"/>
+                  </a:ext>
+                </a:extLst>
+              </p:cNvPr>
+              <p:cNvSpPr/>
+              <p:nvPr/>
+            </p:nvSpPr>
+            <p:spPr>
+              <a:xfrm>
+                <a:off x="6875929" y="1829157"/>
+                <a:ext cx="2411506" cy="2411506"/>
+              </a:xfrm>
+              <a:prstGeom prst="mathPlus">
+                <a:avLst/>
+              </a:prstGeom>
+              <a:grpFill/>
+              <a:ln>
+                <a:noFill/>
+              </a:ln>
+            </p:spPr>
+            <p:style>
+              <a:lnRef idx="2">
+                <a:schemeClr val="accent1">
+                  <a:shade val="15000"/>
+                </a:schemeClr>
+              </a:lnRef>
+              <a:fillRef idx="1">
+                <a:schemeClr val="accent1"/>
+              </a:fillRef>
+              <a:effectRef idx="0">
+                <a:schemeClr val="accent1"/>
+              </a:effectRef>
+              <a:fontRef idx="minor">
+                <a:schemeClr val="lt1"/>
+              </a:fontRef>
+            </p:style>
+            <p:txBody>
+              <a:bodyPr rtlCol="0" anchor="ctr"/>
+              <a:lstStyle/>
+              <a:p>
+                <a:pPr algn="ctr"/>
+                <a:endParaRPr lang="ko-KR" altLang="en-US" dirty="0"/>
+              </a:p>
+            </p:txBody>
+          </p:sp>
+        </p:grpSp>
+        <p:sp>
+          <p:nvSpPr>
+            <p:cNvPr id="13" name="Circle: Hollow 12">
+              <a:extLst>
+                <a:ext uri="{FF2B5EF4-FFF2-40B4-BE49-F238E27FC236}">
+                  <a16:creationId xmlns:a16="http://schemas.microsoft.com/office/drawing/2014/main" id="{30197A9B-7BEF-3C8A-D377-742C2CA2807D}"/>
+                </a:ext>
+              </a:extLst>
+            </p:cNvPr>
+            <p:cNvSpPr/>
+            <p:nvPr/>
+          </p:nvSpPr>
+          <p:spPr>
+            <a:xfrm>
+              <a:off x="0" y="2438400"/>
+              <a:ext cx="2438400" cy="2438400"/>
+            </a:xfrm>
+            <a:prstGeom prst="donut">
+              <a:avLst>
+                <a:gd name="adj" fmla="val 4226"/>
+              </a:avLst>
+            </a:prstGeom>
+            <a:solidFill>
+              <a:schemeClr val="tx1"/>
+            </a:solidFill>
+            <a:ln>
+              <a:noFill/>
+            </a:ln>
+          </p:spPr>
+          <p:style>
+            <a:lnRef idx="2">
+              <a:schemeClr val="accent1">
+                <a:shade val="15000"/>
+              </a:schemeClr>
+            </a:lnRef>
+            <a:fillRef idx="1">
+              <a:schemeClr val="accent1"/>
+            </a:fillRef>
+            <a:effectRef idx="0">
+              <a:schemeClr val="accent1"/>
+            </a:effectRef>
+            <a:fontRef idx="minor">
+              <a:schemeClr val="lt1"/>
+            </a:fontRef>
+          </p:style>
+          <p:txBody>
+            <a:bodyPr rtlCol="0" anchor="ctr"/>
+            <a:lstStyle/>
+            <a:p>
+              <a:pPr algn="ctr"/>
+              <a:endParaRPr lang="ko-KR" altLang="en-US"/>
+            </a:p>
+          </p:txBody>
+        </p:sp>
+        <p:grpSp>
+          <p:nvGrpSpPr>
+            <p:cNvPr id="19" name="Group 18">
+              <a:extLst>
+                <a:ext uri="{FF2B5EF4-FFF2-40B4-BE49-F238E27FC236}">
+                  <a16:creationId xmlns:a16="http://schemas.microsoft.com/office/drawing/2014/main" id="{A265A104-123D-FA15-B04E-967742B77DA0}"/>
+                </a:ext>
+              </a:extLst>
+            </p:cNvPr>
+            <p:cNvGrpSpPr/>
+            <p:nvPr/>
+          </p:nvGrpSpPr>
+          <p:grpSpPr>
+            <a:xfrm rot="16200000">
+              <a:off x="363521" y="3097306"/>
+              <a:ext cx="1711359" cy="1120588"/>
+              <a:chOff x="715375" y="6647329"/>
+              <a:chExt cx="3422717" cy="1353671"/>
+            </a:xfrm>
+            <a:solidFill>
+              <a:schemeClr val="tx1"/>
+            </a:solidFill>
+          </p:grpSpPr>
+          <p:sp>
+            <p:nvSpPr>
+              <p:cNvPr id="14" name="Arrow: Chevron 13">
+                <a:extLst>
+                  <a:ext uri="{FF2B5EF4-FFF2-40B4-BE49-F238E27FC236}">
+                    <a16:creationId xmlns:a16="http://schemas.microsoft.com/office/drawing/2014/main" id="{BD6CA2CF-D48D-9B04-538C-8503D35F0D5C}"/>
+                  </a:ext>
+                </a:extLst>
+              </p:cNvPr>
+              <p:cNvSpPr/>
+              <p:nvPr/>
+            </p:nvSpPr>
+            <p:spPr>
+              <a:xfrm>
+                <a:off x="715375" y="6647329"/>
+                <a:ext cx="1353671" cy="1353671"/>
+              </a:xfrm>
+              <a:prstGeom prst="chevron">
+                <a:avLst/>
+              </a:prstGeom>
+              <a:grpFill/>
+              <a:ln>
+                <a:noFill/>
+              </a:ln>
+            </p:spPr>
+            <p:style>
+              <a:lnRef idx="2">
+                <a:schemeClr val="accent1">
+                  <a:shade val="15000"/>
+                </a:schemeClr>
+              </a:lnRef>
+              <a:fillRef idx="1">
+                <a:schemeClr val="accent1"/>
+              </a:fillRef>
+              <a:effectRef idx="0">
+                <a:schemeClr val="accent1"/>
+              </a:effectRef>
+              <a:fontRef idx="minor">
+                <a:schemeClr val="lt1"/>
+              </a:fontRef>
+            </p:style>
+            <p:txBody>
+              <a:bodyPr rtlCol="0" anchor="ctr"/>
+              <a:lstStyle/>
+              <a:p>
+                <a:pPr algn="ctr"/>
+                <a:endParaRPr lang="ko-KR" altLang="en-US">
+                  <a:solidFill>
+                    <a:schemeClr val="tx1"/>
+                  </a:solidFill>
+                </a:endParaRPr>
+              </a:p>
+            </p:txBody>
+          </p:sp>
+          <p:sp>
+            <p:nvSpPr>
+              <p:cNvPr id="16" name="Arrow: Chevron 15">
+                <a:extLst>
+                  <a:ext uri="{FF2B5EF4-FFF2-40B4-BE49-F238E27FC236}">
+                    <a16:creationId xmlns:a16="http://schemas.microsoft.com/office/drawing/2014/main" id="{9DE9B53E-C1C1-0D5A-8294-021D22F291E8}"/>
+                  </a:ext>
+                </a:extLst>
+              </p:cNvPr>
+              <p:cNvSpPr/>
+              <p:nvPr/>
+            </p:nvSpPr>
+            <p:spPr>
+              <a:xfrm>
+                <a:off x="1749898" y="6647329"/>
+                <a:ext cx="1353671" cy="1353671"/>
+              </a:xfrm>
+              <a:prstGeom prst="chevron">
+                <a:avLst/>
+              </a:prstGeom>
+              <a:grpFill/>
+              <a:ln>
+                <a:noFill/>
+              </a:ln>
+            </p:spPr>
+            <p:style>
+              <a:lnRef idx="2">
+                <a:schemeClr val="accent1">
+                  <a:shade val="15000"/>
+                </a:schemeClr>
+              </a:lnRef>
+              <a:fillRef idx="1">
+                <a:schemeClr val="accent1"/>
+              </a:fillRef>
+              <a:effectRef idx="0">
+                <a:schemeClr val="accent1"/>
+              </a:effectRef>
+              <a:fontRef idx="minor">
+                <a:schemeClr val="lt1"/>
+              </a:fontRef>
+            </p:style>
+            <p:txBody>
+              <a:bodyPr rtlCol="0" anchor="ctr"/>
+              <a:lstStyle/>
+              <a:p>
+                <a:pPr algn="ctr"/>
+                <a:endParaRPr lang="ko-KR" altLang="en-US">
+                  <a:solidFill>
+                    <a:schemeClr val="tx1"/>
+                  </a:solidFill>
+                </a:endParaRPr>
+              </a:p>
+            </p:txBody>
+          </p:sp>
+          <p:sp>
+            <p:nvSpPr>
+              <p:cNvPr id="18" name="Arrow: Chevron 17">
+                <a:extLst>
+                  <a:ext uri="{FF2B5EF4-FFF2-40B4-BE49-F238E27FC236}">
+                    <a16:creationId xmlns:a16="http://schemas.microsoft.com/office/drawing/2014/main" id="{D76A47C4-E5B9-6C51-4189-1F0D7C024EEF}"/>
+                  </a:ext>
+                </a:extLst>
+              </p:cNvPr>
+              <p:cNvSpPr/>
+              <p:nvPr/>
+            </p:nvSpPr>
+            <p:spPr>
+              <a:xfrm>
+                <a:off x="2784421" y="6647329"/>
+                <a:ext cx="1353671" cy="1353671"/>
+              </a:xfrm>
+              <a:prstGeom prst="chevron">
+                <a:avLst/>
+              </a:prstGeom>
+              <a:grpFill/>
+              <a:ln>
+                <a:noFill/>
+              </a:ln>
+            </p:spPr>
+            <p:style>
+              <a:lnRef idx="2">
+                <a:schemeClr val="accent1">
+                  <a:shade val="15000"/>
+                </a:schemeClr>
+              </a:lnRef>
+              <a:fillRef idx="1">
+                <a:schemeClr val="accent1"/>
+              </a:fillRef>
+              <a:effectRef idx="0">
+                <a:schemeClr val="accent1"/>
+              </a:effectRef>
+              <a:fontRef idx="minor">
+                <a:schemeClr val="lt1"/>
+              </a:fontRef>
+            </p:style>
+            <p:txBody>
+              <a:bodyPr rtlCol="0" anchor="ctr"/>
+              <a:lstStyle/>
+              <a:p>
+                <a:pPr algn="ctr"/>
+                <a:endParaRPr lang="ko-KR" altLang="en-US">
+                  <a:solidFill>
+                    <a:schemeClr val="tx1"/>
+                  </a:solidFill>
+                </a:endParaRPr>
+              </a:p>
+            </p:txBody>
+          </p:sp>
+        </p:grpSp>
+        <p:sp>
+          <p:nvSpPr>
+            <p:cNvPr id="21" name="Circle: Hollow 20">
+              <a:extLst>
+                <a:ext uri="{FF2B5EF4-FFF2-40B4-BE49-F238E27FC236}">
+                  <a16:creationId xmlns:a16="http://schemas.microsoft.com/office/drawing/2014/main" id="{B611FF25-C3EF-5BD1-ED49-A06DD0BC00F6}"/>
+                </a:ext>
+              </a:extLst>
+            </p:cNvPr>
+            <p:cNvSpPr/>
+            <p:nvPr/>
+          </p:nvSpPr>
+          <p:spPr>
+            <a:xfrm>
+              <a:off x="2432567" y="2438400"/>
+              <a:ext cx="2438400" cy="2438400"/>
+            </a:xfrm>
+            <a:prstGeom prst="donut">
+              <a:avLst>
+                <a:gd name="adj" fmla="val 4226"/>
+              </a:avLst>
+            </a:prstGeom>
+            <a:solidFill>
+              <a:schemeClr val="tx1"/>
+            </a:solidFill>
+            <a:ln>
+              <a:noFill/>
+            </a:ln>
+          </p:spPr>
+          <p:style>
+            <a:lnRef idx="2">
+              <a:schemeClr val="accent1">
+                <a:shade val="15000"/>
+              </a:schemeClr>
+            </a:lnRef>
+            <a:fillRef idx="1">
+              <a:schemeClr val="accent1"/>
+            </a:fillRef>
+            <a:effectRef idx="0">
+              <a:schemeClr val="accent1"/>
+            </a:effectRef>
+            <a:fontRef idx="minor">
+              <a:schemeClr val="lt1"/>
+            </a:fontRef>
+          </p:style>
+          <p:txBody>
+            <a:bodyPr rtlCol="0" anchor="ctr"/>
+            <a:lstStyle/>
+            <a:p>
+              <a:pPr algn="ctr"/>
+              <a:endParaRPr lang="ko-KR" altLang="en-US"/>
+            </a:p>
+          </p:txBody>
+        </p:sp>
+        <p:grpSp>
+          <p:nvGrpSpPr>
+            <p:cNvPr id="26" name="Group 25">
+              <a:extLst>
+                <a:ext uri="{FF2B5EF4-FFF2-40B4-BE49-F238E27FC236}">
+                  <a16:creationId xmlns:a16="http://schemas.microsoft.com/office/drawing/2014/main" id="{4A3E1C7C-F655-652D-EE72-60A2C402AA83}"/>
+                </a:ext>
+              </a:extLst>
+            </p:cNvPr>
+            <p:cNvGrpSpPr/>
+            <p:nvPr/>
+          </p:nvGrpSpPr>
+          <p:grpSpPr>
+            <a:xfrm rot="16200000">
+              <a:off x="3060553" y="2838676"/>
+              <a:ext cx="1194097" cy="1120588"/>
+              <a:chOff x="1749898" y="6647329"/>
+              <a:chExt cx="2388194" cy="1353671"/>
+            </a:xfrm>
+            <a:solidFill>
+              <a:schemeClr val="tx1"/>
+            </a:solidFill>
+          </p:grpSpPr>
+          <p:sp>
+            <p:nvSpPr>
+              <p:cNvPr id="28" name="Arrow: Chevron 27">
+                <a:extLst>
+                  <a:ext uri="{FF2B5EF4-FFF2-40B4-BE49-F238E27FC236}">
+                    <a16:creationId xmlns:a16="http://schemas.microsoft.com/office/drawing/2014/main" id="{61A762FB-B2E8-1CB2-9D7F-A4DFF0B47584}"/>
+                  </a:ext>
+                </a:extLst>
+              </p:cNvPr>
+              <p:cNvSpPr/>
+              <p:nvPr/>
+            </p:nvSpPr>
+            <p:spPr>
+              <a:xfrm>
+                <a:off x="1749898" y="6647329"/>
+                <a:ext cx="1353671" cy="1353671"/>
+              </a:xfrm>
+              <a:prstGeom prst="chevron">
+                <a:avLst/>
+              </a:prstGeom>
+              <a:grpFill/>
+              <a:ln>
+                <a:noFill/>
+              </a:ln>
+            </p:spPr>
+            <p:style>
+              <a:lnRef idx="2">
+                <a:schemeClr val="accent1">
+                  <a:shade val="15000"/>
+                </a:schemeClr>
+              </a:lnRef>
+              <a:fillRef idx="1">
+                <a:schemeClr val="accent1"/>
+              </a:fillRef>
+              <a:effectRef idx="0">
+                <a:schemeClr val="accent1"/>
+              </a:effectRef>
+              <a:fontRef idx="minor">
+                <a:schemeClr val="lt1"/>
+              </a:fontRef>
+            </p:style>
+            <p:txBody>
+              <a:bodyPr rtlCol="0" anchor="ctr"/>
+              <a:lstStyle/>
+              <a:p>
+                <a:pPr algn="ctr"/>
+                <a:endParaRPr lang="ko-KR" altLang="en-US">
+                  <a:solidFill>
+                    <a:schemeClr val="tx1"/>
+                  </a:solidFill>
+                </a:endParaRPr>
+              </a:p>
+            </p:txBody>
+          </p:sp>
+          <p:sp>
+            <p:nvSpPr>
+              <p:cNvPr id="29" name="Arrow: Chevron 28">
+                <a:extLst>
+                  <a:ext uri="{FF2B5EF4-FFF2-40B4-BE49-F238E27FC236}">
+                    <a16:creationId xmlns:a16="http://schemas.microsoft.com/office/drawing/2014/main" id="{95EABABF-5AAA-94DA-5F99-F3C97D9AED2F}"/>
+                  </a:ext>
+                </a:extLst>
+              </p:cNvPr>
+              <p:cNvSpPr/>
+              <p:nvPr/>
+            </p:nvSpPr>
+            <p:spPr>
+              <a:xfrm>
+                <a:off x="2784421" y="6647329"/>
+                <a:ext cx="1353671" cy="1353671"/>
+              </a:xfrm>
+              <a:prstGeom prst="chevron">
+                <a:avLst/>
+              </a:prstGeom>
+              <a:grpFill/>
+              <a:ln>
+                <a:noFill/>
+              </a:ln>
+            </p:spPr>
+            <p:style>
+              <a:lnRef idx="2">
+                <a:schemeClr val="accent1">
+                  <a:shade val="15000"/>
+                </a:schemeClr>
+              </a:lnRef>
+              <a:fillRef idx="1">
+                <a:schemeClr val="accent1"/>
+              </a:fillRef>
+              <a:effectRef idx="0">
+                <a:schemeClr val="accent1"/>
+              </a:effectRef>
+              <a:fontRef idx="minor">
+                <a:schemeClr val="lt1"/>
+              </a:fontRef>
+            </p:style>
+            <p:txBody>
+              <a:bodyPr rtlCol="0" anchor="ctr"/>
+              <a:lstStyle/>
+              <a:p>
+                <a:pPr algn="ctr"/>
+                <a:endParaRPr lang="ko-KR" altLang="en-US">
+                  <a:solidFill>
+                    <a:schemeClr val="tx1"/>
+                  </a:solidFill>
+                </a:endParaRPr>
+              </a:p>
+            </p:txBody>
+          </p:sp>
+        </p:grpSp>
+        <p:sp>
+          <p:nvSpPr>
+            <p:cNvPr id="31" name="Block Arc 30">
+              <a:extLst>
+                <a:ext uri="{FF2B5EF4-FFF2-40B4-BE49-F238E27FC236}">
+                  <a16:creationId xmlns:a16="http://schemas.microsoft.com/office/drawing/2014/main" id="{704B9043-83F5-9452-AB18-AEB425CE1388}"/>
+                </a:ext>
+              </a:extLst>
+            </p:cNvPr>
+            <p:cNvSpPr/>
+            <p:nvPr/>
+          </p:nvSpPr>
+          <p:spPr>
+            <a:xfrm rot="10800000">
+              <a:off x="2837330" y="4076054"/>
+              <a:ext cx="1640541" cy="321134"/>
+            </a:xfrm>
+            <a:custGeom>
+              <a:avLst/>
+              <a:gdLst>
+                <a:gd name="csX0" fmla="*/ 0 w 2055600"/>
+                <a:gd name="csY0" fmla="*/ 1028573 h 2057146"/>
+                <a:gd name="csX1" fmla="*/ 1027800 w 2055600"/>
+                <a:gd name="csY1" fmla="*/ 0 h 2057146"/>
+                <a:gd name="csX2" fmla="*/ 2055600 w 2055600"/>
+                <a:gd name="csY2" fmla="*/ 1028573 h 2057146"/>
+                <a:gd name="csX3" fmla="*/ 1541700 w 2055600"/>
+                <a:gd name="csY3" fmla="*/ 1028573 h 2057146"/>
+                <a:gd name="csX4" fmla="*/ 1027800 w 2055600"/>
+                <a:gd name="csY4" fmla="*/ 513900 h 2057146"/>
+                <a:gd name="csX5" fmla="*/ 513900 w 2055600"/>
+                <a:gd name="csY5" fmla="*/ 1028573 h 2057146"/>
+                <a:gd name="csX6" fmla="*/ 0 w 2055600"/>
+                <a:gd name="csY6" fmla="*/ 1028573 h 2057146"/>
+                <a:gd name="csX0" fmla="*/ 1541700 w 2055600"/>
+                <a:gd name="csY0" fmla="*/ 1028573 h 1120013"/>
+                <a:gd name="csX1" fmla="*/ 1027800 w 2055600"/>
+                <a:gd name="csY1" fmla="*/ 513900 h 1120013"/>
+                <a:gd name="csX2" fmla="*/ 513900 w 2055600"/>
+                <a:gd name="csY2" fmla="*/ 1028573 h 1120013"/>
+                <a:gd name="csX3" fmla="*/ 0 w 2055600"/>
+                <a:gd name="csY3" fmla="*/ 1028573 h 1120013"/>
+                <a:gd name="csX4" fmla="*/ 1027800 w 2055600"/>
+                <a:gd name="csY4" fmla="*/ 0 h 1120013"/>
+                <a:gd name="csX5" fmla="*/ 2055600 w 2055600"/>
+                <a:gd name="csY5" fmla="*/ 1028573 h 1120013"/>
+                <a:gd name="csX6" fmla="*/ 1633140 w 2055600"/>
+                <a:gd name="csY6" fmla="*/ 1120013 h 1120013"/>
+                <a:gd name="csX0" fmla="*/ 1541700 w 2055600"/>
+                <a:gd name="csY0" fmla="*/ 1028573 h 1028573"/>
+                <a:gd name="csX1" fmla="*/ 1027800 w 2055600"/>
+                <a:gd name="csY1" fmla="*/ 513900 h 1028573"/>
+                <a:gd name="csX2" fmla="*/ 513900 w 2055600"/>
+                <a:gd name="csY2" fmla="*/ 1028573 h 1028573"/>
+                <a:gd name="csX3" fmla="*/ 0 w 2055600"/>
+                <a:gd name="csY3" fmla="*/ 1028573 h 1028573"/>
+                <a:gd name="csX4" fmla="*/ 1027800 w 2055600"/>
+                <a:gd name="csY4" fmla="*/ 0 h 1028573"/>
+                <a:gd name="csX5" fmla="*/ 2055600 w 2055600"/>
+                <a:gd name="csY5" fmla="*/ 1028573 h 1028573"/>
+              </a:gdLst>
+              <a:ahLst/>
+              <a:cxnLst>
+                <a:cxn ang="0">
+                  <a:pos x="csX0" y="csY0"/>
+                </a:cxn>
+                <a:cxn ang="0">
+                  <a:pos x="csX1" y="csY1"/>
+                </a:cxn>
+                <a:cxn ang="0">
+                  <a:pos x="csX2" y="csY2"/>
+                </a:cxn>
+                <a:cxn ang="0">
+                  <a:pos x="csX3" y="csY3"/>
+                </a:cxn>
+                <a:cxn ang="0">
+                  <a:pos x="csX4" y="csY4"/>
+                </a:cxn>
+                <a:cxn ang="0">
+                  <a:pos x="csX5" y="csY5"/>
+                </a:cxn>
+              </a:cxnLst>
+              <a:rect l="l" t="t" r="r" b="b"/>
+              <a:pathLst>
+                <a:path w="2055600" h="1028573">
+                  <a:moveTo>
+                    <a:pt x="1541700" y="1028573"/>
+                  </a:moveTo>
+                  <a:cubicBezTo>
+                    <a:pt x="1541700" y="744327"/>
+                    <a:pt x="1311619" y="513900"/>
+                    <a:pt x="1027800" y="513900"/>
+                  </a:cubicBezTo>
+                  <a:cubicBezTo>
+                    <a:pt x="743981" y="513900"/>
+                    <a:pt x="513900" y="744327"/>
+                    <a:pt x="513900" y="1028573"/>
+                  </a:cubicBezTo>
+                  <a:lnTo>
+                    <a:pt x="0" y="1028573"/>
+                  </a:lnTo>
+                  <a:cubicBezTo>
+                    <a:pt x="0" y="460508"/>
+                    <a:pt x="460162" y="0"/>
+                    <a:pt x="1027800" y="0"/>
+                  </a:cubicBezTo>
+                  <a:cubicBezTo>
+                    <a:pt x="1595438" y="0"/>
+                    <a:pt x="2055600" y="460508"/>
+                    <a:pt x="2055600" y="1028573"/>
+                  </a:cubicBezTo>
+                </a:path>
+              </a:pathLst>
+            </a:custGeom>
+            <a:solidFill>
+              <a:schemeClr val="tx1"/>
+            </a:solidFill>
+            <a:ln>
+              <a:noFill/>
+            </a:ln>
+          </p:spPr>
+          <p:style>
+            <a:lnRef idx="2">
+              <a:schemeClr val="accent1">
+                <a:shade val="15000"/>
+              </a:schemeClr>
+            </a:lnRef>
+            <a:fillRef idx="1">
+              <a:schemeClr val="accent1"/>
+            </a:fillRef>
+            <a:effectRef idx="0">
+              <a:schemeClr val="accent1"/>
+            </a:effectRef>
+            <a:fontRef idx="minor">
+              <a:schemeClr val="lt1"/>
+            </a:fontRef>
+          </p:style>
+          <p:txBody>
+            <a:bodyPr rtlCol="0" anchor="ctr"/>
+            <a:lstStyle/>
+            <a:p>
+              <a:pPr algn="ctr"/>
+              <a:endParaRPr lang="ko-KR" altLang="en-US">
+                <a:solidFill>
+                  <a:schemeClr val="tx1"/>
+                </a:solidFill>
+              </a:endParaRPr>
+            </a:p>
+          </p:txBody>
+        </p:sp>
+        <p:sp>
+          <p:nvSpPr>
+            <p:cNvPr id="34" name="Circle: Hollow 33">
+              <a:extLst>
+                <a:ext uri="{FF2B5EF4-FFF2-40B4-BE49-F238E27FC236}">
+                  <a16:creationId xmlns:a16="http://schemas.microsoft.com/office/drawing/2014/main" id="{DCFE62F1-0F69-0E49-30A4-3EC825D3B1D3}"/>
+                </a:ext>
+              </a:extLst>
+            </p:cNvPr>
+            <p:cNvSpPr/>
+            <p:nvPr/>
+          </p:nvSpPr>
+          <p:spPr>
+            <a:xfrm>
+              <a:off x="4882633" y="0"/>
+              <a:ext cx="2438400" cy="2438400"/>
+            </a:xfrm>
+            <a:prstGeom prst="donut">
+              <a:avLst>
+                <a:gd name="adj" fmla="val 4226"/>
+              </a:avLst>
+            </a:prstGeom>
+            <a:solidFill>
+              <a:schemeClr val="tx1"/>
+            </a:solidFill>
+            <a:ln>
+              <a:noFill/>
+            </a:ln>
+          </p:spPr>
+          <p:style>
+            <a:lnRef idx="2">
+              <a:schemeClr val="accent1">
+                <a:shade val="15000"/>
+              </a:schemeClr>
+            </a:lnRef>
+            <a:fillRef idx="1">
+              <a:schemeClr val="accent1"/>
+            </a:fillRef>
+            <a:effectRef idx="0">
+              <a:schemeClr val="accent1"/>
+            </a:effectRef>
+            <a:fontRef idx="minor">
+              <a:schemeClr val="lt1"/>
+            </a:fontRef>
+          </p:style>
+          <p:txBody>
+            <a:bodyPr rtlCol="0" anchor="ctr"/>
+            <a:lstStyle/>
+            <a:p>
+              <a:pPr algn="ctr"/>
+              <a:endParaRPr lang="ko-KR" altLang="en-US"/>
+            </a:p>
+          </p:txBody>
+        </p:sp>
+        <p:sp>
+          <p:nvSpPr>
+            <p:cNvPr id="36" name="Plus Sign 35">
+              <a:extLst>
+                <a:ext uri="{FF2B5EF4-FFF2-40B4-BE49-F238E27FC236}">
+                  <a16:creationId xmlns:a16="http://schemas.microsoft.com/office/drawing/2014/main" id="{4552F5D6-A064-8725-1E13-4311DD53B5A8}"/>
+                </a:ext>
+              </a:extLst>
+            </p:cNvPr>
+            <p:cNvSpPr/>
+            <p:nvPr/>
+          </p:nvSpPr>
+          <p:spPr>
+            <a:xfrm>
+              <a:off x="5109882" y="424468"/>
+              <a:ext cx="1205753" cy="1205753"/>
+            </a:xfrm>
+            <a:prstGeom prst="mathPlus">
+              <a:avLst/>
+            </a:prstGeom>
+            <a:solidFill>
+              <a:schemeClr val="tx1"/>
+            </a:solidFill>
+            <a:ln>
+              <a:noFill/>
+            </a:ln>
+          </p:spPr>
+          <p:style>
+            <a:lnRef idx="2">
+              <a:schemeClr val="accent1">
+                <a:shade val="15000"/>
+              </a:schemeClr>
+            </a:lnRef>
+            <a:fillRef idx="1">
+              <a:schemeClr val="accent1"/>
+            </a:fillRef>
+            <a:effectRef idx="0">
+              <a:schemeClr val="accent1"/>
+            </a:effectRef>
+            <a:fontRef idx="minor">
+              <a:schemeClr val="lt1"/>
+            </a:fontRef>
+          </p:style>
+          <p:txBody>
+            <a:bodyPr rtlCol="0" anchor="ctr"/>
+            <a:lstStyle/>
+            <a:p>
+              <a:pPr algn="ctr"/>
+              <a:endParaRPr lang="ko-KR" altLang="en-US"/>
+            </a:p>
+          </p:txBody>
+        </p:sp>
+        <p:grpSp>
+          <p:nvGrpSpPr>
+            <p:cNvPr id="37" name="Group 36">
+              <a:extLst>
+                <a:ext uri="{FF2B5EF4-FFF2-40B4-BE49-F238E27FC236}">
+                  <a16:creationId xmlns:a16="http://schemas.microsoft.com/office/drawing/2014/main" id="{A7CDC099-2BAE-8217-B5EC-9312CA8BD6D3}"/>
+                </a:ext>
+              </a:extLst>
+            </p:cNvPr>
+            <p:cNvGrpSpPr/>
+            <p:nvPr/>
+          </p:nvGrpSpPr>
+          <p:grpSpPr>
+            <a:xfrm rot="16200000">
+              <a:off x="6125196" y="1090652"/>
+              <a:ext cx="835376" cy="783950"/>
+              <a:chOff x="1749898" y="6647329"/>
+              <a:chExt cx="2388194" cy="1353671"/>
+            </a:xfrm>
+            <a:solidFill>
+              <a:schemeClr val="tx1"/>
+            </a:solidFill>
+          </p:grpSpPr>
+          <p:sp>
+            <p:nvSpPr>
+              <p:cNvPr id="39" name="Arrow: Chevron 38">
+                <a:extLst>
+                  <a:ext uri="{FF2B5EF4-FFF2-40B4-BE49-F238E27FC236}">
+                    <a16:creationId xmlns:a16="http://schemas.microsoft.com/office/drawing/2014/main" id="{494CE12E-5CEF-E5B4-EC3A-CAACE9009898}"/>
+                  </a:ext>
+                </a:extLst>
+              </p:cNvPr>
+              <p:cNvSpPr/>
+              <p:nvPr/>
+            </p:nvSpPr>
+            <p:spPr>
+              <a:xfrm>
+                <a:off x="1749898" y="6647329"/>
+                <a:ext cx="1353671" cy="1353671"/>
+              </a:xfrm>
+              <a:prstGeom prst="chevron">
+                <a:avLst/>
+              </a:prstGeom>
+              <a:grpFill/>
+              <a:ln>
+                <a:noFill/>
+              </a:ln>
+            </p:spPr>
+            <p:style>
+              <a:lnRef idx="2">
+                <a:schemeClr val="accent1">
+                  <a:shade val="15000"/>
+                </a:schemeClr>
+              </a:lnRef>
+              <a:fillRef idx="1">
+                <a:schemeClr val="accent1"/>
+              </a:fillRef>
+              <a:effectRef idx="0">
+                <a:schemeClr val="accent1"/>
+              </a:effectRef>
+              <a:fontRef idx="minor">
+                <a:schemeClr val="lt1"/>
+              </a:fontRef>
+            </p:style>
+            <p:txBody>
+              <a:bodyPr rtlCol="0" anchor="ctr"/>
+              <a:lstStyle/>
+              <a:p>
+                <a:pPr algn="ctr"/>
+                <a:endParaRPr lang="ko-KR" altLang="en-US">
+                  <a:solidFill>
+                    <a:schemeClr val="tx1"/>
+                  </a:solidFill>
+                </a:endParaRPr>
+              </a:p>
+            </p:txBody>
+          </p:sp>
+          <p:sp>
+            <p:nvSpPr>
+              <p:cNvPr id="40" name="Arrow: Chevron 39">
+                <a:extLst>
+                  <a:ext uri="{FF2B5EF4-FFF2-40B4-BE49-F238E27FC236}">
+                    <a16:creationId xmlns:a16="http://schemas.microsoft.com/office/drawing/2014/main" id="{92A355CD-FB89-784A-4E6A-1D8300EEEE50}"/>
+                  </a:ext>
+                </a:extLst>
+              </p:cNvPr>
+              <p:cNvSpPr/>
+              <p:nvPr/>
+            </p:nvSpPr>
+            <p:spPr>
+              <a:xfrm>
+                <a:off x="2784421" y="6647329"/>
+                <a:ext cx="1353671" cy="1353671"/>
+              </a:xfrm>
+              <a:prstGeom prst="chevron">
+                <a:avLst/>
+              </a:prstGeom>
+              <a:grpFill/>
+              <a:ln>
+                <a:noFill/>
+              </a:ln>
+            </p:spPr>
+            <p:style>
+              <a:lnRef idx="2">
+                <a:schemeClr val="accent1">
+                  <a:shade val="15000"/>
+                </a:schemeClr>
+              </a:lnRef>
+              <a:fillRef idx="1">
+                <a:schemeClr val="accent1"/>
+              </a:fillRef>
+              <a:effectRef idx="0">
+                <a:schemeClr val="accent1"/>
+              </a:effectRef>
+              <a:fontRef idx="minor">
+                <a:schemeClr val="lt1"/>
+              </a:fontRef>
+            </p:style>
+            <p:txBody>
+              <a:bodyPr rtlCol="0" anchor="ctr"/>
+              <a:lstStyle/>
+              <a:p>
+                <a:pPr algn="ctr"/>
+                <a:endParaRPr lang="ko-KR" altLang="en-US">
+                  <a:solidFill>
+                    <a:schemeClr val="tx1"/>
+                  </a:solidFill>
+                </a:endParaRPr>
+              </a:p>
+            </p:txBody>
+          </p:sp>
+        </p:grpSp>
+        <p:sp>
+          <p:nvSpPr>
+            <p:cNvPr id="42" name="Circle: Hollow 41">
+              <a:extLst>
+                <a:ext uri="{FF2B5EF4-FFF2-40B4-BE49-F238E27FC236}">
+                  <a16:creationId xmlns:a16="http://schemas.microsoft.com/office/drawing/2014/main" id="{1CF647F1-19AF-0A88-3395-78D7D03AB7FF}"/>
+                </a:ext>
+              </a:extLst>
+            </p:cNvPr>
+            <p:cNvSpPr/>
+            <p:nvPr/>
+          </p:nvSpPr>
+          <p:spPr>
+            <a:xfrm>
+              <a:off x="7315200" y="0"/>
+              <a:ext cx="2438400" cy="2438400"/>
+            </a:xfrm>
+            <a:prstGeom prst="donut">
+              <a:avLst>
+                <a:gd name="adj" fmla="val 4226"/>
+              </a:avLst>
+            </a:prstGeom>
+            <a:solidFill>
+              <a:schemeClr val="tx1"/>
+            </a:solidFill>
+            <a:ln>
+              <a:noFill/>
+            </a:ln>
+          </p:spPr>
+          <p:style>
+            <a:lnRef idx="2">
+              <a:schemeClr val="accent1">
+                <a:shade val="15000"/>
+              </a:schemeClr>
+            </a:lnRef>
+            <a:fillRef idx="1">
+              <a:schemeClr val="accent1"/>
+            </a:fillRef>
+            <a:effectRef idx="0">
+              <a:schemeClr val="accent1"/>
+            </a:effectRef>
+            <a:fontRef idx="minor">
+              <a:schemeClr val="lt1"/>
+            </a:fontRef>
+          </p:style>
+          <p:txBody>
+            <a:bodyPr rtlCol="0" anchor="ctr"/>
+            <a:lstStyle/>
+            <a:p>
+              <a:pPr algn="ctr"/>
+              <a:endParaRPr lang="ko-KR" altLang="en-US"/>
+            </a:p>
+          </p:txBody>
+        </p:sp>
+        <p:grpSp>
+          <p:nvGrpSpPr>
+            <p:cNvPr id="46" name="Group 45">
+              <a:extLst>
+                <a:ext uri="{FF2B5EF4-FFF2-40B4-BE49-F238E27FC236}">
+                  <a16:creationId xmlns:a16="http://schemas.microsoft.com/office/drawing/2014/main" id="{187AE127-CFA7-2309-2CEC-6F6B2466E323}"/>
+                </a:ext>
+              </a:extLst>
+            </p:cNvPr>
+            <p:cNvGrpSpPr/>
+            <p:nvPr/>
+          </p:nvGrpSpPr>
+          <p:grpSpPr>
+            <a:xfrm>
+              <a:off x="6016012" y="3395377"/>
+              <a:ext cx="891510" cy="1035416"/>
+              <a:chOff x="7835273" y="290512"/>
+              <a:chExt cx="1404086" cy="1630731"/>
+            </a:xfrm>
+          </p:grpSpPr>
+          <p:sp>
+            <p:nvSpPr>
+              <p:cNvPr id="43" name="Block Arc 42">
+                <a:extLst>
+                  <a:ext uri="{FF2B5EF4-FFF2-40B4-BE49-F238E27FC236}">
+                    <a16:creationId xmlns:a16="http://schemas.microsoft.com/office/drawing/2014/main" id="{851D78E6-4FEC-EFFB-7FA5-BD7BDC3D6787}"/>
+                  </a:ext>
+                </a:extLst>
+              </p:cNvPr>
+              <p:cNvSpPr/>
+              <p:nvPr/>
+            </p:nvSpPr>
+            <p:spPr>
+              <a:xfrm rot="5400000">
+                <a:off x="7835273" y="517157"/>
+                <a:ext cx="1404086" cy="1404086"/>
+              </a:xfrm>
+              <a:prstGeom prst="blockArc">
+                <a:avLst>
+                  <a:gd name="adj1" fmla="val 10800000"/>
+                  <a:gd name="adj2" fmla="val 8256432"/>
+                  <a:gd name="adj3" fmla="val 11660"/>
+                </a:avLst>
+              </a:prstGeom>
+              <a:solidFill>
+                <a:schemeClr val="tx1"/>
+              </a:solidFill>
+              <a:ln>
+                <a:noFill/>
+              </a:ln>
+            </p:spPr>
+            <p:style>
+              <a:lnRef idx="2">
+                <a:schemeClr val="accent1">
+                  <a:shade val="15000"/>
+                </a:schemeClr>
+              </a:lnRef>
+              <a:fillRef idx="1">
+                <a:schemeClr val="accent1"/>
+              </a:fillRef>
+              <a:effectRef idx="0">
+                <a:schemeClr val="accent1"/>
+              </a:effectRef>
+              <a:fontRef idx="minor">
+                <a:schemeClr val="lt1"/>
+              </a:fontRef>
+            </p:style>
+            <p:txBody>
+              <a:bodyPr rtlCol="0" anchor="ctr"/>
+              <a:lstStyle/>
+              <a:p>
+                <a:pPr algn="ctr"/>
+                <a:endParaRPr lang="ko-KR" altLang="en-US">
+                  <a:solidFill>
+                    <a:schemeClr val="tx1"/>
+                  </a:solidFill>
+                </a:endParaRPr>
+              </a:p>
+            </p:txBody>
+          </p:sp>
+          <p:sp>
+            <p:nvSpPr>
+              <p:cNvPr id="44" name="Isosceles Triangle 43">
+                <a:extLst>
+                  <a:ext uri="{FF2B5EF4-FFF2-40B4-BE49-F238E27FC236}">
+                    <a16:creationId xmlns:a16="http://schemas.microsoft.com/office/drawing/2014/main" id="{50567D47-39E6-44E2-F15D-EF435FD0821D}"/>
+                  </a:ext>
+                </a:extLst>
+              </p:cNvPr>
+              <p:cNvSpPr/>
+              <p:nvPr/>
+            </p:nvSpPr>
+            <p:spPr>
+              <a:xfrm>
+                <a:off x="8389143" y="853368"/>
+                <a:ext cx="290514" cy="365832"/>
+              </a:xfrm>
+              <a:prstGeom prst="triangle">
+                <a:avLst/>
+              </a:prstGeom>
+              <a:solidFill>
+                <a:schemeClr val="tx1"/>
+              </a:solidFill>
+              <a:ln>
+                <a:noFill/>
+              </a:ln>
+            </p:spPr>
+            <p:style>
+              <a:lnRef idx="2">
+                <a:schemeClr val="accent1">
+                  <a:shade val="15000"/>
+                </a:schemeClr>
+              </a:lnRef>
+              <a:fillRef idx="1">
+                <a:schemeClr val="accent1"/>
+              </a:fillRef>
+              <a:effectRef idx="0">
+                <a:schemeClr val="accent1"/>
+              </a:effectRef>
+              <a:fontRef idx="minor">
+                <a:schemeClr val="lt1"/>
+              </a:fontRef>
+            </p:style>
+            <p:txBody>
+              <a:bodyPr rtlCol="0" anchor="ctr"/>
+              <a:lstStyle/>
+              <a:p>
+                <a:pPr algn="ctr"/>
+                <a:endParaRPr lang="ko-KR" altLang="en-US"/>
+              </a:p>
+            </p:txBody>
+          </p:sp>
+          <p:sp>
+            <p:nvSpPr>
+              <p:cNvPr id="45" name="Rectangle 44">
+                <a:extLst>
+                  <a:ext uri="{FF2B5EF4-FFF2-40B4-BE49-F238E27FC236}">
+                    <a16:creationId xmlns:a16="http://schemas.microsoft.com/office/drawing/2014/main" id="{3D7EB41F-2826-43B4-9A0C-90A1B90E4D06}"/>
+                  </a:ext>
+                </a:extLst>
+              </p:cNvPr>
+              <p:cNvSpPr/>
+              <p:nvPr/>
+            </p:nvSpPr>
+            <p:spPr>
+              <a:xfrm>
+                <a:off x="8292841" y="290512"/>
+                <a:ext cx="488950" cy="148713"/>
+              </a:xfrm>
+              <a:prstGeom prst="rect">
+                <a:avLst/>
+              </a:prstGeom>
+              <a:solidFill>
+                <a:schemeClr val="tx1"/>
+              </a:solidFill>
+              <a:ln>
+                <a:noFill/>
+              </a:ln>
+            </p:spPr>
+            <p:style>
+              <a:lnRef idx="2">
+                <a:schemeClr val="accent1">
+                  <a:shade val="15000"/>
+                </a:schemeClr>
+              </a:lnRef>
+              <a:fillRef idx="1">
+                <a:schemeClr val="accent1"/>
+              </a:fillRef>
+              <a:effectRef idx="0">
+                <a:schemeClr val="accent1"/>
+              </a:effectRef>
+              <a:fontRef idx="minor">
+                <a:schemeClr val="lt1"/>
+              </a:fontRef>
+            </p:style>
+            <p:txBody>
+              <a:bodyPr rtlCol="0" anchor="ctr"/>
+              <a:lstStyle/>
+              <a:p>
+                <a:pPr algn="ctr"/>
+                <a:endParaRPr lang="ko-KR" altLang="en-US"/>
+              </a:p>
+            </p:txBody>
+          </p:sp>
+        </p:grpSp>
+        <p:sp>
+          <p:nvSpPr>
+            <p:cNvPr id="48" name="Circle: Hollow 47">
+              <a:extLst>
+                <a:ext uri="{FF2B5EF4-FFF2-40B4-BE49-F238E27FC236}">
+                  <a16:creationId xmlns:a16="http://schemas.microsoft.com/office/drawing/2014/main" id="{1227F25A-3D81-CF2A-0D4B-555938EA9764}"/>
+                </a:ext>
+              </a:extLst>
+            </p:cNvPr>
+            <p:cNvSpPr/>
+            <p:nvPr/>
+          </p:nvSpPr>
+          <p:spPr>
+            <a:xfrm>
+              <a:off x="4868051" y="2438400"/>
+              <a:ext cx="2438400" cy="2438400"/>
+            </a:xfrm>
+            <a:prstGeom prst="donut">
+              <a:avLst>
+                <a:gd name="adj" fmla="val 4226"/>
+              </a:avLst>
+            </a:prstGeom>
+            <a:solidFill>
+              <a:schemeClr val="tx1"/>
+            </a:solidFill>
+            <a:ln>
+              <a:noFill/>
+            </a:ln>
+          </p:spPr>
+          <p:style>
+            <a:lnRef idx="2">
+              <a:schemeClr val="accent1">
+                <a:shade val="15000"/>
+              </a:schemeClr>
+            </a:lnRef>
+            <a:fillRef idx="1">
+              <a:schemeClr val="accent1"/>
+            </a:fillRef>
+            <a:effectRef idx="0">
+              <a:schemeClr val="accent1"/>
+            </a:effectRef>
+            <a:fontRef idx="minor">
+              <a:schemeClr val="lt1"/>
+            </a:fontRef>
+          </p:style>
+          <p:txBody>
+            <a:bodyPr rtlCol="0" anchor="ctr"/>
+            <a:lstStyle/>
+            <a:p>
+              <a:pPr algn="ctr"/>
+              <a:endParaRPr lang="ko-KR" altLang="en-US"/>
+            </a:p>
+          </p:txBody>
+        </p:sp>
+        <p:grpSp>
+          <p:nvGrpSpPr>
+            <p:cNvPr id="49" name="Group 48">
+              <a:extLst>
+                <a:ext uri="{FF2B5EF4-FFF2-40B4-BE49-F238E27FC236}">
+                  <a16:creationId xmlns:a16="http://schemas.microsoft.com/office/drawing/2014/main" id="{0CF540C5-C63B-1910-5EAF-496DB3547CE8}"/>
+                </a:ext>
+              </a:extLst>
+            </p:cNvPr>
+            <p:cNvGrpSpPr/>
+            <p:nvPr/>
+          </p:nvGrpSpPr>
+          <p:grpSpPr>
+            <a:xfrm>
+              <a:off x="7832357" y="403835"/>
+              <a:ext cx="1404086" cy="1630731"/>
+              <a:chOff x="7835273" y="290512"/>
+              <a:chExt cx="1404086" cy="1630731"/>
+            </a:xfrm>
+          </p:grpSpPr>
+          <p:sp>
+            <p:nvSpPr>
+              <p:cNvPr id="50" name="Block Arc 49">
+                <a:extLst>
+                  <a:ext uri="{FF2B5EF4-FFF2-40B4-BE49-F238E27FC236}">
+                    <a16:creationId xmlns:a16="http://schemas.microsoft.com/office/drawing/2014/main" id="{F928D6E7-5ED4-0B87-94DF-D2B25AF5AA4E}"/>
+                  </a:ext>
+                </a:extLst>
+              </p:cNvPr>
+              <p:cNvSpPr/>
+              <p:nvPr/>
+            </p:nvSpPr>
+            <p:spPr>
+              <a:xfrm rot="5400000">
+                <a:off x="7835273" y="517157"/>
+                <a:ext cx="1404086" cy="1404086"/>
+              </a:xfrm>
+              <a:prstGeom prst="blockArc">
+                <a:avLst>
+                  <a:gd name="adj1" fmla="val 10800000"/>
+                  <a:gd name="adj2" fmla="val 8256432"/>
+                  <a:gd name="adj3" fmla="val 11660"/>
+                </a:avLst>
+              </a:prstGeom>
+              <a:solidFill>
+                <a:schemeClr val="tx1"/>
+              </a:solidFill>
+              <a:ln>
+                <a:noFill/>
+              </a:ln>
+            </p:spPr>
+            <p:style>
+              <a:lnRef idx="2">
+                <a:schemeClr val="accent1">
+                  <a:shade val="15000"/>
+                </a:schemeClr>
+              </a:lnRef>
+              <a:fillRef idx="1">
+                <a:schemeClr val="accent1"/>
+              </a:fillRef>
+              <a:effectRef idx="0">
+                <a:schemeClr val="accent1"/>
+              </a:effectRef>
+              <a:fontRef idx="minor">
+                <a:schemeClr val="lt1"/>
+              </a:fontRef>
+            </p:style>
+            <p:txBody>
+              <a:bodyPr rtlCol="0" anchor="ctr"/>
+              <a:lstStyle/>
+              <a:p>
+                <a:pPr algn="ctr"/>
+                <a:endParaRPr lang="ko-KR" altLang="en-US">
+                  <a:solidFill>
+                    <a:schemeClr val="tx1"/>
+                  </a:solidFill>
+                </a:endParaRPr>
+              </a:p>
+            </p:txBody>
+          </p:sp>
+          <p:sp>
+            <p:nvSpPr>
+              <p:cNvPr id="51" name="Isosceles Triangle 50">
+                <a:extLst>
+                  <a:ext uri="{FF2B5EF4-FFF2-40B4-BE49-F238E27FC236}">
+                    <a16:creationId xmlns:a16="http://schemas.microsoft.com/office/drawing/2014/main" id="{E6C604E3-32F9-CE8A-B8B4-AE04298890F7}"/>
+                  </a:ext>
+                </a:extLst>
+              </p:cNvPr>
+              <p:cNvSpPr/>
+              <p:nvPr/>
+            </p:nvSpPr>
+            <p:spPr>
+              <a:xfrm>
+                <a:off x="8389143" y="853368"/>
+                <a:ext cx="290514" cy="365832"/>
+              </a:xfrm>
+              <a:prstGeom prst="triangle">
+                <a:avLst/>
+              </a:prstGeom>
+              <a:solidFill>
+                <a:schemeClr val="tx1"/>
+              </a:solidFill>
+              <a:ln>
+                <a:noFill/>
+              </a:ln>
+            </p:spPr>
+            <p:style>
+              <a:lnRef idx="2">
+                <a:schemeClr val="accent1">
+                  <a:shade val="15000"/>
+                </a:schemeClr>
+              </a:lnRef>
+              <a:fillRef idx="1">
+                <a:schemeClr val="accent1"/>
+              </a:fillRef>
+              <a:effectRef idx="0">
+                <a:schemeClr val="accent1"/>
+              </a:effectRef>
+              <a:fontRef idx="minor">
+                <a:schemeClr val="lt1"/>
+              </a:fontRef>
+            </p:style>
+            <p:txBody>
+              <a:bodyPr rtlCol="0" anchor="ctr"/>
+              <a:lstStyle/>
+              <a:p>
+                <a:pPr algn="ctr"/>
+                <a:endParaRPr lang="ko-KR" altLang="en-US"/>
+              </a:p>
+            </p:txBody>
+          </p:sp>
+          <p:sp>
+            <p:nvSpPr>
+              <p:cNvPr id="52" name="Rectangle 51">
+                <a:extLst>
+                  <a:ext uri="{FF2B5EF4-FFF2-40B4-BE49-F238E27FC236}">
+                    <a16:creationId xmlns:a16="http://schemas.microsoft.com/office/drawing/2014/main" id="{D40DE61B-8F3F-0895-0692-6E08C71AE5BA}"/>
+                  </a:ext>
+                </a:extLst>
+              </p:cNvPr>
+              <p:cNvSpPr/>
+              <p:nvPr/>
+            </p:nvSpPr>
+            <p:spPr>
+              <a:xfrm>
+                <a:off x="8292841" y="290512"/>
+                <a:ext cx="488950" cy="148713"/>
+              </a:xfrm>
+              <a:prstGeom prst="rect">
+                <a:avLst/>
+              </a:prstGeom>
+              <a:solidFill>
+                <a:schemeClr val="tx1"/>
+              </a:solidFill>
+              <a:ln>
+                <a:noFill/>
+              </a:ln>
+            </p:spPr>
+            <p:style>
+              <a:lnRef idx="2">
+                <a:schemeClr val="accent1">
+                  <a:shade val="15000"/>
+                </a:schemeClr>
+              </a:lnRef>
+              <a:fillRef idx="1">
+                <a:schemeClr val="accent1"/>
+              </a:fillRef>
+              <a:effectRef idx="0">
+                <a:schemeClr val="accent1"/>
+              </a:effectRef>
+              <a:fontRef idx="minor">
+                <a:schemeClr val="lt1"/>
+              </a:fontRef>
+            </p:style>
+            <p:txBody>
+              <a:bodyPr rtlCol="0" anchor="ctr"/>
+              <a:lstStyle/>
+              <a:p>
+                <a:pPr algn="ctr"/>
+                <a:endParaRPr lang="ko-KR" altLang="en-US"/>
+              </a:p>
+            </p:txBody>
+          </p:sp>
+        </p:grpSp>
+        <p:grpSp>
+          <p:nvGrpSpPr>
+            <p:cNvPr id="53" name="Group 52">
+              <a:extLst>
+                <a:ext uri="{FF2B5EF4-FFF2-40B4-BE49-F238E27FC236}">
+                  <a16:creationId xmlns:a16="http://schemas.microsoft.com/office/drawing/2014/main" id="{56B7E768-519F-D6C9-7C25-4B567EECD868}"/>
+                </a:ext>
+              </a:extLst>
+            </p:cNvPr>
+            <p:cNvGrpSpPr/>
+            <p:nvPr/>
+          </p:nvGrpSpPr>
+          <p:grpSpPr>
+            <a:xfrm rot="16200000">
+              <a:off x="5235434" y="2890073"/>
+              <a:ext cx="835376" cy="783950"/>
+              <a:chOff x="1749898" y="6647329"/>
+              <a:chExt cx="2388194" cy="1353671"/>
+            </a:xfrm>
+            <a:solidFill>
+              <a:schemeClr val="tx1"/>
+            </a:solidFill>
+          </p:grpSpPr>
+          <p:sp>
+            <p:nvSpPr>
+              <p:cNvPr id="54" name="Arrow: Chevron 53">
+                <a:extLst>
+                  <a:ext uri="{FF2B5EF4-FFF2-40B4-BE49-F238E27FC236}">
+                    <a16:creationId xmlns:a16="http://schemas.microsoft.com/office/drawing/2014/main" id="{8ECB5F58-DE00-9EE0-3F3E-8DAF73C52839}"/>
+                  </a:ext>
+                </a:extLst>
+              </p:cNvPr>
+              <p:cNvSpPr/>
+              <p:nvPr/>
+            </p:nvSpPr>
+            <p:spPr>
+              <a:xfrm>
+                <a:off x="1749898" y="6647329"/>
+                <a:ext cx="1353671" cy="1353671"/>
+              </a:xfrm>
+              <a:prstGeom prst="chevron">
+                <a:avLst/>
+              </a:prstGeom>
+              <a:grpFill/>
+              <a:ln>
+                <a:noFill/>
+              </a:ln>
+            </p:spPr>
+            <p:style>
+              <a:lnRef idx="2">
+                <a:schemeClr val="accent1">
+                  <a:shade val="15000"/>
+                </a:schemeClr>
+              </a:lnRef>
+              <a:fillRef idx="1">
+                <a:schemeClr val="accent1"/>
+              </a:fillRef>
+              <a:effectRef idx="0">
+                <a:schemeClr val="accent1"/>
+              </a:effectRef>
+              <a:fontRef idx="minor">
+                <a:schemeClr val="lt1"/>
+              </a:fontRef>
+            </p:style>
+            <p:txBody>
+              <a:bodyPr rtlCol="0" anchor="ctr"/>
+              <a:lstStyle/>
+              <a:p>
+                <a:pPr algn="ctr"/>
+                <a:endParaRPr lang="ko-KR" altLang="en-US">
+                  <a:solidFill>
+                    <a:schemeClr val="tx1"/>
+                  </a:solidFill>
+                </a:endParaRPr>
+              </a:p>
+            </p:txBody>
+          </p:sp>
+          <p:sp>
+            <p:nvSpPr>
+              <p:cNvPr id="55" name="Arrow: Chevron 54">
+                <a:extLst>
+                  <a:ext uri="{FF2B5EF4-FFF2-40B4-BE49-F238E27FC236}">
+                    <a16:creationId xmlns:a16="http://schemas.microsoft.com/office/drawing/2014/main" id="{F8A35068-C8FE-78F9-62B0-AF6DBD7A5BC8}"/>
+                  </a:ext>
+                </a:extLst>
+              </p:cNvPr>
+              <p:cNvSpPr/>
+              <p:nvPr/>
+            </p:nvSpPr>
+            <p:spPr>
+              <a:xfrm>
+                <a:off x="2784421" y="6647329"/>
+                <a:ext cx="1353671" cy="1353671"/>
+              </a:xfrm>
+              <a:prstGeom prst="chevron">
+                <a:avLst/>
+              </a:prstGeom>
+              <a:grpFill/>
+              <a:ln>
+                <a:noFill/>
+              </a:ln>
+            </p:spPr>
+            <p:style>
+              <a:lnRef idx="2">
+                <a:schemeClr val="accent1">
+                  <a:shade val="15000"/>
+                </a:schemeClr>
+              </a:lnRef>
+              <a:fillRef idx="1">
+                <a:schemeClr val="accent1"/>
+              </a:fillRef>
+              <a:effectRef idx="0">
+                <a:schemeClr val="accent1"/>
+              </a:effectRef>
+              <a:fontRef idx="minor">
+                <a:schemeClr val="lt1"/>
+              </a:fontRef>
+            </p:style>
+            <p:txBody>
+              <a:bodyPr rtlCol="0" anchor="ctr"/>
+              <a:lstStyle/>
+              <a:p>
+                <a:pPr algn="ctr"/>
+                <a:endParaRPr lang="ko-KR" altLang="en-US">
+                  <a:solidFill>
+                    <a:schemeClr val="tx1"/>
+                  </a:solidFill>
+                </a:endParaRPr>
+              </a:p>
+            </p:txBody>
+          </p:sp>
+        </p:grpSp>
+        <p:sp>
+          <p:nvSpPr>
+            <p:cNvPr id="57" name="Circle: Hollow 56">
+              <a:extLst>
+                <a:ext uri="{FF2B5EF4-FFF2-40B4-BE49-F238E27FC236}">
+                  <a16:creationId xmlns:a16="http://schemas.microsoft.com/office/drawing/2014/main" id="{1812935B-BC13-1414-AE4F-B9809140660A}"/>
+                </a:ext>
+              </a:extLst>
+            </p:cNvPr>
+            <p:cNvSpPr/>
+            <p:nvPr/>
+          </p:nvSpPr>
+          <p:spPr>
+            <a:xfrm>
+              <a:off x="7306796" y="2438400"/>
+              <a:ext cx="2438400" cy="2438400"/>
+            </a:xfrm>
+            <a:prstGeom prst="donut">
+              <a:avLst>
+                <a:gd name="adj" fmla="val 4226"/>
+              </a:avLst>
+            </a:prstGeom>
+            <a:solidFill>
+              <a:schemeClr val="tx1"/>
+            </a:solidFill>
+            <a:ln>
+              <a:noFill/>
+            </a:ln>
+          </p:spPr>
+          <p:style>
+            <a:lnRef idx="2">
+              <a:schemeClr val="accent1">
+                <a:shade val="15000"/>
+              </a:schemeClr>
+            </a:lnRef>
+            <a:fillRef idx="1">
+              <a:schemeClr val="accent1"/>
+            </a:fillRef>
+            <a:effectRef idx="0">
+              <a:schemeClr val="accent1"/>
+            </a:effectRef>
+            <a:fontRef idx="minor">
+              <a:schemeClr val="lt1"/>
+            </a:fontRef>
+          </p:style>
+          <p:txBody>
+            <a:bodyPr rtlCol="0" anchor="ctr"/>
+            <a:lstStyle/>
+            <a:p>
+              <a:pPr algn="ctr"/>
+              <a:endParaRPr lang="ko-KR" altLang="en-US"/>
+            </a:p>
+          </p:txBody>
+        </p:sp>
+        <p:grpSp>
+          <p:nvGrpSpPr>
+            <p:cNvPr id="79" name="Group 78">
+              <a:extLst>
+                <a:ext uri="{FF2B5EF4-FFF2-40B4-BE49-F238E27FC236}">
+                  <a16:creationId xmlns:a16="http://schemas.microsoft.com/office/drawing/2014/main" id="{3320532C-869A-F156-5A46-D36265C8D001}"/>
+                </a:ext>
+              </a:extLst>
+            </p:cNvPr>
+            <p:cNvGrpSpPr/>
+            <p:nvPr/>
+          </p:nvGrpSpPr>
+          <p:grpSpPr>
+            <a:xfrm rot="900000">
+              <a:off x="7828223" y="2962407"/>
+              <a:ext cx="1395547" cy="1390387"/>
+              <a:chOff x="7856014" y="3032352"/>
+              <a:chExt cx="1395547" cy="1390387"/>
+            </a:xfrm>
+            <a:solidFill>
+              <a:schemeClr val="tx1"/>
+            </a:solidFill>
+          </p:grpSpPr>
+          <p:sp>
+            <p:nvSpPr>
+              <p:cNvPr id="72" name="Teardrop 71">
+                <a:extLst>
+                  <a:ext uri="{FF2B5EF4-FFF2-40B4-BE49-F238E27FC236}">
+                    <a16:creationId xmlns:a16="http://schemas.microsoft.com/office/drawing/2014/main" id="{0B1D0F68-AC75-9208-8366-D03CBDDA3401}"/>
+                  </a:ext>
+                </a:extLst>
+              </p:cNvPr>
+              <p:cNvSpPr/>
+              <p:nvPr/>
+            </p:nvSpPr>
+            <p:spPr>
+              <a:xfrm>
+                <a:off x="7856014" y="3787999"/>
+                <a:ext cx="634740" cy="634740"/>
+              </a:xfrm>
+              <a:prstGeom prst="teardrop">
+                <a:avLst/>
+              </a:prstGeom>
+              <a:grpFill/>
+              <a:ln>
+                <a:noFill/>
+              </a:ln>
+            </p:spPr>
+            <p:style>
+              <a:lnRef idx="2">
+                <a:schemeClr val="accent1">
+                  <a:shade val="15000"/>
+                </a:schemeClr>
+              </a:lnRef>
+              <a:fillRef idx="1">
+                <a:schemeClr val="accent1"/>
+              </a:fillRef>
+              <a:effectRef idx="0">
+                <a:schemeClr val="accent1"/>
+              </a:effectRef>
+              <a:fontRef idx="minor">
+                <a:schemeClr val="lt1"/>
+              </a:fontRef>
+            </p:style>
+            <p:txBody>
+              <a:bodyPr rtlCol="0" anchor="ctr"/>
+              <a:lstStyle/>
+              <a:p>
+                <a:pPr algn="ctr"/>
+                <a:endParaRPr lang="ko-KR" altLang="en-US"/>
+              </a:p>
+            </p:txBody>
+          </p:sp>
+          <p:sp>
+            <p:nvSpPr>
+              <p:cNvPr id="74" name="Teardrop 73">
+                <a:extLst>
+                  <a:ext uri="{FF2B5EF4-FFF2-40B4-BE49-F238E27FC236}">
+                    <a16:creationId xmlns:a16="http://schemas.microsoft.com/office/drawing/2014/main" id="{174301D1-76EE-0DA2-DCE9-1C733C55E001}"/>
+                  </a:ext>
+                </a:extLst>
+              </p:cNvPr>
+              <p:cNvSpPr/>
+              <p:nvPr/>
+            </p:nvSpPr>
+            <p:spPr>
+              <a:xfrm rot="16200000">
+                <a:off x="8616821" y="3787999"/>
+                <a:ext cx="634740" cy="634740"/>
+              </a:xfrm>
+              <a:prstGeom prst="teardrop">
+                <a:avLst/>
+              </a:prstGeom>
+              <a:grpFill/>
+              <a:ln>
+                <a:noFill/>
+              </a:ln>
+            </p:spPr>
+            <p:style>
+              <a:lnRef idx="2">
+                <a:schemeClr val="accent1">
+                  <a:shade val="15000"/>
+                </a:schemeClr>
+              </a:lnRef>
+              <a:fillRef idx="1">
+                <a:schemeClr val="accent1"/>
+              </a:fillRef>
+              <a:effectRef idx="0">
+                <a:schemeClr val="accent1"/>
+              </a:effectRef>
+              <a:fontRef idx="minor">
+                <a:schemeClr val="lt1"/>
+              </a:fontRef>
+            </p:style>
+            <p:txBody>
+              <a:bodyPr rtlCol="0" anchor="ctr"/>
+              <a:lstStyle/>
+              <a:p>
+                <a:pPr algn="ctr"/>
+                <a:endParaRPr lang="ko-KR" altLang="en-US"/>
+              </a:p>
+            </p:txBody>
+          </p:sp>
+          <p:sp>
+            <p:nvSpPr>
+              <p:cNvPr id="76" name="Teardrop 75">
+                <a:extLst>
+                  <a:ext uri="{FF2B5EF4-FFF2-40B4-BE49-F238E27FC236}">
+                    <a16:creationId xmlns:a16="http://schemas.microsoft.com/office/drawing/2014/main" id="{141310F7-49AC-2D43-F158-1296C4705438}"/>
+                  </a:ext>
+                </a:extLst>
+              </p:cNvPr>
+              <p:cNvSpPr/>
+              <p:nvPr/>
+            </p:nvSpPr>
+            <p:spPr>
+              <a:xfrm rot="5400000">
+                <a:off x="7856014" y="3032352"/>
+                <a:ext cx="634740" cy="634740"/>
+              </a:xfrm>
+              <a:prstGeom prst="teardrop">
+                <a:avLst/>
+              </a:prstGeom>
+              <a:grpFill/>
+              <a:ln>
+                <a:noFill/>
+              </a:ln>
+            </p:spPr>
+            <p:style>
+              <a:lnRef idx="2">
+                <a:schemeClr val="accent1">
+                  <a:shade val="15000"/>
+                </a:schemeClr>
+              </a:lnRef>
+              <a:fillRef idx="1">
+                <a:schemeClr val="accent1"/>
+              </a:fillRef>
+              <a:effectRef idx="0">
+                <a:schemeClr val="accent1"/>
+              </a:effectRef>
+              <a:fontRef idx="minor">
+                <a:schemeClr val="lt1"/>
+              </a:fontRef>
+            </p:style>
+            <p:txBody>
+              <a:bodyPr rtlCol="0" anchor="ctr"/>
+              <a:lstStyle/>
+              <a:p>
+                <a:pPr algn="ctr"/>
+                <a:endParaRPr lang="ko-KR" altLang="en-US"/>
+              </a:p>
+            </p:txBody>
+          </p:sp>
+          <p:sp>
+            <p:nvSpPr>
+              <p:cNvPr id="78" name="Teardrop 77">
+                <a:extLst>
+                  <a:ext uri="{FF2B5EF4-FFF2-40B4-BE49-F238E27FC236}">
+                    <a16:creationId xmlns:a16="http://schemas.microsoft.com/office/drawing/2014/main" id="{7EB5279E-FFEE-92D9-08B7-E48EE5F2BD61}"/>
+                  </a:ext>
+                </a:extLst>
+              </p:cNvPr>
+              <p:cNvSpPr/>
+              <p:nvPr/>
+            </p:nvSpPr>
+            <p:spPr>
+              <a:xfrm rot="10800000">
+                <a:off x="8616821" y="3032352"/>
+                <a:ext cx="634740" cy="634740"/>
+              </a:xfrm>
+              <a:prstGeom prst="teardrop">
+                <a:avLst/>
+              </a:prstGeom>
+              <a:grpFill/>
+              <a:ln>
+                <a:noFill/>
+              </a:ln>
+            </p:spPr>
+            <p:style>
+              <a:lnRef idx="2">
+                <a:schemeClr val="accent1">
+                  <a:shade val="15000"/>
+                </a:schemeClr>
+              </a:lnRef>
+              <a:fillRef idx="1">
+                <a:schemeClr val="accent1"/>
+              </a:fillRef>
+              <a:effectRef idx="0">
+                <a:schemeClr val="accent1"/>
+              </a:effectRef>
+              <a:fontRef idx="minor">
+                <a:schemeClr val="lt1"/>
+              </a:fontRef>
+            </p:style>
+            <p:txBody>
+              <a:bodyPr rtlCol="0" anchor="ctr"/>
+              <a:lstStyle/>
+              <a:p>
+                <a:pPr algn="ctr"/>
+                <a:endParaRPr lang="ko-KR" altLang="en-US"/>
+              </a:p>
+            </p:txBody>
+          </p:sp>
+        </p:grpSp>
+        <p:sp>
+          <p:nvSpPr>
+            <p:cNvPr id="80" name="Arrow: Circular 79">
+              <a:extLst>
+                <a:ext uri="{FF2B5EF4-FFF2-40B4-BE49-F238E27FC236}">
+                  <a16:creationId xmlns:a16="http://schemas.microsoft.com/office/drawing/2014/main" id="{B3583467-4037-B808-0508-A0ECE0115B4D}"/>
+                </a:ext>
+              </a:extLst>
+            </p:cNvPr>
+            <p:cNvSpPr/>
+            <p:nvPr/>
+          </p:nvSpPr>
+          <p:spPr>
+            <a:xfrm rot="19800000">
+              <a:off x="478390" y="478390"/>
+              <a:ext cx="1481620" cy="1481620"/>
+            </a:xfrm>
+            <a:prstGeom prst="circularArrow">
+              <a:avLst>
+                <a:gd name="adj1" fmla="val 20965"/>
+                <a:gd name="adj2" fmla="val 1142319"/>
+                <a:gd name="adj3" fmla="val 20457683"/>
+                <a:gd name="adj4" fmla="val 10800000"/>
+                <a:gd name="adj5" fmla="val 17956"/>
+              </a:avLst>
+            </a:prstGeom>
+            <a:solidFill>
+              <a:schemeClr val="tx1"/>
+            </a:solidFill>
+            <a:ln>
+              <a:noFill/>
+            </a:ln>
+          </p:spPr>
+          <p:style>
+            <a:lnRef idx="2">
+              <a:schemeClr val="accent1">
+                <a:shade val="15000"/>
+              </a:schemeClr>
+            </a:lnRef>
+            <a:fillRef idx="1">
+              <a:schemeClr val="accent1"/>
+            </a:fillRef>
+            <a:effectRef idx="0">
+              <a:schemeClr val="accent1"/>
+            </a:effectRef>
+            <a:fontRef idx="minor">
+              <a:schemeClr val="lt1"/>
+            </a:fontRef>
+          </p:style>
+          <p:txBody>
+            <a:bodyPr rtlCol="0" anchor="ctr"/>
+            <a:lstStyle/>
+            <a:p>
+              <a:pPr algn="ctr"/>
+              <a:endParaRPr lang="ko-KR" altLang="en-US">
+                <a:solidFill>
+                  <a:schemeClr val="tx1"/>
+                </a:solidFill>
+              </a:endParaRPr>
+            </a:p>
+          </p:txBody>
+        </p:sp>
+      </p:grpSp>
+    </p:spTree>
+    <p:extLst>
+      <p:ext uri="{BB962C8B-B14F-4D97-AF65-F5344CB8AC3E}">
+        <p14:creationId xmlns:p14="http://schemas.microsoft.com/office/powerpoint/2010/main" val="2387143760"/>
+      </p:ext>
+    </p:extLst>
+  </p:cSld>
+  <p:clrMapOvr>
+    <a:masterClrMapping/>
+  </p:clrMapOvr>
+</p:sld>
+</file>
+
 <file path=ppt/theme/theme1.xml><?xml version="1.0" encoding="utf-8"?>
 <a:theme xmlns:a="http://schemas.openxmlformats.org/drawingml/2006/main" name="Office Theme">
   <a:themeElements>

</xml_diff>